<commit_message>
Update 4-slide opening deck with full bilingual English & Thai scripts, UI language toggle, and PPTX notes
</commit_message>
<xml_diff>
--- a/FTH_D365_Executive_Opening_Deck.pptx
+++ b/FTH_D365_Executive_Opening_Deck.pptx
@@ -505,7 +505,36 @@
           <a:lstStyle/>
           <a:p>
             <a:r>
-              <a:t>【บทพูดพิธีกร - สไลด์ที่ 1: ต้อนรับผู้บริหารและเกริ่นนำวิสัยทัศน์】</a:t>
+              <a:t>【English Executive Host Script - Slide 1: Welcome &amp; Visionary Opening】</a:t>
+            </a:r>
+          </a:p>
+          <a:p/>
+          <a:p>
+            <a:r>
+              <a:t>"Good morning and welcome, esteemed executives, colleagues, and distinguished guests. Welcome to this strategic executive briefing from Fujitsu Thailand (FTH) on 'Empowering Enterprise ERP with Microsoft Copilot AI'.</a:t>
+            </a:r>
+          </a:p>
+          <a:p/>
+          <a:p>
+            <a:r>
+              <a:t>Today, we are thrilled to present our vision for advancing Microsoft Dynamics 365 Finance &amp; Operations by natively infusing Microsoft Copilot Studio and Azure AI into everyday financial and Thai tax compliance workflows.</a:t>
+            </a:r>
+          </a:p>
+          <a:p/>
+          <a:p>
+            <a:r>
+              <a:t>Our purpose today is not merely introducing new AI features, but creating high-value Strategic Intellectual Property (IP) for FTH—strengthening our market position as Thailand's most trusted partner in enterprise digital transformation."</a:t>
+            </a:r>
+          </a:p>
+          <a:p/>
+          <a:p>
+            <a:r>
+              <a:t>----------------------------------------------------------------------</a:t>
+            </a:r>
+          </a:p>
+          <a:p>
+            <a:r>
+              <a:t>【บทพูดภาษาไทยสำหรับพิธีกร - สไลด์ที่ 1: ต้อนรับผู้บริหารและเกริ่นนำวิสัยทัศน์】</a:t>
             </a:r>
           </a:p>
           <a:p/>
@@ -593,7 +622,36 @@
           <a:lstStyle/>
           <a:p>
             <a:r>
-              <a:t>【บทพูดพิธีกร - สไลด์ที่ 2: ชี้ให้เห็นความท้าทายและโอกาส】</a:t>
+              <a:t>【English Executive Host Script - Slide 2: Industry Shift &amp; Local Challenges】</a:t>
+            </a:r>
+          </a:p>
+          <a:p/>
+          <a:p>
+            <a:r>
+              <a:t>"Distinguished guests, looking at day-to-day operations across Thailand, traditional ERP systems have served effectively as Systems of Record. However, the true operational bottleneck lies within Accounts Payable—where finance teams spend over 70% of their time manually reviewing hundreds of PDF tax invoices.</a:t>
+            </a:r>
+          </a:p>
+          <a:p/>
+          <a:p>
+            <a:r>
+              <a:t>From verifying 13-digit Tax IDs and 5-digit branch codes to 3-way matching and withholding tax calculations, manual workloads create severe month-end crunches. Coupled with the Revenue Department's aggressive push toward e-Tax Invoice and e-Receipt mandates, a single clerical oversight risks delayed filings and compliance penalties.</a:t>
+            </a:r>
+          </a:p>
+          <a:p/>
+          <a:p>
+            <a:r>
+              <a:t>This is precisely why Fujitsu sees an unprecedented opportunity to elevate D365 into a 'System of Intelligence'—automating repetitive burdens and equipping our finance professionals with predictive, pre-validated intelligence."</a:t>
+            </a:r>
+          </a:p>
+          <a:p/>
+          <a:p>
+            <a:r>
+              <a:t>----------------------------------------------------------------------</a:t>
+            </a:r>
+          </a:p>
+          <a:p>
+            <a:r>
+              <a:t>【บทพูดภาษาไทยสำหรับพิธีกร - สไลด์ที่ 2: ชี้ให้เห็นความท้าทายและโอกาส】</a:t>
             </a:r>
           </a:p>
           <a:p/>
@@ -681,7 +739,36 @@
           <a:lstStyle/>
           <a:p>
             <a:r>
-              <a:t>【บทพูดพิธีกร - สไลด์ที่ 3: เสริมแกร่งผลิตภัณฑ์และคุณค่าของ FTH】</a:t>
+              <a:t>【English Executive Host Script - Slide 3: Product Excellence &amp; Fujitsu Value】</a:t>
+            </a:r>
+          </a:p>
+          <a:p/>
+          <a:p>
+            <a:r>
+              <a:t>"From a strategic value and ROI perspective, this initiative drives dual impact:</a:t>
+            </a:r>
+          </a:p>
+          <a:p/>
+          <a:p>
+            <a:r>
+              <a:t>First, Product Excellence for Dynamics 365: By natively embedding Copilot Studio and Azure AI via Dataverse, enterprise data remains 100% secure within company boundaries. AI extracts, cross-checks against Thai tax laws, and prepares draft vendor invoices—reducing cycle time by over 70%, while strictly maintaining Human-in-the-Loop governance so that finance professionals retain full approval authority before any journal posting.</a:t>
+            </a:r>
+          </a:p>
+          <a:p/>
+          <a:p>
+            <a:r>
+              <a:t>Second, Unmatched Business Value for Fujitsu Thailand: FTH establishes a distinctive first-mover advantage by offering a pre-packaged, AI-infused Thai Localization solution. This high-margin, reusable IP enables our sales and consulting teams to scale rapidly across Japanese multinationals (MNCs) and top-tier Thai conglomerates—reinforcing Fujitsu’s global reputation for quality, governance, and trust."</a:t>
+            </a:r>
+          </a:p>
+          <a:p/>
+          <a:p>
+            <a:r>
+              <a:t>----------------------------------------------------------------------</a:t>
+            </a:r>
+          </a:p>
+          <a:p>
+            <a:r>
+              <a:t>【บทพูดภาษาไทยสำหรับพิธีกร - สไลด์ที่ 3: เสริมแกร่งผลิตภัณฑ์และคุณค่าของ FTH】</a:t>
             </a:r>
           </a:p>
           <a:p/>
@@ -769,7 +856,36 @@
           <a:lstStyle/>
           <a:p>
             <a:r>
-              <a:t>【บทพูดพิธีกร - สไลด์ที่ 4: สรุปหัวข้อและส่งต่อเข้าสู่ Live Interactive Deck】</a:t>
+              <a:t>【English Executive Host Script - Slide 4: Agenda &amp; Live Demonstration Handover】</a:t>
+            </a:r>
+          </a:p>
+          <a:p/>
+          <a:p>
+            <a:r>
+              <a:t>"Looking ahead to today’s session, we have prepared a comprehensive 12-slide Live Interactive Solution Pitch that demonstrates the actual production-ready capabilities:</a:t>
+            </a:r>
+          </a:p>
+          <a:p/>
+          <a:p>
+            <a:r>
+              <a:t>We will walk through the official Microsoft Copilot Studio multi-agent architecture, explore our top five Thai localization use cases—from AP Invoice Intelligence to Continuous Reconciliation—and outline our practical 8-week POC delivery roadmap.</a:t>
+            </a:r>
+          </a:p>
+          <a:p/>
+          <a:p>
+            <a:r>
+              <a:t>Without further ado, I would now like to invite our executive team to transition directly into the live interactive platform to experience the future of Dynamics 365 and Copilot AI firsthand. Let us begin."</a:t>
+            </a:r>
+          </a:p>
+          <a:p/>
+          <a:p>
+            <a:r>
+              <a:t>----------------------------------------------------------------------</a:t>
+            </a:r>
+          </a:p>
+          <a:p>
+            <a:r>
+              <a:t>【บทพูดภาษาไทยสำหรับพิธีกร - สไลด์ที่ 4: สรุปหัวข้อและส่งต่อเข้าสู่ Live Interactive Deck】</a:t>
             </a:r>
           </a:p>
           <a:p/>

</xml_diff>

<commit_message>
Switch 4-slide opening deck to pristine executive English White Theme with harmonized contrast
</commit_message>
<xml_diff>
--- a/FTH_D365_Executive_Opening_Deck.pptx
+++ b/FTH_D365_Executive_Opening_Deck.pptx
@@ -3924,7 +3924,7 @@
             <a:avLst/>
           </a:prstGeom>
           <a:solidFill>
-            <a:srgbClr val="0B1120"/>
+            <a:srgbClr val="F8FAFC"/>
           </a:solidFill>
           <a:ln>
             <a:noFill/>
@@ -3961,13 +3961,13 @@
         <p:spPr>
           <a:xfrm>
             <a:off x="0" y="0"/>
-            <a:ext cx="12191695" cy="54864"/>
+            <a:ext cx="12191695" cy="73152"/>
           </a:xfrm>
           <a:prstGeom prst="rect">
             <a:avLst/>
           </a:prstGeom>
           <a:solidFill>
-            <a:srgbClr val="E60012"/>
+            <a:srgbClr val="DC2626"/>
           </a:solidFill>
           <a:ln>
             <a:noFill/>
@@ -4047,13 +4047,13 @@
               </a:spcAft>
               <a:defRPr sz="1000" b="1">
                 <a:solidFill>
-                  <a:srgbClr val="38BDF8"/>
+                  <a:srgbClr val="DC2626"/>
                 </a:solidFill>
                 <a:latin typeface="Segoe UI"/>
               </a:defRPr>
             </a:pPr>
             <a:r>
-              <a:t>FUJITSU THAILAND (FTH) • EXECUTIVE OPENING KEYNOTE</a:t>
+              <a:t>FUJITSU THAILAND (FTH) • STRATEGIC KEYNOTE</a:t>
             </a:r>
           </a:p>
           <a:p>
@@ -4063,7 +4063,7 @@
               </a:spcAft>
               <a:defRPr sz="2200" b="1">
                 <a:solidFill>
-                  <a:srgbClr val="FFFFFF"/>
+                  <a:srgbClr val="0F172A"/>
                 </a:solidFill>
                 <a:latin typeface="Segoe UI"/>
               </a:defRPr>
@@ -4076,13 +4076,13 @@
             <a:pPr>
               <a:defRPr sz="1200">
                 <a:solidFill>
-                  <a:srgbClr val="94A3B8"/>
+                  <a:srgbClr val="64748B"/>
                 </a:solidFill>
                 <a:latin typeface="Segoe UI"/>
               </a:defRPr>
             </a:pPr>
             <a:r>
-              <a:t>ยกระดับศักยภาพ Dynamics 365 Finance &amp; Operations สู่ยุค Autonomous AI &amp; ขับเคลื่อนคุณค่าเชิงกลยุทธ์ให้ ฟูจิตสึ ประเทศไทย</a:t>
+              <a:t>Advancing Dynamics 365 Finance &amp; Operations into Autonomous AI &amp; Unlocking Strategic Value for Fujitsu Thailand</a:t>
             </a:r>
           </a:p>
         </p:txBody>
@@ -4110,7 +4110,7 @@
           <a:lstStyle/>
           <a:p>
             <a:pPr>
-              <a:defRPr sz="900">
+              <a:defRPr sz="900" b="1">
                 <a:solidFill>
                   <a:srgbClr val="64748B"/>
                 </a:solidFill>
@@ -4118,7 +4118,7 @@
               </a:defRPr>
             </a:pPr>
             <a:r>
-              <a:t>FUJITSU THAILAND (FTH) • DYNAMICS 365 &amp; COPILOT AI EXECUTIVE BRIEFING • SLIDE 1 OF 4</a:t>
+              <a:t>FUJITSU THAILAND (FTH) • DYNAMICS 365 &amp; COPILOT AI EXECUTIVE KEYNOTE • SLIDE 1 OF 4</a:t>
             </a:r>
           </a:p>
         </p:txBody>
@@ -4132,17 +4132,17 @@
         <p:spPr>
           <a:xfrm>
             <a:off x="731520" y="1691640"/>
-            <a:ext cx="10728655" cy="4434840"/>
+            <a:ext cx="3328416" cy="4434840"/>
           </a:xfrm>
           <a:prstGeom prst="roundRect">
             <a:avLst/>
           </a:prstGeom>
           <a:solidFill>
-            <a:srgbClr val="141D2F"/>
+            <a:srgbClr val="FFFFFF"/>
           </a:solidFill>
           <a:ln w="19050">
             <a:solidFill>
-              <a:srgbClr val="263455"/>
+              <a:srgbClr val="0284C7"/>
             </a:solidFill>
           </a:ln>
         </p:spPr>
@@ -4161,83 +4161,363 @@
           </a:fontRef>
         </p:style>
         <p:txBody>
-          <a:bodyPr rtlCol="0" anchor="ctr" wrap="square" lIns="548640" rIns="548640" tIns="365760"/>
+          <a:bodyPr rtlCol="0" anchor="ctr" wrap="square" lIns="274320" rIns="274320" tIns="274320"/>
           <a:lstStyle/>
           <a:p>
             <a:pPr algn="ctr">
               <a:spcAft>
                 <a:spcPts val="1200"/>
               </a:spcAft>
-              <a:defRPr sz="1600" b="1">
-                <a:solidFill>
-                  <a:srgbClr val="38BDF8"/>
+              <a:defRPr sz="1400" b="1">
+                <a:solidFill>
+                  <a:srgbClr val="0284C7"/>
                 </a:solidFill>
                 <a:latin typeface="Segoe UI"/>
               </a:defRPr>
             </a:pPr>
             <a:r>
-              <a:t>🎯 จุดมุ่งหมายเชิงกลยุทธ์ของการบรรยายในวันนี้ (Executive Purpose)</a:t>
+              <a:t>⚡ 1. Autonomous ERP</a:t>
             </a:r>
           </a:p>
           <a:p>
             <a:pPr>
               <a:spcAft>
-                <a:spcPts val="1000"/>
+                <a:spcPts val="800"/>
               </a:spcAft>
-              <a:defRPr sz="1300">
-                <a:solidFill>
-                  <a:srgbClr val="E2E8F0"/>
+              <a:defRPr sz="1050" b="1">
+                <a:solidFill>
+                  <a:srgbClr val="0F172A"/>
                 </a:solidFill>
                 <a:latin typeface="Segoe UI"/>
               </a:defRPr>
             </a:pPr>
             <a:r>
-              <a:t>1. การปฏิวัติระบบ ERP สู่ Autonomous AI: นำเสนอแนวทางการผสาน Dynamics 365 F&amp;O เข้ากับ Microsoft Copilot Studio เพื่อเปลี่ยนจากการทำงานแบบ Manual ซ้ำซ้อน สู่การประมวลผลอัจฉริยะแบบอัตโนมัติ</a:t>
+              <a:t>• Speed &amp; Precision: </a:t>
+            </a:r>
+            <a:r>
+              <a:rPr sz="1000" b="0">
+                <a:solidFill>
+                  <a:srgbClr val="334155"/>
+                </a:solidFill>
+                <a:latin typeface="Segoe UI"/>
+              </a:rPr>
+              <a:t>Transforming manual accounting workflows into an intelligent system that reads, verifies, and pre-drafts invoices.</a:t>
             </a:r>
           </a:p>
           <a:p>
             <a:pPr>
               <a:spcAft>
-                <a:spcPts val="1000"/>
+                <a:spcPts val="800"/>
               </a:spcAft>
-              <a:defRPr sz="1300">
-                <a:solidFill>
-                  <a:srgbClr val="E2E8F0"/>
+              <a:defRPr sz="1050" b="1">
+                <a:solidFill>
+                  <a:srgbClr val="0F172A"/>
                 </a:solidFill>
                 <a:latin typeface="Segoe UI"/>
               </a:defRPr>
             </a:pPr>
             <a:r>
-              <a:t>2. เจาะลึก Thai Localization &amp; Tax Compliance: แก้โจทย์ความซับซ้อนของภาษีไทย ทั้ง VAT 7%, ภาษีหัก ณ ที่จ่าย ภ.พ.30, ภ.ง.ด.3/53, และ e-Tax Invoice ให้ถูกต้อง แม่นยำ รวดเร็ว และตรวจสอบย้อนกลับได้ 100%</a:t>
+              <a:t>• Seamless Dynamics 365: </a:t>
+            </a:r>
+            <a:r>
+              <a:rPr sz="1000" b="0">
+                <a:solidFill>
+                  <a:srgbClr val="334155"/>
+                </a:solidFill>
+                <a:latin typeface="Segoe UI"/>
+              </a:rPr>
+              <a:t>Direct native fusion between Copilot Studio, Azure AI, and D365 F&amp;O via Dataverse.</a:t>
             </a:r>
           </a:p>
           <a:p>
             <a:pPr>
               <a:spcAft>
-                <a:spcPts val="1600"/>
+                <a:spcPts val="800"/>
               </a:spcAft>
-              <a:defRPr sz="1300">
-                <a:solidFill>
-                  <a:srgbClr val="E2E8F0"/>
+              <a:defRPr sz="1050" b="1">
+                <a:solidFill>
+                  <a:srgbClr val="0F172A"/>
                 </a:solidFill>
                 <a:latin typeface="Segoe UI"/>
               </a:defRPr>
             </a:pPr>
             <a:r>
-              <a:t>3. เสริมความแข็งแกร่งของผลิตภัณฑ์ &amp; มูลค่าของ FTH: ตอกย้ำความเป็นผู้นำของ ฟูจิตสึ ประเทศไทย ในฐานะ Trusted Partner ที่ครอบครอง High-Value Intellectual Property (IP) ด้าน AI ERP ในระดับภูมิภาค</a:t>
+              <a:t>• Labor Savings: </a:t>
+            </a:r>
+            <a:r>
+              <a:rPr sz="1000" b="0">
+                <a:solidFill>
+                  <a:srgbClr val="334155"/>
+                </a:solidFill>
+                <a:latin typeface="Segoe UI"/>
+              </a:rPr>
+              <a:t>Slashes repetitive Accounts Payable cycle time by over 70%, freeing teams for strategic finance.</a:t>
+            </a:r>
+          </a:p>
+        </p:txBody>
+      </p:sp>
+      <p:sp>
+        <p:nvSpPr>
+          <p:cNvPr id="8" name="Rounded Rectangle 7"/>
+          <p:cNvSpPr/>
+          <p:nvPr/>
+        </p:nvSpPr>
+        <p:spPr>
+          <a:xfrm>
+            <a:off x="4425696" y="1691640"/>
+            <a:ext cx="3328416" cy="4434840"/>
+          </a:xfrm>
+          <a:prstGeom prst="roundRect">
+            <a:avLst/>
+          </a:prstGeom>
+          <a:solidFill>
+            <a:srgbClr val="FFFFFF"/>
+          </a:solidFill>
+          <a:ln w="19050">
+            <a:solidFill>
+              <a:srgbClr val="7C3AED"/>
+            </a:solidFill>
+          </a:ln>
+        </p:spPr>
+        <p:style>
+          <a:lnRef idx="1">
+            <a:schemeClr val="accent1"/>
+          </a:lnRef>
+          <a:fillRef idx="3">
+            <a:schemeClr val="accent1"/>
+          </a:fillRef>
+          <a:effectRef idx="2">
+            <a:schemeClr val="accent1"/>
+          </a:effectRef>
+          <a:fontRef idx="minor">
+            <a:schemeClr val="lt1"/>
+          </a:fontRef>
+        </p:style>
+        <p:txBody>
+          <a:bodyPr rtlCol="0" anchor="ctr" wrap="square" lIns="274320" rIns="274320" tIns="274320"/>
+          <a:lstStyle/>
+          <a:p>
+            <a:pPr algn="ctr">
+              <a:spcAft>
+                <a:spcPts val="1200"/>
+              </a:spcAft>
+              <a:defRPr sz="1400" b="1">
+                <a:solidFill>
+                  <a:srgbClr val="7C3AED"/>
+                </a:solidFill>
+                <a:latin typeface="Segoe UI"/>
+              </a:defRPr>
+            </a:pPr>
+            <a:r>
+              <a:t>🏛️ 2. Thai Tax Compliance</a:t>
             </a:r>
           </a:p>
           <a:p>
             <a:pPr>
-              <a:defRPr sz="1100" b="1">
-                <a:solidFill>
-                  <a:srgbClr val="A855F7"/>
+              <a:spcAft>
+                <a:spcPts val="800"/>
+              </a:spcAft>
+              <a:defRPr sz="1050" b="1">
+                <a:solidFill>
+                  <a:srgbClr val="0F172A"/>
                 </a:solidFill>
                 <a:latin typeface="Segoe UI"/>
               </a:defRPr>
             </a:pPr>
             <a:r>
-              <a:t>🎤 ผู้นำเสนอ: Solution Principal &amp; Executive Host, Fujitsu Thailand (FTH) | ⏱️ ระยะเวลาเกริ่นนำ: ~2 นาที</a:t>
+              <a:t>• 100% Tax Alignment: </a:t>
+            </a:r>
+            <a:r>
+              <a:rPr sz="1000" b="0">
+                <a:solidFill>
+                  <a:srgbClr val="334155"/>
+                </a:solidFill>
+                <a:latin typeface="Segoe UI"/>
+              </a:rPr>
+              <a:t>Built for Revenue Department standards: PP.30 VAT 7%, PND 3/53, and 50 Tawi certificates.</a:t>
+            </a:r>
+          </a:p>
+          <a:p>
+            <a:pPr>
+              <a:spcAft>
+                <a:spcPts val="800"/>
+              </a:spcAft>
+              <a:defRPr sz="1050" b="1">
+                <a:solidFill>
+                  <a:srgbClr val="0F172A"/>
+                </a:solidFill>
+                <a:latin typeface="Segoe UI"/>
+              </a:defRPr>
+            </a:pPr>
+            <a:r>
+              <a:t>• e-Tax Pre-Validation: </a:t>
+            </a:r>
+            <a:r>
+              <a:rPr sz="1000" b="0">
+                <a:solidFill>
+                  <a:srgbClr val="334155"/>
+                </a:solidFill>
+                <a:latin typeface="Segoe UI"/>
+              </a:rPr>
+              <a:t>Automatic gate checking 13-digit Tax IDs and 5-digit branch codes before XML generation.</a:t>
+            </a:r>
+          </a:p>
+          <a:p>
+            <a:pPr>
+              <a:spcAft>
+                <a:spcPts val="800"/>
+              </a:spcAft>
+              <a:defRPr sz="1050" b="1">
+                <a:solidFill>
+                  <a:srgbClr val="0F172A"/>
+                </a:solidFill>
+                <a:latin typeface="Segoe UI"/>
+              </a:defRPr>
+            </a:pPr>
+            <a:r>
+              <a:t>• Continuous Subledger Audit: </a:t>
+            </a:r>
+            <a:r>
+              <a:rPr sz="1000" b="0">
+                <a:solidFill>
+                  <a:srgbClr val="334155"/>
+                </a:solidFill>
+                <a:latin typeface="Segoe UI"/>
+              </a:rPr>
+              <a:t>Monitors GL against AP/AR/Tax continuously, preventing month-end tax filing panic.</a:t>
+            </a:r>
+          </a:p>
+        </p:txBody>
+      </p:sp>
+      <p:sp>
+        <p:nvSpPr>
+          <p:cNvPr id="9" name="Rounded Rectangle 8"/>
+          <p:cNvSpPr/>
+          <p:nvPr/>
+        </p:nvSpPr>
+        <p:spPr>
+          <a:xfrm>
+            <a:off x="8119872" y="1691640"/>
+            <a:ext cx="3328416" cy="4434840"/>
+          </a:xfrm>
+          <a:prstGeom prst="roundRect">
+            <a:avLst/>
+          </a:prstGeom>
+          <a:solidFill>
+            <a:srgbClr val="FFFFFF"/>
+          </a:solidFill>
+          <a:ln w="19050">
+            <a:solidFill>
+              <a:srgbClr val="DC2626"/>
+            </a:solidFill>
+          </a:ln>
+        </p:spPr>
+        <p:style>
+          <a:lnRef idx="1">
+            <a:schemeClr val="accent1"/>
+          </a:lnRef>
+          <a:fillRef idx="3">
+            <a:schemeClr val="accent1"/>
+          </a:fillRef>
+          <a:effectRef idx="2">
+            <a:schemeClr val="accent1"/>
+          </a:effectRef>
+          <a:fontRef idx="minor">
+            <a:schemeClr val="lt1"/>
+          </a:fontRef>
+        </p:style>
+        <p:txBody>
+          <a:bodyPr rtlCol="0" anchor="ctr" wrap="square" lIns="274320" rIns="274320" tIns="274320"/>
+          <a:lstStyle/>
+          <a:p>
+            <a:pPr algn="ctr">
+              <a:spcAft>
+                <a:spcPts val="1200"/>
+              </a:spcAft>
+              <a:defRPr sz="1400" b="1">
+                <a:solidFill>
+                  <a:srgbClr val="DC2626"/>
+                </a:solidFill>
+                <a:latin typeface="Segoe UI"/>
+              </a:defRPr>
+            </a:pPr>
+            <a:r>
+              <a:t>🏆 3. Value for Fujitsu (FTH)</a:t>
+            </a:r>
+          </a:p>
+          <a:p>
+            <a:pPr>
+              <a:spcAft>
+                <a:spcPts val="800"/>
+              </a:spcAft>
+              <a:defRPr sz="1050" b="1">
+                <a:solidFill>
+                  <a:srgbClr val="0F172A"/>
+                </a:solidFill>
+                <a:latin typeface="Segoe UI"/>
+              </a:defRPr>
+            </a:pPr>
+            <a:r>
+              <a:t>• Proprietary IP Leadership: </a:t>
+            </a:r>
+            <a:r>
+              <a:rPr sz="1000" b="0">
+                <a:solidFill>
+                  <a:srgbClr val="334155"/>
+                </a:solidFill>
+                <a:latin typeface="Segoe UI"/>
+              </a:rPr>
+              <a:t>FTH owns a distinctive, repeatable AI-infused Thai Localization package in Thailand.</a:t>
+            </a:r>
+          </a:p>
+          <a:p>
+            <a:pPr>
+              <a:spcAft>
+                <a:spcPts val="800"/>
+              </a:spcAft>
+              <a:defRPr sz="1050" b="1">
+                <a:solidFill>
+                  <a:srgbClr val="0F172A"/>
+                </a:solidFill>
+                <a:latin typeface="Segoe UI"/>
+              </a:defRPr>
+            </a:pPr>
+            <a:r>
+              <a:t>• High-Margin Reusability: </a:t>
+            </a:r>
+            <a:r>
+              <a:rPr sz="1000" b="0">
+                <a:solidFill>
+                  <a:srgbClr val="334155"/>
+                </a:solidFill>
+                <a:latin typeface="Segoe UI"/>
+              </a:rPr>
+              <a:t>Packaged solution scales across Japanese MNCs and major Thai corporate clients.</a:t>
+            </a:r>
+          </a:p>
+          <a:p>
+            <a:pPr>
+              <a:spcAft>
+                <a:spcPts val="800"/>
+              </a:spcAft>
+              <a:defRPr sz="1050" b="1">
+                <a:solidFill>
+                  <a:srgbClr val="0F172A"/>
+                </a:solidFill>
+                <a:latin typeface="Segoe UI"/>
+              </a:defRPr>
+            </a:pPr>
+            <a:r>
+              <a:t>• Trusted Global Partner: </a:t>
+            </a:r>
+            <a:r>
+              <a:rPr sz="1000" b="0">
+                <a:solidFill>
+                  <a:srgbClr val="334155"/>
+                </a:solidFill>
+                <a:latin typeface="Segoe UI"/>
+              </a:rPr>
+              <a:t>Combines Fujitsu’s Japanese quality and governance with Microsoft’s premier enterprise AI.</a:t>
             </a:r>
           </a:p>
         </p:txBody>
@@ -4275,7 +4555,7 @@
             <a:avLst/>
           </a:prstGeom>
           <a:solidFill>
-            <a:srgbClr val="0B1120"/>
+            <a:srgbClr val="F8FAFC"/>
           </a:solidFill>
           <a:ln>
             <a:noFill/>
@@ -4312,13 +4592,13 @@
         <p:spPr>
           <a:xfrm>
             <a:off x="0" y="0"/>
-            <a:ext cx="12191695" cy="54864"/>
+            <a:ext cx="12191695" cy="73152"/>
           </a:xfrm>
           <a:prstGeom prst="rect">
             <a:avLst/>
           </a:prstGeom>
           <a:solidFill>
-            <a:srgbClr val="E60012"/>
+            <a:srgbClr val="DC2626"/>
           </a:solidFill>
           <a:ln>
             <a:noFill/>
@@ -4398,7 +4678,7 @@
               </a:spcAft>
               <a:defRPr sz="1000" b="1">
                 <a:solidFill>
-                  <a:srgbClr val="38BDF8"/>
+                  <a:srgbClr val="DC2626"/>
                 </a:solidFill>
                 <a:latin typeface="Segoe UI"/>
               </a:defRPr>
@@ -4414,7 +4694,7 @@
               </a:spcAft>
               <a:defRPr sz="2200" b="1">
                 <a:solidFill>
-                  <a:srgbClr val="FFFFFF"/>
+                  <a:srgbClr val="0F172A"/>
                 </a:solidFill>
                 <a:latin typeface="Segoe UI"/>
               </a:defRPr>
@@ -4427,13 +4707,13 @@
             <a:pPr>
               <a:defRPr sz="1200">
                 <a:solidFill>
-                  <a:srgbClr val="94A3B8"/>
+                  <a:srgbClr val="64748B"/>
                 </a:solidFill>
                 <a:latin typeface="Segoe UI"/>
               </a:defRPr>
             </a:pPr>
             <a:r>
-              <a:t>ทำไมระบบ ERP ในปัจจุบันจึงต้องก้าวข้ามขีดจำกัดเดิม สู่การเป็นระบบอัจฉริยะที่ช่วยวิเคราะห์และตัดสินใจ</a:t>
+              <a:t>Navigating Thai financial and tax complexities, and unlocking Fujitsu’s breakthrough opportunity.</a:t>
             </a:r>
           </a:p>
         </p:txBody>
@@ -4461,7 +4741,7 @@
           <a:lstStyle/>
           <a:p>
             <a:pPr>
-              <a:defRPr sz="900">
+              <a:defRPr sz="900" b="1">
                 <a:solidFill>
                   <a:srgbClr val="64748B"/>
                 </a:solidFill>
@@ -4469,7 +4749,7 @@
               </a:defRPr>
             </a:pPr>
             <a:r>
-              <a:t>FUJITSU THAILAND (FTH) • DYNAMICS 365 &amp; COPILOT AI EXECUTIVE BRIEFING • SLIDE 2 OF 4</a:t>
+              <a:t>FUJITSU THAILAND (FTH) • DYNAMICS 365 &amp; COPILOT AI EXECUTIVE KEYNOTE • SLIDE 2 OF 4</a:t>
             </a:r>
           </a:p>
         </p:txBody>
@@ -4489,11 +4769,11 @@
             <a:avLst/>
           </a:prstGeom>
           <a:solidFill>
-            <a:srgbClr val="141D2F"/>
+            <a:srgbClr val="FFFFFF"/>
           </a:solidFill>
           <a:ln w="19050">
             <a:solidFill>
-              <a:srgbClr val="EF4444"/>
+              <a:srgbClr val="DC2626"/>
             </a:solidFill>
           </a:ln>
         </p:spPr>
@@ -4517,17 +4797,17 @@
           <a:p>
             <a:pPr algn="ctr">
               <a:spcAft>
-                <a:spcPts val="800"/>
+                <a:spcPts val="1200"/>
               </a:spcAft>
               <a:defRPr sz="1400" b="1">
                 <a:solidFill>
-                  <a:srgbClr val="F87171"/>
+                  <a:srgbClr val="DC2626"/>
                 </a:solidFill>
                 <a:latin typeface="Segoe UI"/>
               </a:defRPr>
             </a:pPr>
             <a:r>
-              <a:t>⚠️ ความท้าทายของ ERP ดั้งเดิม</a:t>
+              <a:t>⚠️ Traditional ERP Limits</a:t>
             </a:r>
           </a:p>
           <a:p>
@@ -4535,15 +4815,24 @@
               <a:spcAft>
                 <a:spcPts val="800"/>
               </a:spcAft>
-              <a:defRPr sz="1100">
-                <a:solidFill>
-                  <a:srgbClr val="E2E8F0"/>
+              <a:defRPr sz="1050" b="1">
+                <a:solidFill>
+                  <a:srgbClr val="0F172A"/>
                 </a:solidFill>
                 <a:latin typeface="Segoe UI"/>
               </a:defRPr>
             </a:pPr>
             <a:r>
-              <a:t>• งาน Manual สูง: พนักงานต้องใช้เวลากว่า 70% ตรวจสอบเอกสารใบแจ้งหนี้ PDF และใบเสร็จรับเงินด้วยตาเปล่า</a:t>
+              <a:t>• Manual Overload: </a:t>
+            </a:r>
+            <a:r>
+              <a:rPr sz="1000" b="0">
+                <a:solidFill>
+                  <a:srgbClr val="334155"/>
+                </a:solidFill>
+                <a:latin typeface="Segoe UI"/>
+              </a:rPr>
+              <a:t>AP teams spend &gt;70% of time verifying PDF invoices, receipts, and line items manually.</a:t>
             </a:r>
           </a:p>
           <a:p>
@@ -4551,15 +4840,24 @@
               <a:spcAft>
                 <a:spcPts val="800"/>
               </a:spcAft>
-              <a:defRPr sz="1100">
-                <a:solidFill>
-                  <a:srgbClr val="E2E8F0"/>
+              <a:defRPr sz="1050" b="1">
+                <a:solidFill>
+                  <a:srgbClr val="0F172A"/>
                 </a:solidFill>
                 <a:latin typeface="Segoe UI"/>
               </a:defRPr>
             </a:pPr>
             <a:r>
-              <a:t>• ความเสี่ยงเรื่อง Human Error: การคีย์เลขประจำตัวผู้เสียภาษี 13 หลัก หรือรหัสสาขา 5 หลัก ผิดพลาด นำไปสู่ปัญหาภาษี</a:t>
+              <a:t>• Human Error Risks: </a:t>
+            </a:r>
+            <a:r>
+              <a:rPr sz="1000" b="0">
+                <a:solidFill>
+                  <a:srgbClr val="334155"/>
+                </a:solidFill>
+                <a:latin typeface="Segoe UI"/>
+              </a:rPr>
+              <a:t>Typos in 13-digit Tax IDs or 5-digit branch codes trigger tax discrepancies.</a:t>
             </a:r>
           </a:p>
           <a:p>
@@ -4567,15 +4865,24 @@
               <a:spcAft>
                 <a:spcPts val="800"/>
               </a:spcAft>
-              <a:defRPr sz="1100">
-                <a:solidFill>
-                  <a:srgbClr val="E2E8F0"/>
+              <a:defRPr sz="1050" b="1">
+                <a:solidFill>
+                  <a:srgbClr val="0F172A"/>
                 </a:solidFill>
                 <a:latin typeface="Segoe UI"/>
               </a:defRPr>
             </a:pPr>
             <a:r>
-              <a:t>• ปิดงวดบัญชีล่าช้า: คอขวดในช่วงสิ้นเดือน ส่งผลกระทบต่อการยื่นแบบ ภ.พ.30 และการบริหารสภาพคล่องขององค์กร</a:t>
+              <a:t>• Closing Delays: </a:t>
+            </a:r>
+            <a:r>
+              <a:rPr sz="1000" b="0">
+                <a:solidFill>
+                  <a:srgbClr val="334155"/>
+                </a:solidFill>
+                <a:latin typeface="Segoe UI"/>
+              </a:rPr>
+              <a:t>Month-end crunch delays PP.30 submissions and obscures real-time cash visibility.</a:t>
             </a:r>
           </a:p>
         </p:txBody>
@@ -4595,11 +4902,11 @@
             <a:avLst/>
           </a:prstGeom>
           <a:solidFill>
-            <a:srgbClr val="141D2F"/>
+            <a:srgbClr val="FFFFFF"/>
           </a:solidFill>
           <a:ln w="19050">
             <a:solidFill>
-              <a:srgbClr val="A855F7"/>
+              <a:srgbClr val="7C3AED"/>
             </a:solidFill>
           </a:ln>
         </p:spPr>
@@ -4623,17 +4930,17 @@
           <a:p>
             <a:pPr algn="ctr">
               <a:spcAft>
-                <a:spcPts val="800"/>
+                <a:spcPts val="1200"/>
               </a:spcAft>
               <a:defRPr sz="1400" b="1">
                 <a:solidFill>
-                  <a:srgbClr val="A855F7"/>
+                  <a:srgbClr val="7C3AED"/>
                 </a:solidFill>
                 <a:latin typeface="Segoe UI"/>
               </a:defRPr>
             </a:pPr>
             <a:r>
-              <a:t>🏛️ กฎระเบียบภาษีไทยที่เข้มงวด</a:t>
+              <a:t>🏛️ Strict Thai Mandates</a:t>
             </a:r>
           </a:p>
           <a:p>
@@ -4641,15 +4948,24 @@
               <a:spcAft>
                 <a:spcPts val="800"/>
               </a:spcAft>
-              <a:defRPr sz="1100">
-                <a:solidFill>
-                  <a:srgbClr val="E2E8F0"/>
+              <a:defRPr sz="1050" b="1">
+                <a:solidFill>
+                  <a:srgbClr val="0F172A"/>
                 </a:solidFill>
                 <a:latin typeface="Segoe UI"/>
               </a:defRPr>
             </a:pPr>
             <a:r>
-              <a:t>• นโยบาย e-Tax Mandate: กรมสรรพากรผลักดันระบบ e-Tax Invoice &amp; e-Receipt จำเป็นต้องมีระบบตรวจสอบความสมบูรณ์ก่อนส่ง</a:t>
+              <a:t>• e-Tax Enforcement: </a:t>
+            </a:r>
+            <a:r>
+              <a:rPr sz="1000" b="0">
+                <a:solidFill>
+                  <a:srgbClr val="334155"/>
+                </a:solidFill>
+                <a:latin typeface="Segoe UI"/>
+              </a:rPr>
+              <a:t>Revenue Dept requires strict XML schemas and 100% pre-validation before submission.</a:t>
             </a:r>
           </a:p>
           <a:p>
@@ -4657,15 +4973,24 @@
               <a:spcAft>
                 <a:spcPts val="800"/>
               </a:spcAft>
-              <a:defRPr sz="1100">
-                <a:solidFill>
-                  <a:srgbClr val="E2E8F0"/>
+              <a:defRPr sz="1050" b="1">
+                <a:solidFill>
+                  <a:srgbClr val="0F172A"/>
                 </a:solidFill>
                 <a:latin typeface="Segoe UI"/>
               </a:defRPr>
             </a:pPr>
             <a:r>
-              <a:t>• ภาษีหัก ณ ที่จ่าย (WHT): มีอัตราภาษีหลากหลายและเงื่อนไขซับซ้อนตามประเภทบริการ</a:t>
+              <a:t>• Complex WHT Rules: </a:t>
+            </a:r>
+            <a:r>
+              <a:rPr sz="1000" b="0">
+                <a:solidFill>
+                  <a:srgbClr val="334155"/>
+                </a:solidFill>
+                <a:latin typeface="Segoe UI"/>
+              </a:rPr>
+              <a:t>Variable 1%, 2%, 3%, 5% rates require exact categorization based on service nature.</a:t>
             </a:r>
           </a:p>
           <a:p>
@@ -4673,15 +4998,24 @@
               <a:spcAft>
                 <a:spcPts val="800"/>
               </a:spcAft>
-              <a:defRPr sz="1100">
-                <a:solidFill>
-                  <a:srgbClr val="E2E8F0"/>
+              <a:defRPr sz="1050" b="1">
+                <a:solidFill>
+                  <a:srgbClr val="0F172A"/>
                 </a:solidFill>
                 <a:latin typeface="Segoe UI"/>
               </a:defRPr>
             </a:pPr>
             <a:r>
-              <a:t>• โทษปรับและภาระดอกเบี้ย: ความผิดพลาดเพียงจุดเดียวส่งผลกระทบต่อการยื่นภาษีและสร้างภาระค่าใช้จ่ายที่ไม่จำเป็นแก่ธุรกิจ</a:t>
+              <a:t>• Penalty Exposure: </a:t>
+            </a:r>
+            <a:r>
+              <a:rPr sz="1000" b="0">
+                <a:solidFill>
+                  <a:srgbClr val="334155"/>
+                </a:solidFill>
+                <a:latin typeface="Segoe UI"/>
+              </a:rPr>
+              <a:t>Late or erroneous filings result in unnecessary surcharges and audit friction.</a:t>
             </a:r>
           </a:p>
         </p:txBody>
@@ -4701,11 +5035,11 @@
             <a:avLst/>
           </a:prstGeom>
           <a:solidFill>
-            <a:srgbClr val="141D2F"/>
+            <a:srgbClr val="FFFFFF"/>
           </a:solidFill>
           <a:ln w="19050">
             <a:solidFill>
-              <a:srgbClr val="38BDF8"/>
+              <a:srgbClr val="0284C7"/>
             </a:solidFill>
           </a:ln>
         </p:spPr>
@@ -4729,17 +5063,17 @@
           <a:p>
             <a:pPr algn="ctr">
               <a:spcAft>
-                <a:spcPts val="800"/>
+                <a:spcPts val="1200"/>
               </a:spcAft>
               <a:defRPr sz="1400" b="1">
                 <a:solidFill>
-                  <a:srgbClr val="38BDF8"/>
+                  <a:srgbClr val="0284C7"/>
                 </a:solidFill>
                 <a:latin typeface="Segoe UI"/>
               </a:defRPr>
             </a:pPr>
             <a:r>
-              <a:t>🚀 โอกาสของ Fujitsu (FTH)</a:t>
+              <a:t>🚀 Fujitsu's Opportunity</a:t>
             </a:r>
           </a:p>
           <a:p>
@@ -4747,15 +5081,24 @@
               <a:spcAft>
                 <a:spcPts val="800"/>
               </a:spcAft>
-              <a:defRPr sz="1100">
-                <a:solidFill>
-                  <a:srgbClr val="E2E8F0"/>
+              <a:defRPr sz="1050" b="1">
+                <a:solidFill>
+                  <a:srgbClr val="0F172A"/>
                 </a:solidFill>
                 <a:latin typeface="Segoe UI"/>
               </a:defRPr>
             </a:pPr>
             <a:r>
-              <a:t>• System of Intelligence: เปลี่ยน D365 F&amp;O ให้กลายเป็นศูนย์บัญชาการการเงินที่คิด วิเคราะห์ และตรวจทานข้อมูลล่วงหน้า</a:t>
+              <a:t>• System of Intelligence: </a:t>
+            </a:r>
+            <a:r>
+              <a:rPr sz="1000" b="0">
+                <a:solidFill>
+                  <a:srgbClr val="334155"/>
+                </a:solidFill>
+                <a:latin typeface="Segoe UI"/>
+              </a:rPr>
+              <a:t>Elevating D365 to analyze, pre-validate, and predict issues before transactions post.</a:t>
             </a:r>
           </a:p>
           <a:p>
@@ -4763,15 +5106,24 @@
               <a:spcAft>
                 <a:spcPts val="800"/>
               </a:spcAft>
-              <a:defRPr sz="1100">
-                <a:solidFill>
-                  <a:srgbClr val="E2E8F0"/>
+              <a:defRPr sz="1050" b="1">
+                <a:solidFill>
+                  <a:srgbClr val="0F172A"/>
                 </a:solidFill>
                 <a:latin typeface="Segoe UI"/>
               </a:defRPr>
             </a:pPr>
             <a:r>
-              <a:t>• Human-in-the-Loop: AI ช่วยอ่านและร่างเอกสาร แต่ให้อำนาจการตัดสินใจและอนุมัติขั้นสุดท้ายแก่บุคลากรผู้เชี่ยวชาญ</a:t>
+              <a:t>• Human-in-the-Loop: </a:t>
+            </a:r>
+            <a:r>
+              <a:rPr sz="1000" b="0">
+                <a:solidFill>
+                  <a:srgbClr val="334155"/>
+                </a:solidFill>
+                <a:latin typeface="Segoe UI"/>
+              </a:rPr>
+              <a:t>AI prepares validated drafts; accountants retain full approval authority.</a:t>
             </a:r>
           </a:p>
           <a:p>
@@ -4779,15 +5131,24 @@
               <a:spcAft>
                 <a:spcPts val="800"/>
               </a:spcAft>
-              <a:defRPr sz="1100">
-                <a:solidFill>
-                  <a:srgbClr val="E2E8F0"/>
+              <a:defRPr sz="1050" b="1">
+                <a:solidFill>
+                  <a:srgbClr val="0F172A"/>
                 </a:solidFill>
                 <a:latin typeface="Segoe UI"/>
               </a:defRPr>
             </a:pPr>
             <a:r>
-              <a:t>• สร้างแต้มต่อทางธุรกิจ: FTH สามารถส่งมอบโซลูชันที่เหนือกว่าคู่แข่งรายอื่นในตลาด และตอบโจทย์องค์กรยุคใหม่อย่างแท้จริง</a:t>
+              <a:t>• Market Leadership: </a:t>
+            </a:r>
+            <a:r>
+              <a:rPr sz="1000" b="0">
+                <a:solidFill>
+                  <a:srgbClr val="334155"/>
+                </a:solidFill>
+                <a:latin typeface="Segoe UI"/>
+              </a:rPr>
+              <a:t>FTH delivers modern AI innovation that traditional competitors in Thailand cannot match.</a:t>
             </a:r>
           </a:p>
         </p:txBody>
@@ -4825,7 +5186,7 @@
             <a:avLst/>
           </a:prstGeom>
           <a:solidFill>
-            <a:srgbClr val="0B1120"/>
+            <a:srgbClr val="F8FAFC"/>
           </a:solidFill>
           <a:ln>
             <a:noFill/>
@@ -4862,13 +5223,13 @@
         <p:spPr>
           <a:xfrm>
             <a:off x="0" y="0"/>
-            <a:ext cx="12191695" cy="54864"/>
+            <a:ext cx="12191695" cy="73152"/>
           </a:xfrm>
           <a:prstGeom prst="rect">
             <a:avLst/>
           </a:prstGeom>
           <a:solidFill>
-            <a:srgbClr val="E60012"/>
+            <a:srgbClr val="DC2626"/>
           </a:solidFill>
           <a:ln>
             <a:noFill/>
@@ -4948,7 +5309,7 @@
               </a:spcAft>
               <a:defRPr sz="1000" b="1">
                 <a:solidFill>
-                  <a:srgbClr val="38BDF8"/>
+                  <a:srgbClr val="DC2626"/>
                 </a:solidFill>
                 <a:latin typeface="Segoe UI"/>
               </a:defRPr>
@@ -4964,26 +5325,26 @@
               </a:spcAft>
               <a:defRPr sz="2200" b="1">
                 <a:solidFill>
-                  <a:srgbClr val="FFFFFF"/>
+                  <a:srgbClr val="0F172A"/>
                 </a:solidFill>
                 <a:latin typeface="Segoe UI"/>
               </a:defRPr>
             </a:pPr>
             <a:r>
-              <a:t>Strengthening Dynamics 365 &amp; Maximizing Fujitsu (FTH) Enterprise Value</a:t>
+              <a:t>Strengthening Dynamics 365 &amp; Maximizing Fujitsu (FTH) Value</a:t>
             </a:r>
           </a:p>
           <a:p>
             <a:pPr>
               <a:defRPr sz="1200">
                 <a:solidFill>
-                  <a:srgbClr val="94A3B8"/>
+                  <a:srgbClr val="64748B"/>
                 </a:solidFill>
                 <a:latin typeface="Segoe UI"/>
               </a:defRPr>
             </a:pPr>
             <a:r>
-              <a:t>เสริมความแข็งแกร่งของโซลูชัน และสร้างมูลค่าเพิ่มมหาศาลให้กับ ฟูจิตสึ ประเทศไทย</a:t>
+              <a:t>A strategic technology fusion that drives mutual ROI for our clients and Fujitsu Thailand.</a:t>
             </a:r>
           </a:p>
         </p:txBody>
@@ -5011,7 +5372,7 @@
           <a:lstStyle/>
           <a:p>
             <a:pPr>
-              <a:defRPr sz="900">
+              <a:defRPr sz="900" b="1">
                 <a:solidFill>
                   <a:srgbClr val="64748B"/>
                 </a:solidFill>
@@ -5019,7 +5380,7 @@
               </a:defRPr>
             </a:pPr>
             <a:r>
-              <a:t>FUJITSU THAILAND (FTH) • DYNAMICS 365 &amp; COPILOT AI EXECUTIVE BRIEFING • SLIDE 3 OF 4</a:t>
+              <a:t>FUJITSU THAILAND (FTH) • DYNAMICS 365 &amp; COPILOT AI EXECUTIVE KEYNOTE • SLIDE 3 OF 4</a:t>
             </a:r>
           </a:p>
         </p:txBody>
@@ -5039,11 +5400,11 @@
             <a:avLst/>
           </a:prstGeom>
           <a:solidFill>
-            <a:srgbClr val="141D2F"/>
+            <a:srgbClr val="FFFFFF"/>
           </a:solidFill>
           <a:ln w="19050">
             <a:solidFill>
-              <a:srgbClr val="38BDF8"/>
+              <a:srgbClr val="0284C7"/>
             </a:solidFill>
           </a:ln>
         </p:spPr>
@@ -5071,23 +5432,23 @@
               </a:spcAft>
               <a:defRPr sz="1500" b="1">
                 <a:solidFill>
-                  <a:srgbClr val="38BDF8"/>
+                  <a:srgbClr val="0284C7"/>
                 </a:solidFill>
                 <a:latin typeface="Segoe UI"/>
               </a:defRPr>
             </a:pPr>
             <a:r>
-              <a:t>💎 1. เสริมความแข็งแกร่งของผลิตภัณฑ์ (D365 F&amp;O)</a:t>
+              <a:t>💎 1. D365 Product Enhancement</a:t>
             </a:r>
           </a:p>
           <a:p>
             <a:pPr>
               <a:spcAft>
-                <a:spcPts val="600"/>
+                <a:spcPts val="700"/>
               </a:spcAft>
               <a:defRPr sz="1100" b="1">
                 <a:solidFill>
-                  <a:srgbClr val="FFFFFF"/>
+                  <a:srgbClr val="0F172A"/>
                 </a:solidFill>
                 <a:latin typeface="Segoe UI"/>
               </a:defRPr>
@@ -5096,48 +5457,48 @@
               <a:t>• Native Copilot Fusion: </a:t>
             </a:r>
             <a:r>
-              <a:rPr sz="1050" b="0">
-                <a:solidFill>
-                  <a:srgbClr val="E2E8F0"/>
+              <a:rPr sz="1000" b="0">
+                <a:solidFill>
+                  <a:srgbClr val="334155"/>
                 </a:solidFill>
                 <a:latin typeface="Segoe UI"/>
               </a:rPr>
-              <a:t>ผสาน Microsoft Copilot Studio และ Azure AI เข้ากับ D365 ผ่าน Dataverse และ standard API โดยตรง ไม่มีการส่งข้อมูลออกนอกระบบ</a:t>
+              <a:t>Direct integration with Copilot Studio and Azure AI via Dataverse and standard APIs—zero external data leakage.</a:t>
             </a:r>
           </a:p>
           <a:p>
             <a:pPr>
               <a:spcAft>
-                <a:spcPts val="600"/>
+                <a:spcPts val="700"/>
               </a:spcAft>
               <a:defRPr sz="1100" b="1">
                 <a:solidFill>
-                  <a:srgbClr val="FFFFFF"/>
+                  <a:srgbClr val="0F172A"/>
                 </a:solidFill>
                 <a:latin typeface="Segoe UI"/>
               </a:defRPr>
             </a:pPr>
             <a:r>
-              <a:t>• Autonomous Draft Workflow: </a:t>
-            </a:r>
-            <a:r>
-              <a:rPr sz="1050" b="0">
-                <a:solidFill>
-                  <a:srgbClr val="E2E8F0"/>
+              <a:t>• Autonomous Draft Preparation: </a:t>
+            </a:r>
+            <a:r>
+              <a:rPr sz="1000" b="0">
+                <a:solidFill>
+                  <a:srgbClr val="334155"/>
                 </a:solidFill>
                 <a:latin typeface="Segoe UI"/>
               </a:rPr>
-              <a:t>AI ช่วยอ่านเอกสาร ตรวจสอบกฎระเบียบ และสร้าง Draft Vendor Invoice ล่วงหน้า ลดเวลางานลงกว่า 70%</a:t>
+              <a:t>AI reads documents, validates 3-way matching rules, and creates draft vendor invoices—slashing AP review time by &gt;70%.</a:t>
             </a:r>
           </a:p>
           <a:p>
             <a:pPr>
               <a:spcAft>
-                <a:spcPts val="600"/>
+                <a:spcPts val="700"/>
               </a:spcAft>
               <a:defRPr sz="1100" b="1">
                 <a:solidFill>
-                  <a:srgbClr val="FFFFFF"/>
+                  <a:srgbClr val="0F172A"/>
                 </a:solidFill>
                 <a:latin typeface="Segoe UI"/>
               </a:defRPr>
@@ -5146,38 +5507,38 @@
               <a:t>• Strict Human-in-the-Loop: </a:t>
             </a:r>
             <a:r>
-              <a:rPr sz="1050" b="0">
-                <a:solidFill>
-                  <a:srgbClr val="E2E8F0"/>
+              <a:rPr sz="1000" b="0">
+                <a:solidFill>
+                  <a:srgbClr val="334155"/>
                 </a:solidFill>
                 <a:latin typeface="Segoe UI"/>
               </a:rPr>
-              <a:t>รักษาความปลอดภัยสูงสุด AI ทำหน้าที่เป็นผู้ช่วยจัดเตรียม แต่พนักงานต้องกด Confirm และ Approve เสมอก่อนโพสต์ลงสมุดบัญชี</a:t>
+              <a:t>AI prepares validated drafts; accountants retain exclusive approval authority before any journal posting.</a:t>
             </a:r>
           </a:p>
           <a:p>
             <a:pPr>
               <a:spcAft>
-                <a:spcPts val="600"/>
+                <a:spcPts val="700"/>
               </a:spcAft>
               <a:defRPr sz="1100" b="1">
                 <a:solidFill>
-                  <a:srgbClr val="FFFFFF"/>
+                  <a:srgbClr val="0F172A"/>
                 </a:solidFill>
                 <a:latin typeface="Segoe UI"/>
               </a:defRPr>
             </a:pPr>
             <a:r>
-              <a:t>• Comprehensive Thai Localization: </a:t>
-            </a:r>
-            <a:r>
-              <a:rPr sz="1050" b="0">
-                <a:solidFill>
-                  <a:srgbClr val="E2E8F0"/>
+              <a:t>• Total Thai Tax Compliance: </a:t>
+            </a:r>
+            <a:r>
+              <a:rPr sz="1000" b="0">
+                <a:solidFill>
+                  <a:srgbClr val="334155"/>
                 </a:solidFill>
                 <a:latin typeface="Segoe UI"/>
               </a:rPr>
-              <a:t>ครอบคลุมรายงานภาษีไทยครบวงจร: ภ.พ.30, ภ.ง.ด.3, ภ.ง.ด.53, หนังสือรับรองการหักภาษี 50 ทวิ และ e-Tax XML</a:t>
+              <a:t>Full support for PP.30, PND 3/53, 50 Tawi certificates, and Revenue Dept e-Tax XML formats.</a:t>
             </a:r>
           </a:p>
         </p:txBody>
@@ -5197,11 +5558,11 @@
             <a:avLst/>
           </a:prstGeom>
           <a:solidFill>
-            <a:srgbClr val="141D2F"/>
+            <a:srgbClr val="FFFFFF"/>
           </a:solidFill>
           <a:ln w="19050">
             <a:solidFill>
-              <a:srgbClr val="E60012"/>
+              <a:srgbClr val="DC2626"/>
             </a:solidFill>
           </a:ln>
         </p:spPr>
@@ -5229,113 +5590,113 @@
               </a:spcAft>
               <a:defRPr sz="1500" b="1">
                 <a:solidFill>
-                  <a:srgbClr val="F87171"/>
+                  <a:srgbClr val="DC2626"/>
                 </a:solidFill>
                 <a:latin typeface="Segoe UI"/>
               </a:defRPr>
             </a:pPr>
             <a:r>
-              <a:t>🏆 2. เพิ่มมูลค่าและแต้มต่อทางธุรกิจให้ Fujitsu (FTH)</a:t>
+              <a:t>🏆 2. Fujitsu (FTH) Strategic Value</a:t>
             </a:r>
           </a:p>
           <a:p>
             <a:pPr>
               <a:spcAft>
-                <a:spcPts val="600"/>
+                <a:spcPts val="700"/>
               </a:spcAft>
               <a:defRPr sz="1100" b="1">
                 <a:solidFill>
-                  <a:srgbClr val="FFFFFF"/>
+                  <a:srgbClr val="0F172A"/>
                 </a:solidFill>
                 <a:latin typeface="Segoe UI"/>
               </a:defRPr>
             </a:pPr>
             <a:r>
-              <a:t>• First-Mover Advantage ในไทย: </a:t>
-            </a:r>
-            <a:r>
-              <a:rPr sz="1050" b="0">
-                <a:solidFill>
-                  <a:srgbClr val="E2E8F0"/>
+              <a:t>• First-Mover Advantage in Thailand: </a:t>
+            </a:r>
+            <a:r>
+              <a:rPr sz="1000" b="0">
+                <a:solidFill>
+                  <a:srgbClr val="334155"/>
                 </a:solidFill>
                 <a:latin typeface="Segoe UI"/>
               </a:rPr>
-              <a:t>FTH เป็นผู้นำรายแรกที่นำเสนอ Thai Localization Package ที่มี AI ฝังตัว ช่วยสร้างแต้มต่อที่ยากแก่การลอกเลียนแบบ</a:t>
+              <a:t>FTH becomes the first partner offering a pre-packaged, AI-infused Thai Localization solution, creating a strong moat.</a:t>
             </a:r>
           </a:p>
           <a:p>
             <a:pPr>
               <a:spcAft>
-                <a:spcPts val="600"/>
+                <a:spcPts val="700"/>
               </a:spcAft>
               <a:defRPr sz="1100" b="1">
                 <a:solidFill>
-                  <a:srgbClr val="FFFFFF"/>
+                  <a:srgbClr val="0F172A"/>
                 </a:solidFill>
                 <a:latin typeface="Segoe UI"/>
               </a:defRPr>
             </a:pPr>
             <a:r>
-              <a:t>• High-Margin Reusable IP: </a:t>
-            </a:r>
-            <a:r>
-              <a:rPr sz="1050" b="0">
-                <a:solidFill>
-                  <a:srgbClr val="E2E8F0"/>
+              <a:t>• High-Margin Reusable IP Asset: </a:t>
+            </a:r>
+            <a:r>
+              <a:rPr sz="1000" b="0">
+                <a:solidFill>
+                  <a:srgbClr val="334155"/>
                 </a:solidFill>
                 <a:latin typeface="Segoe UI"/>
               </a:rPr>
-              <a:t>สามารถแพ็กเกจเป็น Commercial IP Asset นำไปติดตั้งและต่อยอดให้กับลูกค้าองค์กรได้อย่างรวดเร็ว ลดเวลา Implement</a:t>
+              <a:t>Packaged as commercial IP, enabling rapid deployment across enterprise clients with lower implementation costs.</a:t>
             </a:r>
           </a:p>
           <a:p>
             <a:pPr>
               <a:spcAft>
-                <a:spcPts val="600"/>
+                <a:spcPts val="700"/>
               </a:spcAft>
               <a:defRPr sz="1100" b="1">
                 <a:solidFill>
-                  <a:srgbClr val="FFFFFF"/>
+                  <a:srgbClr val="0F172A"/>
                 </a:solidFill>
                 <a:latin typeface="Segoe UI"/>
               </a:defRPr>
             </a:pPr>
             <a:r>
-              <a:t>• ขยายฐานลูกค้าญี่ปุ่นและองค์กรชั้นนำ: </a:t>
-            </a:r>
-            <a:r>
-              <a:rPr sz="1050" b="0">
-                <a:solidFill>
-                  <a:srgbClr val="E2E8F0"/>
+              <a:t>• Expands Japanese MNC &amp; Enterprise Footprint: </a:t>
+            </a:r>
+            <a:r>
+              <a:rPr sz="1000" b="0">
+                <a:solidFill>
+                  <a:srgbClr val="334155"/>
                 </a:solidFill>
                 <a:latin typeface="Segoe UI"/>
               </a:rPr>
-              <a:t>ตอบโจทย์ Japanese MNCs และกลุ่มธุรกิจขนาดใหญ่ในไทยที่ต้องการยกระดับ ERP ให้ทันสมัยและสอดรับกฎหมายไทย</a:t>
+              <a:t>Tailored to Japanese MNCs and major Thai conglomerates seeking modern, compliant ERP modernization.</a:t>
             </a:r>
           </a:p>
           <a:p>
             <a:pPr>
               <a:spcAft>
-                <a:spcPts val="600"/>
+                <a:spcPts val="700"/>
               </a:spcAft>
               <a:defRPr sz="1100" b="1">
                 <a:solidFill>
-                  <a:srgbClr val="FFFFFF"/>
+                  <a:srgbClr val="0F172A"/>
                 </a:solidFill>
                 <a:latin typeface="Segoe UI"/>
               </a:defRPr>
             </a:pPr>
             <a:r>
-              <a:t>• Fujitsu Trusted Brand Heritage: </a:t>
-            </a:r>
-            <a:r>
-              <a:rPr sz="1050" b="0">
-                <a:solidFill>
-                  <a:srgbClr val="E2E8F0"/>
+              <a:t>• Reinforces Global Trusted Partner Brand: </a:t>
+            </a:r>
+            <a:r>
+              <a:rPr sz="1000" b="0">
+                <a:solidFill>
+                  <a:srgbClr val="334155"/>
                 </a:solidFill>
                 <a:latin typeface="Segoe UI"/>
               </a:rPr>
-              <a:t>ผสานจุดแข็งด้าน Service Quality และมาตรฐานความปลอดภัยขั้นสูงของ Fujitsu เข้ากับนวัตกรรม AI ระดับโลกของ Microsoft</a:t>
+              <a:t>Combines Fujitsu’s renowned Japanese quality and governance standards with Microsoft’s premier AI technology.</a:t>
             </a:r>
           </a:p>
         </p:txBody>
@@ -5373,7 +5734,7 @@
             <a:avLst/>
           </a:prstGeom>
           <a:solidFill>
-            <a:srgbClr val="0B1120"/>
+            <a:srgbClr val="F8FAFC"/>
           </a:solidFill>
           <a:ln>
             <a:noFill/>
@@ -5410,13 +5771,13 @@
         <p:spPr>
           <a:xfrm>
             <a:off x="0" y="0"/>
-            <a:ext cx="12191695" cy="54864"/>
+            <a:ext cx="12191695" cy="73152"/>
           </a:xfrm>
           <a:prstGeom prst="rect">
             <a:avLst/>
           </a:prstGeom>
           <a:solidFill>
-            <a:srgbClr val="E60012"/>
+            <a:srgbClr val="DC2626"/>
           </a:solidFill>
           <a:ln>
             <a:noFill/>
@@ -5496,7 +5857,7 @@
               </a:spcAft>
               <a:defRPr sz="1000" b="1">
                 <a:solidFill>
-                  <a:srgbClr val="38BDF8"/>
+                  <a:srgbClr val="DC2626"/>
                 </a:solidFill>
                 <a:latin typeface="Segoe UI"/>
               </a:defRPr>
@@ -5512,26 +5873,26 @@
               </a:spcAft>
               <a:defRPr sz="2200" b="1">
                 <a:solidFill>
-                  <a:srgbClr val="FFFFFF"/>
+                  <a:srgbClr val="0F172A"/>
                 </a:solidFill>
                 <a:latin typeface="Segoe UI"/>
               </a:defRPr>
             </a:pPr>
             <a:r>
-              <a:t>Executive Agenda &amp; Transition to Live Interactive Solution Pitch</a:t>
+              <a:t>Executive Agenda &amp; Transition to Live Solution Pitch</a:t>
             </a:r>
           </a:p>
           <a:p>
             <a:pPr>
               <a:defRPr sz="1200">
                 <a:solidFill>
-                  <a:srgbClr val="94A3B8"/>
+                  <a:srgbClr val="64748B"/>
                 </a:solidFill>
                 <a:latin typeface="Segoe UI"/>
               </a:defRPr>
             </a:pPr>
             <a:r>
-              <a:t>โครงสร้างเนื้อหาที่จะได้รับชมในวันนี้ และการส่งมอบเข้าสู่แพลตฟอร์มจำลองระบบจริง (Interactive Deck)</a:t>
+              <a:t>Today’s 12-slide walkthrough and formal handover into the live interactive demonstration platform.</a:t>
             </a:r>
           </a:p>
         </p:txBody>
@@ -5559,7 +5920,7 @@
           <a:lstStyle/>
           <a:p>
             <a:pPr>
-              <a:defRPr sz="900">
+              <a:defRPr sz="900" b="1">
                 <a:solidFill>
                   <a:srgbClr val="64748B"/>
                 </a:solidFill>
@@ -5567,7 +5928,7 @@
               </a:defRPr>
             </a:pPr>
             <a:r>
-              <a:t>FUJITSU THAILAND (FTH) • DYNAMICS 365 &amp; COPILOT AI EXECUTIVE BRIEFING • SLIDE 4 OF 4</a:t>
+              <a:t>FUJITSU THAILAND (FTH) • DYNAMICS 365 &amp; COPILOT AI EXECUTIVE KEYNOTE • SLIDE 4 OF 4</a:t>
             </a:r>
           </a:p>
         </p:txBody>
@@ -5587,11 +5948,11 @@
             <a:avLst/>
           </a:prstGeom>
           <a:solidFill>
-            <a:srgbClr val="141D2F"/>
+            <a:srgbClr val="FFFFFF"/>
           </a:solidFill>
           <a:ln w="19050">
             <a:solidFill>
-              <a:srgbClr val="263455"/>
+              <a:srgbClr val="E2E8F0"/>
             </a:solidFill>
           </a:ln>
         </p:spPr>
@@ -5619,13 +5980,13 @@
               </a:spcAft>
               <a:defRPr sz="1500" b="1">
                 <a:solidFill>
-                  <a:srgbClr val="38BDF8"/>
+                  <a:srgbClr val="0284C7"/>
                 </a:solidFill>
                 <a:latin typeface="Segoe UI"/>
               </a:defRPr>
             </a:pPr>
             <a:r>
-              <a:t>📑 4 ประเด็นสำคัญใน Live Interactive Solution Pitch (12 สไลด์)</a:t>
+              <a:t>📑 Key Milestones in Live Interactive Pitch (12 Slides)</a:t>
             </a:r>
           </a:p>
           <a:p>
@@ -5635,7 +5996,7 @@
               </a:spcAft>
               <a:defRPr sz="1100" b="1">
                 <a:solidFill>
-                  <a:srgbClr val="FFFFFF"/>
+                  <a:srgbClr val="0F172A"/>
                 </a:solidFill>
                 <a:latin typeface="Segoe UI"/>
               </a:defRPr>
@@ -5644,13 +6005,13 @@
               <a:t>• 1. Official Architecture: </a:t>
             </a:r>
             <a:r>
-              <a:rPr sz="1050" b="0">
-                <a:solidFill>
-                  <a:srgbClr val="E2E8F0"/>
+              <a:rPr sz="1000" b="0">
+                <a:solidFill>
+                  <a:srgbClr val="334155"/>
                 </a:solidFill>
                 <a:latin typeface="Segoe UI"/>
               </a:rPr>
-              <a:t>สถาปัตยกรรมอ้างอิง Microsoft Copilot Studio &amp; Multi-Agent Framework ที่ทำงานร่วมกับ D365 อย่างปลอดภัย</a:t>
+              <a:t>Multi-Agent Framework and 100% secure enterprise integration with D365 via Dataverse.</a:t>
             </a:r>
           </a:p>
           <a:p>
@@ -5660,7 +6021,7 @@
               </a:spcAft>
               <a:defRPr sz="1100" b="1">
                 <a:solidFill>
-                  <a:srgbClr val="FFFFFF"/>
+                  <a:srgbClr val="0F172A"/>
                 </a:solidFill>
                 <a:latin typeface="Segoe UI"/>
               </a:defRPr>
@@ -5669,13 +6030,13 @@
               <a:t>• 2. Top 5 Thai Use Cases: </a:t>
             </a:r>
             <a:r>
-              <a:rPr sz="1050" b="0">
-                <a:solidFill>
-                  <a:srgbClr val="E2E8F0"/>
+              <a:rPr sz="1000" b="0">
+                <a:solidFill>
+                  <a:srgbClr val="334155"/>
                 </a:solidFill>
                 <a:latin typeface="Segoe UI"/>
               </a:rPr>
-              <a:t>สาธิต 5 รูปแบบการใช้งานจริง: AP Invoice, Tax Compliance, e-Tax Gateway, Continuous Reconciliation และ Knowledge Q&amp;A</a:t>
+              <a:t>Live walkthrough: AP Invoice Intelligence, Thai Tax Copilot, e-Tax Gateway, and Continuous Reconciliation.</a:t>
             </a:r>
           </a:p>
           <a:p>
@@ -5685,22 +6046,22 @@
               </a:spcAft>
               <a:defRPr sz="1100" b="1">
                 <a:solidFill>
-                  <a:srgbClr val="FFFFFF"/>
+                  <a:srgbClr val="0F172A"/>
                 </a:solidFill>
                 <a:latin typeface="Segoe UI"/>
               </a:defRPr>
             </a:pPr>
             <a:r>
-              <a:t>• 3. 8-Week POC Roadmap: </a:t>
-            </a:r>
-            <a:r>
-              <a:rPr sz="1050" b="0">
-                <a:solidFill>
-                  <a:srgbClr val="E2E8F0"/>
+              <a:t>• 3. 8-Week POC Delivery Plan: </a:t>
+            </a:r>
+            <a:r>
+              <a:rPr sz="1000" b="0">
+                <a:solidFill>
+                  <a:srgbClr val="334155"/>
                 </a:solidFill>
                 <a:latin typeface="Segoe UI"/>
               </a:rPr>
-              <a:t>แผนการดำเนินงานโครงการนำร่อง 8 สัปดาห์ เพื่อประเมินผลความคุ้มค่า (ROI) และความพร้อมในการใช้งานจริง</a:t>
+              <a:t>Pragmatic, low-risk deployment roadmap delivering fast measurable value and fast payback.</a:t>
             </a:r>
           </a:p>
           <a:p>
@@ -5710,7 +6071,7 @@
               </a:spcAft>
               <a:defRPr sz="1100" b="1">
                 <a:solidFill>
-                  <a:srgbClr val="FFFFFF"/>
+                  <a:srgbClr val="0F172A"/>
                 </a:solidFill>
                 <a:latin typeface="Segoe UI"/>
               </a:defRPr>
@@ -5719,13 +6080,13 @@
               <a:t>• 4. Dual-Host AI Narration: </a:t>
             </a:r>
             <a:r>
-              <a:rPr sz="1050" b="0">
-                <a:solidFill>
-                  <a:srgbClr val="E2E8F0"/>
+              <a:rPr sz="1000" b="0">
+                <a:solidFill>
+                  <a:srgbClr val="334155"/>
                 </a:solidFill>
                 <a:latin typeface="Segoe UI"/>
               </a:rPr>
-              <a:t>ระบบเสียงบรรยายจำลองแบบ Dual-Host รองรับทั้งภาษาอังกฤษและภาษาไทย พร้อมระบบเลื่อนสไลด์อัตโนมัติ</a:t>
+              <a:t>Production neural studio voice in English &amp; Thai with automated auto-tour mode.</a:t>
             </a:r>
           </a:p>
         </p:txBody>
@@ -5745,11 +6106,11 @@
             <a:avLst/>
           </a:prstGeom>
           <a:solidFill>
-            <a:srgbClr val="141D2F"/>
+            <a:srgbClr val="FFFFFF"/>
           </a:solidFill>
           <a:ln w="19050">
             <a:solidFill>
-              <a:srgbClr val="10B981"/>
+              <a:srgbClr val="059669"/>
             </a:solidFill>
           </a:ln>
         </p:spPr>
@@ -5777,13 +6138,13 @@
               </a:spcAft>
               <a:defRPr sz="1400" b="1">
                 <a:solidFill>
-                  <a:srgbClr val="10B981"/>
+                  <a:srgbClr val="059669"/>
                 </a:solidFill>
                 <a:latin typeface="Segoe UI"/>
               </a:defRPr>
             </a:pPr>
             <a:r>
-              <a:t>🚀 คำกล่าวส่งต่อและเปิดตัวระบบจำลอง (Live Handover)</a:t>
+              <a:t>🚀 Ready for Live Demonstration</a:t>
             </a:r>
           </a:p>
           <a:p>
@@ -5791,15 +6152,15 @@
               <a:spcAft>
                 <a:spcPts val="1600"/>
               </a:spcAft>
-              <a:defRPr sz="1150" i="1">
-                <a:solidFill>
-                  <a:srgbClr val="A7F3D0"/>
+              <a:defRPr sz="1100" i="1">
+                <a:solidFill>
+                  <a:srgbClr val="334155"/>
                 </a:solidFill>
                 <a:latin typeface="Segoe UI"/>
               </a:defRPr>
             </a:pPr>
             <a:r>
-              <a:t>"บัดนี้ ผมขอเรียนเชิญคณะผู้บริหารทุกท่าน ร่วมสัมผัสและทดสอบระบบจำลองจริงผ่าน Interactive Pitch Deck ได้ ณ บัดนี้ครับ..."</a:t>
+              <a:t>"Without further ado, let us now transition directly into the live interactive platform to experience the future of D365 and Copilot AI firsthand..."</a:t>
             </a:r>
           </a:p>
           <a:p>
@@ -5807,15 +6168,15 @@
               <a:spcAft>
                 <a:spcPts val="400"/>
               </a:spcAft>
-              <a:defRPr sz="1100" b="1">
-                <a:solidFill>
-                  <a:srgbClr val="FFFFFF"/>
+              <a:defRPr sz="1050" b="1">
+                <a:solidFill>
+                  <a:srgbClr val="0F172A"/>
                 </a:solidFill>
                 <a:latin typeface="Segoe UI"/>
               </a:defRPr>
             </a:pPr>
             <a:r>
-              <a:t>🌐 Direct Solution Link:</a:t>
+              <a:t>🌐 Direct Platform Link (GitHub Pages):</a:t>
             </a:r>
           </a:p>
           <a:p>
@@ -5825,7 +6186,7 @@
               </a:spcAft>
               <a:defRPr sz="1000" b="1">
                 <a:solidFill>
-                  <a:srgbClr val="38BDF8"/>
+                  <a:srgbClr val="0284C7"/>
                 </a:solidFill>
                 <a:latin typeface="Segoe UI"/>
               </a:defRPr>
@@ -5838,17 +6199,17 @@
             <a:pPr>
               <a:defRPr sz="950">
                 <a:solidFill>
-                  <a:srgbClr val="94A3B8"/>
+                  <a:srgbClr val="64748B"/>
                 </a:solidFill>
                 <a:latin typeface="Segoe UI"/>
               </a:defRPr>
             </a:pPr>
             <a:r>
-              <a:t>💡 คำแนะนำสำหรับพิธีกร:</a:t>
+              <a:t>💡 Host Guidance:</a:t>
             </a:r>
             <a:br/>
             <a:r>
-              <a:t>เมื่อกล่าวประโยคส่งมอบจบ สามารถคลิกเปิดลิงก์ด้านบน หรือสลับหน้าต่างไปยังเบราว์เซอร์เพื่อเริ่มระบบสไลด์จำลองได้ทันที</a:t>
+              <a:t>Click the live link or switch to the browser window to start the 12-slide interactive tour.</a:t>
             </a:r>
           </a:p>
         </p:txBody>

</xml_diff>

<commit_message>
Finalize professional 4-slide English executive PPTX with pure formal scripts in notes and clean white theme
</commit_message>
<xml_diff>
--- a/FTH_D365_Executive_Opening_Deck.pptx
+++ b/FTH_D365_Executive_Opening_Deck.pptx
@@ -505,54 +505,42 @@
           <a:lstStyle/>
           <a:p>
             <a:r>
-              <a:t>【English Executive Host Script - Slide 1: Welcome &amp; Visionary Opening】</a:t>
+              <a:t>【Slide 1: Executive Welcome &amp; Visionary Opening】</a:t>
+            </a:r>
+          </a:p>
+          <a:p>
+            <a:r>
+              <a:t>Tone: Formal, Confident, Prestigious | Target Duration: ~40 seconds</a:t>
             </a:r>
           </a:p>
           <a:p/>
           <a:p>
             <a:r>
-              <a:t>"Good morning and welcome, esteemed executives, colleagues, and distinguished guests. Welcome to this strategic executive briefing from Fujitsu Thailand (FTH) on 'Empowering Enterprise ERP with Microsoft Copilot AI'.</a:t>
+              <a:t>"Good morning, members of the executive leadership team, esteemed colleagues, and distinguished guests.</a:t>
             </a:r>
           </a:p>
           <a:p/>
           <a:p>
             <a:r>
-              <a:t>Today, we are thrilled to present our vision for advancing Microsoft Dynamics 365 Finance &amp; Operations by natively infusing Microsoft Copilot Studio and Azure AI into everyday financial and Thai tax compliance workflows.</a:t>
+              <a:t>On behalf of Fujitsu Thailand, it is my distinct privilege to welcome you to today’s executive briefing: 'Empowering Enterprise ERP with Microsoft Copilot AI.'</a:t>
             </a:r>
           </a:p>
           <a:p/>
           <a:p>
             <a:r>
-              <a:t>Our purpose today is not merely introducing new AI features, but creating high-value Strategic Intellectual Property (IP) for FTH—strengthening our market position as Thailand's most trusted partner in enterprise digital transformation."</a:t>
+              <a:t>As organizations navigate rapid digital evolution and intensifying regulatory demands in Thailand, traditional enterprise resource planning systems must evolve beyond passive data recording. Today, we are proud to present Fujitsu’s strategic vision for Dynamics 365 Finance &amp; Operations—natively enhanced by Microsoft Copilot Studio and Azure AI.</a:t>
             </a:r>
           </a:p>
           <a:p/>
           <a:p>
             <a:r>
-              <a:t>----------------------------------------------------------------------</a:t>
-            </a:r>
-          </a:p>
-          <a:p>
-            <a:r>
-              <a:t>【บทพูดภาษาไทยสำหรับพิธีกร - สไลด์ที่ 1: ต้อนรับผู้บริหารและเกริ่นนำวิสัยทัศน์】</a:t>
+              <a:t>Our objective this morning is twofold: first, to demonstrate how autonomous AI streamlines everyday accounting, accounts payable, and Thai tax compliance; and second, to illustrate how this initiative creates proprietary, high-margin Intellectual Property that solidifies Fujitsu Thailand’s position as the premier digital transformation partner in the region.</a:t>
             </a:r>
           </a:p>
           <a:p/>
           <a:p>
             <a:r>
-              <a:t>"กราบเรียนท่านผู้บริหาร คณะทำงาน และแขกผู้มีเกียรติทุกท่านครับ ผมขอต้อนรับทุกท่านเข้าสู่การนำเสนอเชิงกลยุทธ์ ของ ฟูจิตสึ ประเทศไทย (FTH) ในหัวข้อ 'Empowering Enterprise ERP with Microsoft Copilot AI' ครับ</a:t>
-            </a:r>
-          </a:p>
-          <a:p/>
-          <a:p>
-            <a:r>
-              <a:t>ในวันนี้ เรามีความยินดีเป็นอย่างยิ่งที่จะแบ่งปันวิสัยทัศน์ในการยกระดับระบบ Dynamics 365 Finance &amp; Operations โดยการนำเทคโนโลยีปัญญาประดิษฐ์ระดับองค์กรอย่าง Microsoft Copilot Studio และ Azure AI เข้ามาเสริมความแข็งแกร่ง ให้กับกระบวนการบัญชีและการเงินของไทย</a:t>
-            </a:r>
-          </a:p>
-          <a:p/>
-          <a:p>
-            <a:r>
-              <a:t>เป้าหมายสำคัญของเราในวันนี้ ไม่ใช่เพียงการแนะนำเทคโนโลยีใหม่ แต่เป็นการสร้าง New Strategic Asset และเพิ่มมูลค่าการแข่งขัน ให้กับ FTH ในฐานะผู้นำโซลูชันด้านดิจิทัลทรานส์ฟอร์เมชันที่ได้รับความไว้วางใจสูงสุดในประเทศไทยครับ"</a:t>
+              <a:t>Thank you for your time, and we look forward to an insightful session."</a:t>
             </a:r>
           </a:p>
         </p:txBody>
@@ -622,54 +610,36 @@
           <a:lstStyle/>
           <a:p>
             <a:r>
-              <a:t>【English Executive Host Script - Slide 2: Industry Shift &amp; Local Challenges】</a:t>
+              <a:t>【Slide 2: Industry Shift &amp; Local Regulatory Challenges】</a:t>
+            </a:r>
+          </a:p>
+          <a:p>
+            <a:r>
+              <a:t>Tone: Problem-Solving, Strategic | Target Duration: ~45 seconds</a:t>
             </a:r>
           </a:p>
           <a:p/>
           <a:p>
             <a:r>
-              <a:t>"Distinguished guests, looking at day-to-day operations across Thailand, traditional ERP systems have served effectively as Systems of Record. However, the true operational bottleneck lies within Accounts Payable—where finance teams spend over 70% of their time manually reviewing hundreds of PDF tax invoices.</a:t>
+              <a:t>"Turning to Slide 2, let us examine the operational realities and regulatory drivers shaping modern corporate finance.</a:t>
             </a:r>
           </a:p>
           <a:p/>
           <a:p>
             <a:r>
-              <a:t>From verifying 13-digit Tax IDs and 5-digit branch codes to 3-way matching and withholding tax calculations, manual workloads create severe month-end crunches. Coupled with the Revenue Department's aggressive push toward e-Tax Invoice and e-Receipt mandates, a single clerical oversight risks delayed filings and compliance penalties.</a:t>
+              <a:t>Historically, ERP systems were designed as Systems of Record—reliable at logging historical transactions, but fundamentally passive. In practice, our finance and Accounts Payable teams across Thailand continue to bear an immense manual burden. More than 70% of an AP accountant's time is consumed by repetitive administrative tasks: scrutinizing hundreds of PDF tax invoices, cross-referencing purchase orders, and validating 13-digit Tax Identification Numbers and branch codes line by line.</a:t>
             </a:r>
           </a:p>
           <a:p/>
           <a:p>
             <a:r>
-              <a:t>This is precisely why Fujitsu sees an unprecedented opportunity to elevate D365 into a 'System of Intelligence'—automating repetitive burdens and equipping our finance professionals with predictive, pre-validated intelligence."</a:t>
+              <a:t>Compounding this challenge is Thailand’s rapidly tightening regulatory landscape. The Revenue Department’s ongoing transition toward mandatory e-Tax Invoices and e-Receipts, coupled with intricate Withholding Tax classifications, means that even a minor typographical error can stall monthly PP.30 filings or invite statutory penalties.</a:t>
             </a:r>
           </a:p>
           <a:p/>
           <a:p>
             <a:r>
-              <a:t>----------------------------------------------------------------------</a:t>
-            </a:r>
-          </a:p>
-          <a:p>
-            <a:r>
-              <a:t>【บทพูดภาษาไทยสำหรับพิธีกร - สไลด์ที่ 2: ชี้ให้เห็นความท้าทายและโอกาส】</a:t>
-            </a:r>
-          </a:p>
-          <a:p/>
-          <a:p>
-            <a:r>
-              <a:t>"ทุกท่านครับ เมื่อมองย้อนกลับมาที่การดำเนินงานจริงในปัจจุบัน ระบบ ERP แบบดั้งเดิมทำหน้าที่บันทึกประวัติ หรือ System of Record ได้ดี แต่ปัญหาคอขวดที่แท้จริงขององค์กรธุรกิจในประเทศไทย คือภาระงานของทีมบัญชี (AP) ที่ต้องตรวจสอบเอกสารใบกำกับภาษี PDF จำนวนหลายร้อยหลายพันใบในแต่ละเดือน</a:t>
-            </a:r>
-          </a:p>
-          <a:p/>
-          <a:p>
-            <a:r>
-              <a:t>ทั้งการตรวจสอบเลขประจำตัวผู้เสียภาษี 13 หลัก, สาขา 5 หลัก, การจับคู่ 3-Way Matching, และการคำนวณภาษีหัก ณ ที่จ่าย ประกอบกับนโยบายของกรมสรรพากรที่กำลังขับเคลื่อนสู่ e-Tax Invoice อย่างเต็มรูปแบบ ความผิดพลาดแม้เพียงเล็กน้อย ย่อมหมายถึงความล่าช้าและผลกระทบทางภาษี</a:t>
-            </a:r>
-          </a:p>
-          <a:p/>
-          <a:p>
-            <a:r>
-              <a:t>นี่คือสาเหตุที่ ฟูจิตสึ เล็งเห็นโอกาสครั้งสำคัญ ในการเปลี่ยนผ่าน D365 ให้กลายเป็น 'System of Intelligence' เพื่อช่วยแบ่งเบาภาระงานซ้ำซ้อน และเพิ่มความแม่นยำให้กับการเงินขององค์กรครับ"</a:t>
+              <a:t>This operational friction represents a transformative opportunity for Fujitsu. By elevating Dynamics 365 into a System of Intelligence, we introduce proactive AI agents that validate data, match transactions, and flag discrepancies before posting—converting the finance department from a transactional cost center into an agile, strategic growth driver."</a:t>
             </a:r>
           </a:p>
         </p:txBody>
@@ -739,54 +709,30 @@
           <a:lstStyle/>
           <a:p>
             <a:r>
-              <a:t>【English Executive Host Script - Slide 3: Product Excellence &amp; Fujitsu Value】</a:t>
+              <a:t>【Slide 3: Product Excellence &amp; Fujitsu Strategic Value】</a:t>
+            </a:r>
+          </a:p>
+          <a:p>
+            <a:r>
+              <a:t>Tone: Visionary, High-Impact | Target Duration: ~50 seconds</a:t>
             </a:r>
           </a:p>
           <a:p/>
           <a:p>
             <a:r>
-              <a:t>"From a strategic value and ROI perspective, this initiative drives dual impact:</a:t>
+              <a:t>"On Slide 3, we illustrate how this initiative generates substantial, balanced value across both the product platform and Fujitsu Thailand’s commercial portfolio.</a:t>
             </a:r>
           </a:p>
           <a:p/>
           <a:p>
             <a:r>
-              <a:t>First, Product Excellence for Dynamics 365: By natively embedding Copilot Studio and Azure AI via Dataverse, enterprise data remains 100% secure within company boundaries. AI extracts, cross-checks against Thai tax laws, and prepares draft vendor invoices—reducing cycle time by over 70%, while strictly maintaining Human-in-the-Loop governance so that finance professionals retain full approval authority before any journal posting.</a:t>
+              <a:t>From a product enhancement perspective, we are embedding Microsoft Copilot Studio and Azure AI directly into Dynamics 365 via Microsoft Dataverse. This architectural design ensures that enterprise data never leaves your secure tenant. Rather than replacing human judgment, Copilot functions as an autonomous drafting co-pilot: extracting invoice details, validating against 3-way matching rules, and pre-populating draft vendor journals. Crucially, we enforce strict Human-in-the-Loop governance: no transaction is ever committed to the general ledger without explicit review and approval by an authorized accountant.</a:t>
             </a:r>
           </a:p>
           <a:p/>
           <a:p>
             <a:r>
-              <a:t>Second, Unmatched Business Value for Fujitsu Thailand: FTH establishes a distinctive first-mover advantage by offering a pre-packaged, AI-infused Thai Localization solution. This high-margin, reusable IP enables our sales and consulting teams to scale rapidly across Japanese multinationals (MNCs) and top-tier Thai conglomerates—reinforcing Fujitsu’s global reputation for quality, governance, and trust."</a:t>
-            </a:r>
-          </a:p>
-          <a:p/>
-          <a:p>
-            <a:r>
-              <a:t>----------------------------------------------------------------------</a:t>
-            </a:r>
-          </a:p>
-          <a:p>
-            <a:r>
-              <a:t>【บทพูดภาษาไทยสำหรับพิธีกร - สไลด์ที่ 3: เสริมแกร่งผลิตภัณฑ์และคุณค่าของ FTH】</a:t>
-            </a:r>
-          </a:p>
-          <a:p/>
-          <a:p>
-            <a:r>
-              <a:t>"ในแง่ของความคุ้มค่าและผลประโยชน์เชิงกลยุทธ์ โครงการนี้ได้สร้างคุณค่าสองด้านพร้อมกันครับ</a:t>
-            </a:r>
-          </a:p>
-          <a:p/>
-          <a:p>
-            <a:r>
-              <a:t>ด้านแรก คือความแข็งแกร่งของผลิตภัณฑ์ Dynamics 365 ที่ได้รับการอัปเกรดให้มี AI ทำงานอยู่เบื้องหลังอย่างแท้จริง ช่วยเตรียมเอกสารร่าง ตรวจสอบกฎหมายภาษีไทย และคงมาตรฐานความปลอดภัยระดับสูงสุด โดยไม่ปล่อยให้ AI โพสต์ข้อมูลโดยพลการ</a:t>
-            </a:r>
-          </a:p>
-          <a:p/>
-          <a:p>
-            <a:r>
-              <a:t>และด้านที่สอง ซึ่งสำคัญยิ่งต่อ ฟูจิตสึ ประเทศไทย คือการสร้าง 'ความแตกต่างที่เหนือกว่า' ในตลาด ERP เราจะไม่ได้เป็นเพียงผู้ Implement ระบบตามคู่มือทั่วไป แต่เราจะเป็นเจ้าของ Intellectual Property หรือทรัพย์สินทางปัญญา ที่ตอบโจทย์ภาษีไทยด้วย AI ซึ่งสร้าง Margin ที่สูงขึ้น เปิดประตูสู่กลุ่มลูกค้าบริษัทข้ามชาติทั้งญี่ปุ่นและไทย และตอกย้ำภาพลักษณ์ของ Fujitsu ในฐานะผู้นำด้านนวัตกรรมองค์กรครับ"</a:t>
+              <a:t>From Fujitsu Thailand’s strategic perspective, this initiative establishes a decisive first-mover advantage. By transforming custom localization scripts into a packaged, repeatable AI-powered Thai Localization IP asset, we significantly reduce project implementation time while commanding higher consulting margins. This offering directly addresses the acute compliance needs of Japanese multinationals and major domestic enterprises in Thailand, reinforcing Fujitsu’s legacy of Japanese engineering quality, robust governance, and trusted delivery."</a:t>
             </a:r>
           </a:p>
         </p:txBody>
@@ -856,54 +802,56 @@
           <a:lstStyle/>
           <a:p>
             <a:r>
-              <a:t>【English Executive Host Script - Slide 4: Agenda &amp; Live Demonstration Handover】</a:t>
+              <a:t>【Slide 4: Executive Agenda &amp; Transition to Live Solution Pitch】</a:t>
+            </a:r>
+          </a:p>
+          <a:p>
+            <a:r>
+              <a:t>Tone: Engaging, Action-Oriented | Target Duration: ~30 seconds</a:t>
             </a:r>
           </a:p>
           <a:p/>
           <a:p>
             <a:r>
-              <a:t>"Looking ahead to today’s session, we have prepared a comprehensive 12-slide Live Interactive Solution Pitch that demonstrates the actual production-ready capabilities:</a:t>
+              <a:t>"Finally, on Slide 4, let us outline the interactive journey we have prepared for you today.</a:t>
             </a:r>
           </a:p>
           <a:p/>
           <a:p>
             <a:r>
-              <a:t>We will walk through the official Microsoft Copilot Studio multi-agent architecture, explore our top five Thai localization use cases—from AP Invoice Intelligence to Continuous Reconciliation—and outline our practical 8-week POC delivery roadmap.</a:t>
+              <a:t>Following this opening briefing, we will transition directly into our production-grade Live Interactive Pitch Platform, which walks through four core pillars across twelve executive slides:</a:t>
+            </a:r>
+          </a:p>
+          <a:p>
+            <a:r>
+              <a:t>1. First, the official Microsoft Copilot Studio reference architecture, detailing enterprise security, Dataverse integration, and multi-agent coordination;</a:t>
+            </a:r>
+          </a:p>
+          <a:p>
+            <a:r>
+              <a:t>2. Second, an in-depth walkthrough of our top five Thai localization use cases—spanning AP Invoice Intelligence, Thai Tax Copilot, e-Tax Gateway pre-validation, Continuous Reconciliation, and Policy Q&amp;A;</a:t>
+            </a:r>
+          </a:p>
+          <a:p>
+            <a:r>
+              <a:t>3. Third, a pragmatic 8-week Proof of Concept delivery roadmap, engineered to deliver measurable ROI and verified business value within two months; and</a:t>
+            </a:r>
+          </a:p>
+          <a:p>
+            <a:r>
+              <a:t>4. Fourth, an interactive presentation experience equipped with dual-host narration and real-time scenario simulation.</a:t>
             </a:r>
           </a:p>
           <a:p/>
           <a:p>
             <a:r>
-              <a:t>Without further ado, I would now like to invite our executive team to transition directly into the live interactive platform to experience the future of Dynamics 365 and Copilot AI firsthand. Let us begin."</a:t>
+              <a:t>Without further delay, I invite our executive team to transition with me into the live interactive platform to witness the future of Dynamics 365 and Copilot AI in action.</a:t>
             </a:r>
           </a:p>
           <a:p/>
           <a:p>
             <a:r>
-              <a:t>----------------------------------------------------------------------</a:t>
-            </a:r>
-          </a:p>
-          <a:p>
-            <a:r>
-              <a:t>【บทพูดภาษาไทยสำหรับพิธีกร - สไลด์ที่ 4: สรุปหัวข้อและส่งต่อเข้าสู่ Live Interactive Deck】</a:t>
-            </a:r>
-          </a:p>
-          <a:p/>
-          <a:p>
-            <a:r>
-              <a:t>"และในลำดับถัดไป เพื่อให้ทุกท่านได้เห็นภาพการทำงานจริงอย่างเป็นรูปธรรม ทางทีมงานได้จัดเตรียม แพลตฟอร์มการนำเสนอแบบ Interactive Pitch Deck จำนวน 12 สไลด์ ที่จำลองการทำงานจริงอย่างละเอียด</a:t>
-            </a:r>
-          </a:p>
-          <a:p/>
-          <a:p>
-            <a:r>
-              <a:t>โดยประกอบด้วยสถาปัตยกรรมทางเทคนิค, 5 Use Cases หลักที่ออกแบบมาเพื่อภาษีไทยโดยเฉพาะ, และแผนการดำเนินงาน POC 8 สัปดาห์ พร้อมเสียงบรรยายจำลองแบบ Dual-Host ที่ปรับแต่งมาอย่างเป็นทางการ</a:t>
-            </a:r>
-          </a:p>
-          <a:p/>
-          <a:p>
-            <a:r>
-              <a:t>บัดนี้ ผมขออนุญาตนำพาทุกท่านเข้าสู่ระบบจำลองผ่านลิงก์โครงการ เพื่อร่วมทดสอบและสัมผัสประสบการณ์แห่งอนาคต ของ Dynamics 365 และ Copilot AI ไปพร้อมกันได้ ณ บัดนี้ครับ ขอเรียนเชิญทุกท่านครับ"</a:t>
+              <a:t>Please join me as we launch the live demonstration."</a:t>
             </a:r>
           </a:p>
         </p:txBody>
@@ -3924,7 +3872,7 @@
             <a:avLst/>
           </a:prstGeom>
           <a:solidFill>
-            <a:srgbClr val="F8FAFC"/>
+            <a:srgbClr val="FFFFFF"/>
           </a:solidFill>
           <a:ln>
             <a:noFill/>
@@ -4011,7 +3959,7 @@
         </p:blipFill>
         <p:spPr>
           <a:xfrm>
-            <a:off x="10424160" y="365760"/>
+            <a:off x="10378440" y="320040"/>
             <a:ext cx="1280160" cy="676448"/>
           </a:xfrm>
           <a:prstGeom prst="rect">
@@ -4028,7 +3976,7 @@
         <p:spPr>
           <a:xfrm>
             <a:off x="731520" y="320040"/>
-            <a:ext cx="9326880" cy="1188720"/>
+            <a:ext cx="9418320" cy="1097280"/>
           </a:xfrm>
           <a:prstGeom prst="rect">
             <a:avLst/>
@@ -4043,9 +3991,9 @@
           <a:p>
             <a:pPr>
               <a:spcAft>
-                <a:spcPts val="300"/>
+                <a:spcPts val="200"/>
               </a:spcAft>
-              <a:defRPr sz="1000" b="1">
+              <a:defRPr sz="950" b="1">
                 <a:solidFill>
                   <a:srgbClr val="DC2626"/>
                 </a:solidFill>
@@ -4053,13 +4001,13 @@
               </a:defRPr>
             </a:pPr>
             <a:r>
-              <a:t>FUJITSU THAILAND (FTH) • STRATEGIC KEYNOTE</a:t>
+              <a:t>FUJITSU THAILAND (FTH) • STRATEGIC EXECUTIVE KEYNOTE</a:t>
             </a:r>
           </a:p>
           <a:p>
             <a:pPr>
               <a:spcAft>
-                <a:spcPts val="300"/>
+                <a:spcPts val="200"/>
               </a:spcAft>
               <a:defRPr sz="2200" b="1">
                 <a:solidFill>
@@ -4074,9 +4022,9 @@
           </a:p>
           <a:p>
             <a:pPr>
-              <a:defRPr sz="1200">
-                <a:solidFill>
-                  <a:srgbClr val="64748B"/>
+              <a:defRPr sz="1100">
+                <a:solidFill>
+                  <a:srgbClr val="475569"/>
                 </a:solidFill>
                 <a:latin typeface="Segoe UI"/>
               </a:defRPr>
@@ -4089,14 +4037,57 @@
       </p:sp>
       <p:sp>
         <p:nvSpPr>
-          <p:cNvPr id="6" name="TextBox 5"/>
+          <p:cNvPr id="6" name="Rectangle 5"/>
+          <p:cNvSpPr/>
+          <p:nvPr/>
+        </p:nvSpPr>
+        <p:spPr>
+          <a:xfrm>
+            <a:off x="731520" y="1508760"/>
+            <a:ext cx="10728655" cy="13716"/>
+          </a:xfrm>
+          <a:prstGeom prst="rect">
+            <a:avLst/>
+          </a:prstGeom>
+          <a:solidFill>
+            <a:srgbClr val="E2E8F0"/>
+          </a:solidFill>
+          <a:ln>
+            <a:noFill/>
+          </a:ln>
+        </p:spPr>
+        <p:style>
+          <a:lnRef idx="1">
+            <a:schemeClr val="accent1"/>
+          </a:lnRef>
+          <a:fillRef idx="3">
+            <a:schemeClr val="accent1"/>
+          </a:fillRef>
+          <a:effectRef idx="2">
+            <a:schemeClr val="accent1"/>
+          </a:effectRef>
+          <a:fontRef idx="minor">
+            <a:schemeClr val="lt1"/>
+          </a:fontRef>
+        </p:style>
+        <p:txBody>
+          <a:bodyPr rtlCol="0" anchor="ctr"/>
+          <a:lstStyle/>
+          <a:p>
+            <a:pPr algn="ctr"/>
+          </a:p>
+        </p:txBody>
+      </p:sp>
+      <p:sp>
+        <p:nvSpPr>
+          <p:cNvPr id="7" name="TextBox 6"/>
           <p:cNvSpPr txBox="1"/>
           <p:nvPr/>
         </p:nvSpPr>
         <p:spPr>
           <a:xfrm>
-            <a:off x="731520" y="6400800"/>
-            <a:ext cx="10698480" cy="320040"/>
+            <a:off x="731520" y="6446520"/>
+            <a:ext cx="10728655" cy="274320"/>
           </a:xfrm>
           <a:prstGeom prst="rect">
             <a:avLst/>
@@ -4110,9 +4101,9 @@
           <a:lstStyle/>
           <a:p>
             <a:pPr>
-              <a:defRPr sz="900" b="1">
-                <a:solidFill>
-                  <a:srgbClr val="64748B"/>
+              <a:defRPr sz="850" b="1">
+                <a:solidFill>
+                  <a:srgbClr val="94A3B8"/>
                 </a:solidFill>
                 <a:latin typeface="Segoe UI"/>
               </a:defRPr>
@@ -4125,24 +4116,24 @@
       </p:sp>
       <p:sp>
         <p:nvSpPr>
-          <p:cNvPr id="7" name="Rounded Rectangle 6"/>
+          <p:cNvPr id="8" name="Rounded Rectangle 7"/>
           <p:cNvSpPr/>
           <p:nvPr/>
         </p:nvSpPr>
         <p:spPr>
           <a:xfrm>
             <a:off x="731520" y="1691640"/>
-            <a:ext cx="3328416" cy="4434840"/>
+            <a:ext cx="3328416" cy="3977639"/>
           </a:xfrm>
           <a:prstGeom prst="roundRect">
             <a:avLst/>
           </a:prstGeom>
           <a:solidFill>
-            <a:srgbClr val="FFFFFF"/>
+            <a:srgbClr val="F8FAFC"/>
           </a:solidFill>
-          <a:ln w="19050">
+          <a:ln w="15240">
             <a:solidFill>
-              <a:srgbClr val="0284C7"/>
+              <a:srgbClr val="E2E8F0"/>
             </a:solidFill>
           </a:ln>
         </p:spPr>
@@ -4161,14 +4152,14 @@
           </a:fontRef>
         </p:style>
         <p:txBody>
-          <a:bodyPr rtlCol="0" anchor="ctr" wrap="square" lIns="274320" rIns="274320" tIns="274320"/>
+          <a:bodyPr rtlCol="0" anchor="ctr" wrap="square" lIns="274320" rIns="274320" tIns="228600"/>
           <a:lstStyle/>
           <a:p>
             <a:pPr algn="ctr">
               <a:spcAft>
                 <a:spcPts val="1200"/>
               </a:spcAft>
-              <a:defRPr sz="1400" b="1">
+              <a:defRPr sz="1350" b="1">
                 <a:solidFill>
                   <a:srgbClr val="0284C7"/>
                 </a:solidFill>
@@ -4186,22 +4177,22 @@
               </a:spcAft>
               <a:defRPr sz="1050" b="1">
                 <a:solidFill>
-                  <a:srgbClr val="0F172A"/>
+                  <a:srgbClr val="1E293B"/>
                 </a:solidFill>
                 <a:latin typeface="Segoe UI"/>
               </a:defRPr>
             </a:pPr>
             <a:r>
-              <a:t>• Speed &amp; Precision: </a:t>
-            </a:r>
-            <a:r>
-              <a:rPr sz="1000" b="0">
-                <a:solidFill>
-                  <a:srgbClr val="334155"/>
+              <a:t>• Workflow Automation: </a:t>
+            </a:r>
+            <a:r>
+              <a:rPr sz="950" b="0">
+                <a:solidFill>
+                  <a:srgbClr val="475569"/>
                 </a:solidFill>
                 <a:latin typeface="Segoe UI"/>
               </a:rPr>
-              <a:t>Transforming manual accounting workflows into an intelligent system that reads, verifies, and pre-drafts invoices.</a:t>
+              <a:t>Transforms manual accounting workflows into an intelligent system that reads, verifies, and pre-drafts transactions.</a:t>
             </a:r>
           </a:p>
           <a:p>
@@ -4211,22 +4202,22 @@
               </a:spcAft>
               <a:defRPr sz="1050" b="1">
                 <a:solidFill>
-                  <a:srgbClr val="0F172A"/>
+                  <a:srgbClr val="1E293B"/>
                 </a:solidFill>
                 <a:latin typeface="Segoe UI"/>
               </a:defRPr>
             </a:pPr>
             <a:r>
-              <a:t>• Seamless Dynamics 365: </a:t>
-            </a:r>
-            <a:r>
-              <a:rPr sz="1000" b="0">
-                <a:solidFill>
-                  <a:srgbClr val="334155"/>
+              <a:t>• Native D365 Fusion: </a:t>
+            </a:r>
+            <a:r>
+              <a:rPr sz="950" b="0">
+                <a:solidFill>
+                  <a:srgbClr val="475569"/>
                 </a:solidFill>
                 <a:latin typeface="Segoe UI"/>
               </a:rPr>
-              <a:t>Direct native fusion between Copilot Studio, Azure AI, and D365 F&amp;O via Dataverse.</a:t>
+              <a:t>Direct integration with Copilot Studio, Azure AI, and D365 F&amp;O via Dataverse—zero external data leakage.</a:t>
             </a:r>
           </a:p>
           <a:p>
@@ -4236,46 +4227,89 @@
               </a:spcAft>
               <a:defRPr sz="1050" b="1">
                 <a:solidFill>
-                  <a:srgbClr val="0F172A"/>
+                  <a:srgbClr val="1E293B"/>
                 </a:solidFill>
                 <a:latin typeface="Segoe UI"/>
               </a:defRPr>
             </a:pPr>
             <a:r>
-              <a:t>• Labor Savings: </a:t>
-            </a:r>
-            <a:r>
-              <a:rPr sz="1000" b="0">
-                <a:solidFill>
-                  <a:srgbClr val="334155"/>
+              <a:t>• Operational Efficiency: </a:t>
+            </a:r>
+            <a:r>
+              <a:rPr sz="950" b="0">
+                <a:solidFill>
+                  <a:srgbClr val="475569"/>
                 </a:solidFill>
                 <a:latin typeface="Segoe UI"/>
               </a:rPr>
-              <a:t>Slashes repetitive Accounts Payable cycle time by over 70%, freeing teams for strategic finance.</a:t>
-            </a:r>
-          </a:p>
-        </p:txBody>
-      </p:sp>
-      <p:sp>
-        <p:nvSpPr>
-          <p:cNvPr id="8" name="Rounded Rectangle 7"/>
+              <a:t>Slashes repetitive Accounts Payable cycle time by over 70%, freeing teams for strategic financial analysis.</a:t>
+            </a:r>
+          </a:p>
+        </p:txBody>
+      </p:sp>
+      <p:sp>
+        <p:nvSpPr>
+          <p:cNvPr id="9" name="Rounded Rectangle 8"/>
           <p:cNvSpPr/>
           <p:nvPr/>
         </p:nvSpPr>
         <p:spPr>
           <a:xfrm>
-            <a:off x="4425696" y="1691640"/>
-            <a:ext cx="3328416" cy="4434840"/>
+            <a:off x="731520" y="1691640"/>
+            <a:ext cx="3328416" cy="73152"/>
           </a:xfrm>
           <a:prstGeom prst="roundRect">
             <a:avLst/>
           </a:prstGeom>
           <a:solidFill>
-            <a:srgbClr val="FFFFFF"/>
+            <a:srgbClr val="0284C7"/>
           </a:solidFill>
-          <a:ln w="19050">
+          <a:ln>
+            <a:noFill/>
+          </a:ln>
+        </p:spPr>
+        <p:style>
+          <a:lnRef idx="1">
+            <a:schemeClr val="accent1"/>
+          </a:lnRef>
+          <a:fillRef idx="3">
+            <a:schemeClr val="accent1"/>
+          </a:fillRef>
+          <a:effectRef idx="2">
+            <a:schemeClr val="accent1"/>
+          </a:effectRef>
+          <a:fontRef idx="minor">
+            <a:schemeClr val="lt1"/>
+          </a:fontRef>
+        </p:style>
+        <p:txBody>
+          <a:bodyPr rtlCol="0" anchor="ctr"/>
+          <a:lstStyle/>
+          <a:p>
+            <a:pPr algn="ctr"/>
+          </a:p>
+        </p:txBody>
+      </p:sp>
+      <p:sp>
+        <p:nvSpPr>
+          <p:cNvPr id="10" name="Rounded Rectangle 9"/>
+          <p:cNvSpPr/>
+          <p:nvPr/>
+        </p:nvSpPr>
+        <p:spPr>
+          <a:xfrm>
+            <a:off x="4425696" y="1691640"/>
+            <a:ext cx="3328416" cy="3977639"/>
+          </a:xfrm>
+          <a:prstGeom prst="roundRect">
+            <a:avLst/>
+          </a:prstGeom>
+          <a:solidFill>
+            <a:srgbClr val="F8FAFC"/>
+          </a:solidFill>
+          <a:ln w="15240">
             <a:solidFill>
-              <a:srgbClr val="7C3AED"/>
+              <a:srgbClr val="E2E8F0"/>
             </a:solidFill>
           </a:ln>
         </p:spPr>
@@ -4294,14 +4328,14 @@
           </a:fontRef>
         </p:style>
         <p:txBody>
-          <a:bodyPr rtlCol="0" anchor="ctr" wrap="square" lIns="274320" rIns="274320" tIns="274320"/>
+          <a:bodyPr rtlCol="0" anchor="ctr" wrap="square" lIns="274320" rIns="274320" tIns="228600"/>
           <a:lstStyle/>
           <a:p>
             <a:pPr algn="ctr">
               <a:spcAft>
                 <a:spcPts val="1200"/>
               </a:spcAft>
-              <a:defRPr sz="1400" b="1">
+              <a:defRPr sz="1350" b="1">
                 <a:solidFill>
                   <a:srgbClr val="7C3AED"/>
                 </a:solidFill>
@@ -4319,22 +4353,22 @@
               </a:spcAft>
               <a:defRPr sz="1050" b="1">
                 <a:solidFill>
-                  <a:srgbClr val="0F172A"/>
+                  <a:srgbClr val="1E293B"/>
                 </a:solidFill>
                 <a:latin typeface="Segoe UI"/>
               </a:defRPr>
             </a:pPr>
             <a:r>
-              <a:t>• 100% Tax Alignment: </a:t>
-            </a:r>
-            <a:r>
-              <a:rPr sz="1000" b="0">
-                <a:solidFill>
-                  <a:srgbClr val="334155"/>
+              <a:t>• Full Regulatory Support: </a:t>
+            </a:r>
+            <a:r>
+              <a:rPr sz="950" b="0">
+                <a:solidFill>
+                  <a:srgbClr val="475569"/>
                 </a:solidFill>
                 <a:latin typeface="Segoe UI"/>
               </a:rPr>
-              <a:t>Built for Revenue Department standards: PP.30 VAT 7%, PND 3/53, and 50 Tawi certificates.</a:t>
+              <a:t>Purpose-built for Revenue Department requirements: PP.30 VAT 7%, PND 3/53, and 50 Tawi certificates.</a:t>
             </a:r>
           </a:p>
           <a:p>
@@ -4344,7 +4378,7 @@
               </a:spcAft>
               <a:defRPr sz="1050" b="1">
                 <a:solidFill>
-                  <a:srgbClr val="0F172A"/>
+                  <a:srgbClr val="1E293B"/>
                 </a:solidFill>
                 <a:latin typeface="Segoe UI"/>
               </a:defRPr>
@@ -4353,13 +4387,13 @@
               <a:t>• e-Tax Pre-Validation: </a:t>
             </a:r>
             <a:r>
-              <a:rPr sz="1000" b="0">
-                <a:solidFill>
-                  <a:srgbClr val="334155"/>
+              <a:rPr sz="950" b="0">
+                <a:solidFill>
+                  <a:srgbClr val="475569"/>
                 </a:solidFill>
                 <a:latin typeface="Segoe UI"/>
               </a:rPr>
-              <a:t>Automatic gate checking 13-digit Tax IDs and 5-digit branch codes before XML generation.</a:t>
+              <a:t>Automatic validation gate checking 13-digit Tax IDs and 5-digit branch codes prior to XML generation.</a:t>
             </a:r>
           </a:p>
           <a:p>
@@ -4369,7 +4403,7 @@
               </a:spcAft>
               <a:defRPr sz="1050" b="1">
                 <a:solidFill>
-                  <a:srgbClr val="0F172A"/>
+                  <a:srgbClr val="1E293B"/>
                 </a:solidFill>
                 <a:latin typeface="Segoe UI"/>
               </a:defRPr>
@@ -4378,37 +4412,80 @@
               <a:t>• Continuous Subledger Audit: </a:t>
             </a:r>
             <a:r>
-              <a:rPr sz="1000" b="0">
-                <a:solidFill>
-                  <a:srgbClr val="334155"/>
+              <a:rPr sz="950" b="0">
+                <a:solidFill>
+                  <a:srgbClr val="475569"/>
                 </a:solidFill>
                 <a:latin typeface="Segoe UI"/>
               </a:rPr>
-              <a:t>Monitors GL against AP/AR/Tax continuously, preventing month-end tax filing panic.</a:t>
-            </a:r>
-          </a:p>
-        </p:txBody>
-      </p:sp>
-      <p:sp>
-        <p:nvSpPr>
-          <p:cNvPr id="9" name="Rounded Rectangle 8"/>
+              <a:t>Monitors General Ledger against AP, AR, and Tax subledgers throughout the month, eliminating closing panic.</a:t>
+            </a:r>
+          </a:p>
+        </p:txBody>
+      </p:sp>
+      <p:sp>
+        <p:nvSpPr>
+          <p:cNvPr id="11" name="Rounded Rectangle 10"/>
           <p:cNvSpPr/>
           <p:nvPr/>
         </p:nvSpPr>
         <p:spPr>
           <a:xfrm>
-            <a:off x="8119872" y="1691640"/>
-            <a:ext cx="3328416" cy="4434840"/>
+            <a:off x="4425696" y="1691640"/>
+            <a:ext cx="3328416" cy="73152"/>
           </a:xfrm>
           <a:prstGeom prst="roundRect">
             <a:avLst/>
           </a:prstGeom>
           <a:solidFill>
-            <a:srgbClr val="FFFFFF"/>
+            <a:srgbClr val="7C3AED"/>
           </a:solidFill>
-          <a:ln w="19050">
+          <a:ln>
+            <a:noFill/>
+          </a:ln>
+        </p:spPr>
+        <p:style>
+          <a:lnRef idx="1">
+            <a:schemeClr val="accent1"/>
+          </a:lnRef>
+          <a:fillRef idx="3">
+            <a:schemeClr val="accent1"/>
+          </a:fillRef>
+          <a:effectRef idx="2">
+            <a:schemeClr val="accent1"/>
+          </a:effectRef>
+          <a:fontRef idx="minor">
+            <a:schemeClr val="lt1"/>
+          </a:fontRef>
+        </p:style>
+        <p:txBody>
+          <a:bodyPr rtlCol="0" anchor="ctr"/>
+          <a:lstStyle/>
+          <a:p>
+            <a:pPr algn="ctr"/>
+          </a:p>
+        </p:txBody>
+      </p:sp>
+      <p:sp>
+        <p:nvSpPr>
+          <p:cNvPr id="12" name="Rounded Rectangle 11"/>
+          <p:cNvSpPr/>
+          <p:nvPr/>
+        </p:nvSpPr>
+        <p:spPr>
+          <a:xfrm>
+            <a:off x="8119872" y="1691640"/>
+            <a:ext cx="3328416" cy="3977639"/>
+          </a:xfrm>
+          <a:prstGeom prst="roundRect">
+            <a:avLst/>
+          </a:prstGeom>
+          <a:solidFill>
+            <a:srgbClr val="F8FAFC"/>
+          </a:solidFill>
+          <a:ln w="15240">
             <a:solidFill>
-              <a:srgbClr val="DC2626"/>
+              <a:srgbClr val="E2E8F0"/>
             </a:solidFill>
           </a:ln>
         </p:spPr>
@@ -4427,14 +4504,14 @@
           </a:fontRef>
         </p:style>
         <p:txBody>
-          <a:bodyPr rtlCol="0" anchor="ctr" wrap="square" lIns="274320" rIns="274320" tIns="274320"/>
+          <a:bodyPr rtlCol="0" anchor="ctr" wrap="square" lIns="274320" rIns="274320" tIns="228600"/>
           <a:lstStyle/>
           <a:p>
             <a:pPr algn="ctr">
               <a:spcAft>
                 <a:spcPts val="1200"/>
               </a:spcAft>
-              <a:defRPr sz="1400" b="1">
+              <a:defRPr sz="1350" b="1">
                 <a:solidFill>
                   <a:srgbClr val="DC2626"/>
                 </a:solidFill>
@@ -4442,7 +4519,7 @@
               </a:defRPr>
             </a:pPr>
             <a:r>
-              <a:t>🏆 3. Value for Fujitsu (FTH)</a:t>
+              <a:t>🏆 3. Strategic Value for FTH</a:t>
             </a:r>
           </a:p>
           <a:p>
@@ -4452,7 +4529,7 @@
               </a:spcAft>
               <a:defRPr sz="1050" b="1">
                 <a:solidFill>
-                  <a:srgbClr val="0F172A"/>
+                  <a:srgbClr val="1E293B"/>
                 </a:solidFill>
                 <a:latin typeface="Segoe UI"/>
               </a:defRPr>
@@ -4461,13 +4538,13 @@
               <a:t>• Proprietary IP Leadership: </a:t>
             </a:r>
             <a:r>
-              <a:rPr sz="1000" b="0">
-                <a:solidFill>
-                  <a:srgbClr val="334155"/>
+              <a:rPr sz="950" b="0">
+                <a:solidFill>
+                  <a:srgbClr val="475569"/>
                 </a:solidFill>
                 <a:latin typeface="Segoe UI"/>
               </a:rPr>
-              <a:t>FTH owns a distinctive, repeatable AI-infused Thai Localization package in Thailand.</a:t>
+              <a:t>Establishes FTH as the premier partner with a proven, repeatable AI-infused Thai Localization package.</a:t>
             </a:r>
           </a:p>
           <a:p>
@@ -4477,7 +4554,7 @@
               </a:spcAft>
               <a:defRPr sz="1050" b="1">
                 <a:solidFill>
-                  <a:srgbClr val="0F172A"/>
+                  <a:srgbClr val="1E293B"/>
                 </a:solidFill>
                 <a:latin typeface="Segoe UI"/>
               </a:defRPr>
@@ -4486,13 +4563,13 @@
               <a:t>• High-Margin Reusability: </a:t>
             </a:r>
             <a:r>
-              <a:rPr sz="1000" b="0">
-                <a:solidFill>
-                  <a:srgbClr val="334155"/>
+              <a:rPr sz="950" b="0">
+                <a:solidFill>
+                  <a:srgbClr val="475569"/>
                 </a:solidFill>
                 <a:latin typeface="Segoe UI"/>
               </a:rPr>
-              <a:t>Packaged solution scales across Japanese MNCs and major Thai corporate clients.</a:t>
+              <a:t>Packaged solution scales across Japanese MNCs and major domestic corporate enterprises in Thailand.</a:t>
             </a:r>
           </a:p>
           <a:p>
@@ -4502,7 +4579,7 @@
               </a:spcAft>
               <a:defRPr sz="1050" b="1">
                 <a:solidFill>
-                  <a:srgbClr val="0F172A"/>
+                  <a:srgbClr val="1E293B"/>
                 </a:solidFill>
                 <a:latin typeface="Segoe UI"/>
               </a:defRPr>
@@ -4511,13 +4588,111 @@
               <a:t>• Trusted Global Partner: </a:t>
             </a:r>
             <a:r>
-              <a:rPr sz="1000" b="0">
-                <a:solidFill>
-                  <a:srgbClr val="334155"/>
+              <a:rPr sz="950" b="0">
+                <a:solidFill>
+                  <a:srgbClr val="475569"/>
                 </a:solidFill>
                 <a:latin typeface="Segoe UI"/>
               </a:rPr>
-              <a:t>Combines Fujitsu’s Japanese quality and governance with Microsoft’s premier enterprise AI.</a:t>
+              <a:t>Combines Fujitsu’s renowned Japanese quality and governance with Microsoft’s premier enterprise AI platform.</a:t>
+            </a:r>
+          </a:p>
+        </p:txBody>
+      </p:sp>
+      <p:sp>
+        <p:nvSpPr>
+          <p:cNvPr id="13" name="Rounded Rectangle 12"/>
+          <p:cNvSpPr/>
+          <p:nvPr/>
+        </p:nvSpPr>
+        <p:spPr>
+          <a:xfrm>
+            <a:off x="8119872" y="1691640"/>
+            <a:ext cx="3328416" cy="73152"/>
+          </a:xfrm>
+          <a:prstGeom prst="roundRect">
+            <a:avLst/>
+          </a:prstGeom>
+          <a:solidFill>
+            <a:srgbClr val="DC2626"/>
+          </a:solidFill>
+          <a:ln>
+            <a:noFill/>
+          </a:ln>
+        </p:spPr>
+        <p:style>
+          <a:lnRef idx="1">
+            <a:schemeClr val="accent1"/>
+          </a:lnRef>
+          <a:fillRef idx="3">
+            <a:schemeClr val="accent1"/>
+          </a:fillRef>
+          <a:effectRef idx="2">
+            <a:schemeClr val="accent1"/>
+          </a:effectRef>
+          <a:fontRef idx="minor">
+            <a:schemeClr val="lt1"/>
+          </a:fontRef>
+        </p:style>
+        <p:txBody>
+          <a:bodyPr rtlCol="0" anchor="ctr"/>
+          <a:lstStyle/>
+          <a:p>
+            <a:pPr algn="ctr"/>
+          </a:p>
+        </p:txBody>
+      </p:sp>
+      <p:sp>
+        <p:nvSpPr>
+          <p:cNvPr id="14" name="Rounded Rectangle 13"/>
+          <p:cNvSpPr/>
+          <p:nvPr/>
+        </p:nvSpPr>
+        <p:spPr>
+          <a:xfrm>
+            <a:off x="731520" y="5806440"/>
+            <a:ext cx="10728655" cy="475488"/>
+          </a:xfrm>
+          <a:prstGeom prst="roundRect">
+            <a:avLst/>
+          </a:prstGeom>
+          <a:solidFill>
+            <a:srgbClr val="F1F5F9"/>
+          </a:solidFill>
+          <a:ln w="12700">
+            <a:solidFill>
+              <a:srgbClr val="E2E8F0"/>
+            </a:solidFill>
+          </a:ln>
+        </p:spPr>
+        <p:style>
+          <a:lnRef idx="1">
+            <a:schemeClr val="accent1"/>
+          </a:lnRef>
+          <a:fillRef idx="3">
+            <a:schemeClr val="accent1"/>
+          </a:fillRef>
+          <a:effectRef idx="2">
+            <a:schemeClr val="accent1"/>
+          </a:effectRef>
+          <a:fontRef idx="minor">
+            <a:schemeClr val="lt1"/>
+          </a:fontRef>
+        </p:style>
+        <p:txBody>
+          <a:bodyPr rtlCol="0" anchor="ctr" wrap="square" tIns="109728"/>
+          <a:lstStyle/>
+          <a:p>
+            <a:pPr algn="ctr">
+              <a:defRPr sz="1000" b="1">
+                <a:solidFill>
+                  <a:srgbClr val="475569"/>
+                </a:solidFill>
+                <a:latin typeface="Segoe UI"/>
+              </a:defRPr>
+            </a:pPr>
+            <a:r>
+              <a:t>🎤 Presenter: Senior Solution Principal &amp; Executive Host, Fujitsu Thailand (FTH)   |   ⏱️ Opening Duration: ~2 Minutes   |   ● Direct Live Solution Pitch Handover</a:t>
             </a:r>
           </a:p>
         </p:txBody>
@@ -4555,7 +4730,7 @@
             <a:avLst/>
           </a:prstGeom>
           <a:solidFill>
-            <a:srgbClr val="F8FAFC"/>
+            <a:srgbClr val="FFFFFF"/>
           </a:solidFill>
           <a:ln>
             <a:noFill/>
@@ -4642,7 +4817,7 @@
         </p:blipFill>
         <p:spPr>
           <a:xfrm>
-            <a:off x="10424160" y="365760"/>
+            <a:off x="10378440" y="320040"/>
             <a:ext cx="1280160" cy="676448"/>
           </a:xfrm>
           <a:prstGeom prst="rect">
@@ -4659,7 +4834,7 @@
         <p:spPr>
           <a:xfrm>
             <a:off x="731520" y="320040"/>
-            <a:ext cx="9326880" cy="1188720"/>
+            <a:ext cx="9418320" cy="1097280"/>
           </a:xfrm>
           <a:prstGeom prst="rect">
             <a:avLst/>
@@ -4674,9 +4849,9 @@
           <a:p>
             <a:pPr>
               <a:spcAft>
-                <a:spcPts val="300"/>
+                <a:spcPts val="200"/>
               </a:spcAft>
-              <a:defRPr sz="1000" b="1">
+              <a:defRPr sz="950" b="1">
                 <a:solidFill>
                   <a:srgbClr val="DC2626"/>
                 </a:solidFill>
@@ -4690,7 +4865,7 @@
           <a:p>
             <a:pPr>
               <a:spcAft>
-                <a:spcPts val="300"/>
+                <a:spcPts val="200"/>
               </a:spcAft>
               <a:defRPr sz="2200" b="1">
                 <a:solidFill>
@@ -4705,9 +4880,9 @@
           </a:p>
           <a:p>
             <a:pPr>
-              <a:defRPr sz="1200">
-                <a:solidFill>
-                  <a:srgbClr val="64748B"/>
+              <a:defRPr sz="1100">
+                <a:solidFill>
+                  <a:srgbClr val="475569"/>
                 </a:solidFill>
                 <a:latin typeface="Segoe UI"/>
               </a:defRPr>
@@ -4720,14 +4895,57 @@
       </p:sp>
       <p:sp>
         <p:nvSpPr>
-          <p:cNvPr id="6" name="TextBox 5"/>
+          <p:cNvPr id="6" name="Rectangle 5"/>
+          <p:cNvSpPr/>
+          <p:nvPr/>
+        </p:nvSpPr>
+        <p:spPr>
+          <a:xfrm>
+            <a:off x="731520" y="1508760"/>
+            <a:ext cx="10728655" cy="13716"/>
+          </a:xfrm>
+          <a:prstGeom prst="rect">
+            <a:avLst/>
+          </a:prstGeom>
+          <a:solidFill>
+            <a:srgbClr val="E2E8F0"/>
+          </a:solidFill>
+          <a:ln>
+            <a:noFill/>
+          </a:ln>
+        </p:spPr>
+        <p:style>
+          <a:lnRef idx="1">
+            <a:schemeClr val="accent1"/>
+          </a:lnRef>
+          <a:fillRef idx="3">
+            <a:schemeClr val="accent1"/>
+          </a:fillRef>
+          <a:effectRef idx="2">
+            <a:schemeClr val="accent1"/>
+          </a:effectRef>
+          <a:fontRef idx="minor">
+            <a:schemeClr val="lt1"/>
+          </a:fontRef>
+        </p:style>
+        <p:txBody>
+          <a:bodyPr rtlCol="0" anchor="ctr"/>
+          <a:lstStyle/>
+          <a:p>
+            <a:pPr algn="ctr"/>
+          </a:p>
+        </p:txBody>
+      </p:sp>
+      <p:sp>
+        <p:nvSpPr>
+          <p:cNvPr id="7" name="TextBox 6"/>
           <p:cNvSpPr txBox="1"/>
           <p:nvPr/>
         </p:nvSpPr>
         <p:spPr>
           <a:xfrm>
-            <a:off x="731520" y="6400800"/>
-            <a:ext cx="10698480" cy="320040"/>
+            <a:off x="731520" y="6446520"/>
+            <a:ext cx="10728655" cy="274320"/>
           </a:xfrm>
           <a:prstGeom prst="rect">
             <a:avLst/>
@@ -4741,9 +4959,9 @@
           <a:lstStyle/>
           <a:p>
             <a:pPr>
-              <a:defRPr sz="900" b="1">
-                <a:solidFill>
-                  <a:srgbClr val="64748B"/>
+              <a:defRPr sz="850" b="1">
+                <a:solidFill>
+                  <a:srgbClr val="94A3B8"/>
                 </a:solidFill>
                 <a:latin typeface="Segoe UI"/>
               </a:defRPr>
@@ -4756,24 +4974,24 @@
       </p:sp>
       <p:sp>
         <p:nvSpPr>
-          <p:cNvPr id="7" name="Rounded Rectangle 6"/>
+          <p:cNvPr id="8" name="Rounded Rectangle 7"/>
           <p:cNvSpPr/>
           <p:nvPr/>
         </p:nvSpPr>
         <p:spPr>
           <a:xfrm>
             <a:off x="731520" y="1691640"/>
-            <a:ext cx="3328416" cy="4434840"/>
+            <a:ext cx="3328416" cy="3977639"/>
           </a:xfrm>
           <a:prstGeom prst="roundRect">
             <a:avLst/>
           </a:prstGeom>
           <a:solidFill>
-            <a:srgbClr val="FFFFFF"/>
+            <a:srgbClr val="F8FAFC"/>
           </a:solidFill>
-          <a:ln w="19050">
+          <a:ln w="15240">
             <a:solidFill>
-              <a:srgbClr val="DC2626"/>
+              <a:srgbClr val="E2E8F0"/>
             </a:solidFill>
           </a:ln>
         </p:spPr>
@@ -4792,14 +5010,14 @@
           </a:fontRef>
         </p:style>
         <p:txBody>
-          <a:bodyPr rtlCol="0" anchor="ctr" wrap="square" lIns="274320" rIns="274320" tIns="274320"/>
+          <a:bodyPr rtlCol="0" anchor="ctr" wrap="square" lIns="274320" rIns="274320" tIns="228600"/>
           <a:lstStyle/>
           <a:p>
             <a:pPr algn="ctr">
               <a:spcAft>
                 <a:spcPts val="1200"/>
               </a:spcAft>
-              <a:defRPr sz="1400" b="1">
+              <a:defRPr sz="1350" b="1">
                 <a:solidFill>
                   <a:srgbClr val="DC2626"/>
                 </a:solidFill>
@@ -4817,7 +5035,7 @@
               </a:spcAft>
               <a:defRPr sz="1050" b="1">
                 <a:solidFill>
-                  <a:srgbClr val="0F172A"/>
+                  <a:srgbClr val="1E293B"/>
                 </a:solidFill>
                 <a:latin typeface="Segoe UI"/>
               </a:defRPr>
@@ -4826,13 +5044,13 @@
               <a:t>• Manual Overload: </a:t>
             </a:r>
             <a:r>
-              <a:rPr sz="1000" b="0">
-                <a:solidFill>
-                  <a:srgbClr val="334155"/>
+              <a:rPr sz="950" b="0">
+                <a:solidFill>
+                  <a:srgbClr val="475569"/>
                 </a:solidFill>
                 <a:latin typeface="Segoe UI"/>
               </a:rPr>
-              <a:t>AP teams spend &gt;70% of time verifying PDF invoices, receipts, and line items manually.</a:t>
+              <a:t>Accounts Payable teams spend &gt;70% of time manually verifying PDF invoices, receipts, and line items.</a:t>
             </a:r>
           </a:p>
           <a:p>
@@ -4842,7 +5060,7 @@
               </a:spcAft>
               <a:defRPr sz="1050" b="1">
                 <a:solidFill>
-                  <a:srgbClr val="0F172A"/>
+                  <a:srgbClr val="1E293B"/>
                 </a:solidFill>
                 <a:latin typeface="Segoe UI"/>
               </a:defRPr>
@@ -4851,13 +5069,13 @@
               <a:t>• Human Error Risks: </a:t>
             </a:r>
             <a:r>
-              <a:rPr sz="1000" b="0">
-                <a:solidFill>
-                  <a:srgbClr val="334155"/>
+              <a:rPr sz="950" b="0">
+                <a:solidFill>
+                  <a:srgbClr val="475569"/>
                 </a:solidFill>
                 <a:latin typeface="Segoe UI"/>
               </a:rPr>
-              <a:t>Typos in 13-digit Tax IDs or 5-digit branch codes trigger tax discrepancies.</a:t>
+              <a:t>Typos in 13-digit Tax IDs or 5-digit branch codes trigger costly month-end tax filing discrepancies.</a:t>
             </a:r>
           </a:p>
           <a:p>
@@ -4867,46 +5085,89 @@
               </a:spcAft>
               <a:defRPr sz="1050" b="1">
                 <a:solidFill>
-                  <a:srgbClr val="0F172A"/>
+                  <a:srgbClr val="1E293B"/>
                 </a:solidFill>
                 <a:latin typeface="Segoe UI"/>
               </a:defRPr>
             </a:pPr>
             <a:r>
-              <a:t>• Closing Delays: </a:t>
-            </a:r>
-            <a:r>
-              <a:rPr sz="1000" b="0">
-                <a:solidFill>
-                  <a:srgbClr val="334155"/>
+              <a:t>• Month-End Bottlenecks: </a:t>
+            </a:r>
+            <a:r>
+              <a:rPr sz="950" b="0">
+                <a:solidFill>
+                  <a:srgbClr val="475569"/>
                 </a:solidFill>
                 <a:latin typeface="Segoe UI"/>
               </a:rPr>
-              <a:t>Month-end crunch delays PP.30 submissions and obscures real-time cash visibility.</a:t>
-            </a:r>
-          </a:p>
-        </p:txBody>
-      </p:sp>
-      <p:sp>
-        <p:nvSpPr>
-          <p:cNvPr id="8" name="Rounded Rectangle 7"/>
+              <a:t>Volume spikes create severe month-end stress, delaying PP.30 filings and obscuring cash visibility.</a:t>
+            </a:r>
+          </a:p>
+        </p:txBody>
+      </p:sp>
+      <p:sp>
+        <p:nvSpPr>
+          <p:cNvPr id="9" name="Rounded Rectangle 8"/>
           <p:cNvSpPr/>
           <p:nvPr/>
         </p:nvSpPr>
         <p:spPr>
           <a:xfrm>
-            <a:off x="4425696" y="1691640"/>
-            <a:ext cx="3328416" cy="4434840"/>
+            <a:off x="731520" y="1691640"/>
+            <a:ext cx="3328416" cy="73152"/>
           </a:xfrm>
           <a:prstGeom prst="roundRect">
             <a:avLst/>
           </a:prstGeom>
           <a:solidFill>
-            <a:srgbClr val="FFFFFF"/>
+            <a:srgbClr val="DC2626"/>
           </a:solidFill>
-          <a:ln w="19050">
+          <a:ln>
+            <a:noFill/>
+          </a:ln>
+        </p:spPr>
+        <p:style>
+          <a:lnRef idx="1">
+            <a:schemeClr val="accent1"/>
+          </a:lnRef>
+          <a:fillRef idx="3">
+            <a:schemeClr val="accent1"/>
+          </a:fillRef>
+          <a:effectRef idx="2">
+            <a:schemeClr val="accent1"/>
+          </a:effectRef>
+          <a:fontRef idx="minor">
+            <a:schemeClr val="lt1"/>
+          </a:fontRef>
+        </p:style>
+        <p:txBody>
+          <a:bodyPr rtlCol="0" anchor="ctr"/>
+          <a:lstStyle/>
+          <a:p>
+            <a:pPr algn="ctr"/>
+          </a:p>
+        </p:txBody>
+      </p:sp>
+      <p:sp>
+        <p:nvSpPr>
+          <p:cNvPr id="10" name="Rounded Rectangle 9"/>
+          <p:cNvSpPr/>
+          <p:nvPr/>
+        </p:nvSpPr>
+        <p:spPr>
+          <a:xfrm>
+            <a:off x="4425696" y="1691640"/>
+            <a:ext cx="3328416" cy="3977639"/>
+          </a:xfrm>
+          <a:prstGeom prst="roundRect">
+            <a:avLst/>
+          </a:prstGeom>
+          <a:solidFill>
+            <a:srgbClr val="F8FAFC"/>
+          </a:solidFill>
+          <a:ln w="15240">
             <a:solidFill>
-              <a:srgbClr val="7C3AED"/>
+              <a:srgbClr val="E2E8F0"/>
             </a:solidFill>
           </a:ln>
         </p:spPr>
@@ -4925,14 +5186,14 @@
           </a:fontRef>
         </p:style>
         <p:txBody>
-          <a:bodyPr rtlCol="0" anchor="ctr" wrap="square" lIns="274320" rIns="274320" tIns="274320"/>
+          <a:bodyPr rtlCol="0" anchor="ctr" wrap="square" lIns="274320" rIns="274320" tIns="228600"/>
           <a:lstStyle/>
           <a:p>
             <a:pPr algn="ctr">
               <a:spcAft>
                 <a:spcPts val="1200"/>
               </a:spcAft>
-              <a:defRPr sz="1400" b="1">
+              <a:defRPr sz="1350" b="1">
                 <a:solidFill>
                   <a:srgbClr val="7C3AED"/>
                 </a:solidFill>
@@ -4950,7 +5211,7 @@
               </a:spcAft>
               <a:defRPr sz="1050" b="1">
                 <a:solidFill>
-                  <a:srgbClr val="0F172A"/>
+                  <a:srgbClr val="1E293B"/>
                 </a:solidFill>
                 <a:latin typeface="Segoe UI"/>
               </a:defRPr>
@@ -4959,13 +5220,13 @@
               <a:t>• e-Tax Enforcement: </a:t>
             </a:r>
             <a:r>
-              <a:rPr sz="1000" b="0">
-                <a:solidFill>
-                  <a:srgbClr val="334155"/>
+              <a:rPr sz="950" b="0">
+                <a:solidFill>
+                  <a:srgbClr val="475569"/>
                 </a:solidFill>
                 <a:latin typeface="Segoe UI"/>
               </a:rPr>
-              <a:t>Revenue Dept requires strict XML schemas and 100% pre-validation before submission.</a:t>
+              <a:t>Revenue Department enforces strict XML / e-Filing schemas requiring 100% pre-validation before submission.</a:t>
             </a:r>
           </a:p>
           <a:p>
@@ -4975,7 +5236,7 @@
               </a:spcAft>
               <a:defRPr sz="1050" b="1">
                 <a:solidFill>
-                  <a:srgbClr val="0F172A"/>
+                  <a:srgbClr val="1E293B"/>
                 </a:solidFill>
                 <a:latin typeface="Segoe UI"/>
               </a:defRPr>
@@ -4984,13 +5245,13 @@
               <a:t>• Complex WHT Rules: </a:t>
             </a:r>
             <a:r>
-              <a:rPr sz="1000" b="0">
-                <a:solidFill>
-                  <a:srgbClr val="334155"/>
+              <a:rPr sz="950" b="0">
+                <a:solidFill>
+                  <a:srgbClr val="475569"/>
                 </a:solidFill>
                 <a:latin typeface="Segoe UI"/>
               </a:rPr>
-              <a:t>Variable 1%, 2%, 3%, 5% rates require exact categorization based on service nature.</a:t>
+              <a:t>Variable 1%, 2%, 3%, 5% rates require exact categorization based on the underlying nature of services.</a:t>
             </a:r>
           </a:p>
           <a:p>
@@ -5000,7 +5261,7 @@
               </a:spcAft>
               <a:defRPr sz="1050" b="1">
                 <a:solidFill>
-                  <a:srgbClr val="0F172A"/>
+                  <a:srgbClr val="1E293B"/>
                 </a:solidFill>
                 <a:latin typeface="Segoe UI"/>
               </a:defRPr>
@@ -5009,37 +5270,80 @@
               <a:t>• Penalty Exposure: </a:t>
             </a:r>
             <a:r>
-              <a:rPr sz="1000" b="0">
-                <a:solidFill>
-                  <a:srgbClr val="334155"/>
+              <a:rPr sz="950" b="0">
+                <a:solidFill>
+                  <a:srgbClr val="475569"/>
                 </a:solidFill>
                 <a:latin typeface="Segoe UI"/>
               </a:rPr>
-              <a:t>Late or erroneous filings result in unnecessary surcharges and audit friction.</a:t>
-            </a:r>
-          </a:p>
-        </p:txBody>
-      </p:sp>
-      <p:sp>
-        <p:nvSpPr>
-          <p:cNvPr id="9" name="Rounded Rectangle 8"/>
+              <a:t>Late or erroneous filings lead to surcharges, statutory interest, and unnecessary audit friction.</a:t>
+            </a:r>
+          </a:p>
+        </p:txBody>
+      </p:sp>
+      <p:sp>
+        <p:nvSpPr>
+          <p:cNvPr id="11" name="Rounded Rectangle 10"/>
           <p:cNvSpPr/>
           <p:nvPr/>
         </p:nvSpPr>
         <p:spPr>
           <a:xfrm>
-            <a:off x="8119872" y="1691640"/>
-            <a:ext cx="3328416" cy="4434840"/>
+            <a:off x="4425696" y="1691640"/>
+            <a:ext cx="3328416" cy="73152"/>
           </a:xfrm>
           <a:prstGeom prst="roundRect">
             <a:avLst/>
           </a:prstGeom>
           <a:solidFill>
-            <a:srgbClr val="FFFFFF"/>
+            <a:srgbClr val="7C3AED"/>
           </a:solidFill>
-          <a:ln w="19050">
+          <a:ln>
+            <a:noFill/>
+          </a:ln>
+        </p:spPr>
+        <p:style>
+          <a:lnRef idx="1">
+            <a:schemeClr val="accent1"/>
+          </a:lnRef>
+          <a:fillRef idx="3">
+            <a:schemeClr val="accent1"/>
+          </a:fillRef>
+          <a:effectRef idx="2">
+            <a:schemeClr val="accent1"/>
+          </a:effectRef>
+          <a:fontRef idx="minor">
+            <a:schemeClr val="lt1"/>
+          </a:fontRef>
+        </p:style>
+        <p:txBody>
+          <a:bodyPr rtlCol="0" anchor="ctr"/>
+          <a:lstStyle/>
+          <a:p>
+            <a:pPr algn="ctr"/>
+          </a:p>
+        </p:txBody>
+      </p:sp>
+      <p:sp>
+        <p:nvSpPr>
+          <p:cNvPr id="12" name="Rounded Rectangle 11"/>
+          <p:cNvSpPr/>
+          <p:nvPr/>
+        </p:nvSpPr>
+        <p:spPr>
+          <a:xfrm>
+            <a:off x="8119872" y="1691640"/>
+            <a:ext cx="3328416" cy="3977639"/>
+          </a:xfrm>
+          <a:prstGeom prst="roundRect">
+            <a:avLst/>
+          </a:prstGeom>
+          <a:solidFill>
+            <a:srgbClr val="F8FAFC"/>
+          </a:solidFill>
+          <a:ln w="15240">
             <a:solidFill>
-              <a:srgbClr val="0284C7"/>
+              <a:srgbClr val="E2E8F0"/>
             </a:solidFill>
           </a:ln>
         </p:spPr>
@@ -5058,14 +5362,14 @@
           </a:fontRef>
         </p:style>
         <p:txBody>
-          <a:bodyPr rtlCol="0" anchor="ctr" wrap="square" lIns="274320" rIns="274320" tIns="274320"/>
+          <a:bodyPr rtlCol="0" anchor="ctr" wrap="square" lIns="274320" rIns="274320" tIns="228600"/>
           <a:lstStyle/>
           <a:p>
             <a:pPr algn="ctr">
               <a:spcAft>
                 <a:spcPts val="1200"/>
               </a:spcAft>
-              <a:defRPr sz="1400" b="1">
+              <a:defRPr sz="1350" b="1">
                 <a:solidFill>
                   <a:srgbClr val="0284C7"/>
                 </a:solidFill>
@@ -5083,7 +5387,7 @@
               </a:spcAft>
               <a:defRPr sz="1050" b="1">
                 <a:solidFill>
-                  <a:srgbClr val="0F172A"/>
+                  <a:srgbClr val="1E293B"/>
                 </a:solidFill>
                 <a:latin typeface="Segoe UI"/>
               </a:defRPr>
@@ -5092,13 +5396,13 @@
               <a:t>• System of Intelligence: </a:t>
             </a:r>
             <a:r>
-              <a:rPr sz="1000" b="0">
-                <a:solidFill>
-                  <a:srgbClr val="334155"/>
+              <a:rPr sz="950" b="0">
+                <a:solidFill>
+                  <a:srgbClr val="475569"/>
                 </a:solidFill>
                 <a:latin typeface="Segoe UI"/>
               </a:rPr>
-              <a:t>Elevating D365 to analyze, pre-validate, and predict issues before transactions post.</a:t>
+              <a:t>Elevates D365 to analyze, pre-validate, and predict discrepancies before journal entries are posted.</a:t>
             </a:r>
           </a:p>
           <a:p>
@@ -5108,7 +5412,7 @@
               </a:spcAft>
               <a:defRPr sz="1050" b="1">
                 <a:solidFill>
-                  <a:srgbClr val="0F172A"/>
+                  <a:srgbClr val="1E293B"/>
                 </a:solidFill>
                 <a:latin typeface="Segoe UI"/>
               </a:defRPr>
@@ -5117,13 +5421,13 @@
               <a:t>• Human-in-the-Loop: </a:t>
             </a:r>
             <a:r>
-              <a:rPr sz="1000" b="0">
-                <a:solidFill>
-                  <a:srgbClr val="334155"/>
+              <a:rPr sz="950" b="0">
+                <a:solidFill>
+                  <a:srgbClr val="475569"/>
                 </a:solidFill>
                 <a:latin typeface="Segoe UI"/>
               </a:rPr>
-              <a:t>AI prepares validated drafts; accountants retain full approval authority.</a:t>
+              <a:t>AI prepares validated drafts; finance professionals retain exclusive approval authority.</a:t>
             </a:r>
           </a:p>
           <a:p>
@@ -5133,7 +5437,7 @@
               </a:spcAft>
               <a:defRPr sz="1050" b="1">
                 <a:solidFill>
-                  <a:srgbClr val="0F172A"/>
+                  <a:srgbClr val="1E293B"/>
                 </a:solidFill>
                 <a:latin typeface="Segoe UI"/>
               </a:defRPr>
@@ -5142,13 +5446,111 @@
               <a:t>• Market Leadership: </a:t>
             </a:r>
             <a:r>
-              <a:rPr sz="1000" b="0">
-                <a:solidFill>
-                  <a:srgbClr val="334155"/>
+              <a:rPr sz="950" b="0">
+                <a:solidFill>
+                  <a:srgbClr val="475569"/>
                 </a:solidFill>
                 <a:latin typeface="Segoe UI"/>
               </a:rPr>
-              <a:t>FTH delivers modern AI innovation that traditional competitors in Thailand cannot match.</a:t>
+              <a:t>FTH delivers modern AI innovation that traditional ERP consulting competitors in Thailand cannot match.</a:t>
+            </a:r>
+          </a:p>
+        </p:txBody>
+      </p:sp>
+      <p:sp>
+        <p:nvSpPr>
+          <p:cNvPr id="13" name="Rounded Rectangle 12"/>
+          <p:cNvSpPr/>
+          <p:nvPr/>
+        </p:nvSpPr>
+        <p:spPr>
+          <a:xfrm>
+            <a:off x="8119872" y="1691640"/>
+            <a:ext cx="3328416" cy="73152"/>
+          </a:xfrm>
+          <a:prstGeom prst="roundRect">
+            <a:avLst/>
+          </a:prstGeom>
+          <a:solidFill>
+            <a:srgbClr val="0284C7"/>
+          </a:solidFill>
+          <a:ln>
+            <a:noFill/>
+          </a:ln>
+        </p:spPr>
+        <p:style>
+          <a:lnRef idx="1">
+            <a:schemeClr val="accent1"/>
+          </a:lnRef>
+          <a:fillRef idx="3">
+            <a:schemeClr val="accent1"/>
+          </a:fillRef>
+          <a:effectRef idx="2">
+            <a:schemeClr val="accent1"/>
+          </a:effectRef>
+          <a:fontRef idx="minor">
+            <a:schemeClr val="lt1"/>
+          </a:fontRef>
+        </p:style>
+        <p:txBody>
+          <a:bodyPr rtlCol="0" anchor="ctr"/>
+          <a:lstStyle/>
+          <a:p>
+            <a:pPr algn="ctr"/>
+          </a:p>
+        </p:txBody>
+      </p:sp>
+      <p:sp>
+        <p:nvSpPr>
+          <p:cNvPr id="14" name="Rounded Rectangle 13"/>
+          <p:cNvSpPr/>
+          <p:nvPr/>
+        </p:nvSpPr>
+        <p:spPr>
+          <a:xfrm>
+            <a:off x="731520" y="5806440"/>
+            <a:ext cx="10728655" cy="475488"/>
+          </a:xfrm>
+          <a:prstGeom prst="roundRect">
+            <a:avLst/>
+          </a:prstGeom>
+          <a:solidFill>
+            <a:srgbClr val="F1F5F9"/>
+          </a:solidFill>
+          <a:ln w="12700">
+            <a:solidFill>
+              <a:srgbClr val="E2E8F0"/>
+            </a:solidFill>
+          </a:ln>
+        </p:spPr>
+        <p:style>
+          <a:lnRef idx="1">
+            <a:schemeClr val="accent1"/>
+          </a:lnRef>
+          <a:fillRef idx="3">
+            <a:schemeClr val="accent1"/>
+          </a:fillRef>
+          <a:effectRef idx="2">
+            <a:schemeClr val="accent1"/>
+          </a:effectRef>
+          <a:fontRef idx="minor">
+            <a:schemeClr val="lt1"/>
+          </a:fontRef>
+        </p:style>
+        <p:txBody>
+          <a:bodyPr rtlCol="0" anchor="ctr" wrap="square" tIns="109728"/>
+          <a:lstStyle/>
+          <a:p>
+            <a:pPr algn="ctr">
+              <a:defRPr sz="1000" b="1">
+                <a:solidFill>
+                  <a:srgbClr val="1E3A8A"/>
+                </a:solidFill>
+                <a:latin typeface="Segoe UI"/>
+              </a:defRPr>
+            </a:pPr>
+            <a:r>
+              <a:t>💡 Executive Takeaway: Evolving ERP from passive data recording into proactive, AI-assisted financial governance.</a:t>
             </a:r>
           </a:p>
         </p:txBody>
@@ -5186,7 +5588,7 @@
             <a:avLst/>
           </a:prstGeom>
           <a:solidFill>
-            <a:srgbClr val="F8FAFC"/>
+            <a:srgbClr val="FFFFFF"/>
           </a:solidFill>
           <a:ln>
             <a:noFill/>
@@ -5273,7 +5675,7 @@
         </p:blipFill>
         <p:spPr>
           <a:xfrm>
-            <a:off x="10424160" y="365760"/>
+            <a:off x="10378440" y="320040"/>
             <a:ext cx="1280160" cy="676448"/>
           </a:xfrm>
           <a:prstGeom prst="rect">
@@ -5290,7 +5692,7 @@
         <p:spPr>
           <a:xfrm>
             <a:off x="731520" y="320040"/>
-            <a:ext cx="9326880" cy="1188720"/>
+            <a:ext cx="9418320" cy="1097280"/>
           </a:xfrm>
           <a:prstGeom prst="rect">
             <a:avLst/>
@@ -5305,9 +5707,9 @@
           <a:p>
             <a:pPr>
               <a:spcAft>
-                <a:spcPts val="300"/>
+                <a:spcPts val="200"/>
               </a:spcAft>
-              <a:defRPr sz="1000" b="1">
+              <a:defRPr sz="950" b="1">
                 <a:solidFill>
                   <a:srgbClr val="DC2626"/>
                 </a:solidFill>
@@ -5321,7 +5723,7 @@
           <a:p>
             <a:pPr>
               <a:spcAft>
-                <a:spcPts val="300"/>
+                <a:spcPts val="200"/>
               </a:spcAft>
               <a:defRPr sz="2200" b="1">
                 <a:solidFill>
@@ -5336,29 +5738,72 @@
           </a:p>
           <a:p>
             <a:pPr>
-              <a:defRPr sz="1200">
-                <a:solidFill>
-                  <a:srgbClr val="64748B"/>
+              <a:defRPr sz="1100">
+                <a:solidFill>
+                  <a:srgbClr val="475569"/>
                 </a:solidFill>
                 <a:latin typeface="Segoe UI"/>
               </a:defRPr>
             </a:pPr>
             <a:r>
-              <a:t>A strategic technology fusion that drives mutual ROI for our clients and Fujitsu Thailand.</a:t>
-            </a:r>
-          </a:p>
-        </p:txBody>
-      </p:sp>
-      <p:sp>
-        <p:nvSpPr>
-          <p:cNvPr id="6" name="TextBox 5"/>
+              <a:t>A strategic technology fusion that drives mutual ROI for enterprise clients and Fujitsu Thailand.</a:t>
+            </a:r>
+          </a:p>
+        </p:txBody>
+      </p:sp>
+      <p:sp>
+        <p:nvSpPr>
+          <p:cNvPr id="6" name="Rectangle 5"/>
+          <p:cNvSpPr/>
+          <p:nvPr/>
+        </p:nvSpPr>
+        <p:spPr>
+          <a:xfrm>
+            <a:off x="731520" y="1508760"/>
+            <a:ext cx="10728655" cy="13716"/>
+          </a:xfrm>
+          <a:prstGeom prst="rect">
+            <a:avLst/>
+          </a:prstGeom>
+          <a:solidFill>
+            <a:srgbClr val="E2E8F0"/>
+          </a:solidFill>
+          <a:ln>
+            <a:noFill/>
+          </a:ln>
+        </p:spPr>
+        <p:style>
+          <a:lnRef idx="1">
+            <a:schemeClr val="accent1"/>
+          </a:lnRef>
+          <a:fillRef idx="3">
+            <a:schemeClr val="accent1"/>
+          </a:fillRef>
+          <a:effectRef idx="2">
+            <a:schemeClr val="accent1"/>
+          </a:effectRef>
+          <a:fontRef idx="minor">
+            <a:schemeClr val="lt1"/>
+          </a:fontRef>
+        </p:style>
+        <p:txBody>
+          <a:bodyPr rtlCol="0" anchor="ctr"/>
+          <a:lstStyle/>
+          <a:p>
+            <a:pPr algn="ctr"/>
+          </a:p>
+        </p:txBody>
+      </p:sp>
+      <p:sp>
+        <p:nvSpPr>
+          <p:cNvPr id="7" name="TextBox 6"/>
           <p:cNvSpPr txBox="1"/>
           <p:nvPr/>
         </p:nvSpPr>
         <p:spPr>
           <a:xfrm>
-            <a:off x="731520" y="6400800"/>
-            <a:ext cx="10698480" cy="320040"/>
+            <a:off x="731520" y="6446520"/>
+            <a:ext cx="10728655" cy="274320"/>
           </a:xfrm>
           <a:prstGeom prst="rect">
             <a:avLst/>
@@ -5372,9 +5817,9 @@
           <a:lstStyle/>
           <a:p>
             <a:pPr>
-              <a:defRPr sz="900" b="1">
-                <a:solidFill>
-                  <a:srgbClr val="64748B"/>
+              <a:defRPr sz="850" b="1">
+                <a:solidFill>
+                  <a:srgbClr val="94A3B8"/>
                 </a:solidFill>
                 <a:latin typeface="Segoe UI"/>
               </a:defRPr>
@@ -5387,24 +5832,24 @@
       </p:sp>
       <p:sp>
         <p:nvSpPr>
-          <p:cNvPr id="7" name="Rounded Rectangle 6"/>
+          <p:cNvPr id="8" name="Rounded Rectangle 7"/>
           <p:cNvSpPr/>
           <p:nvPr/>
         </p:nvSpPr>
         <p:spPr>
           <a:xfrm>
             <a:off x="731520" y="1691640"/>
-            <a:ext cx="5175504" cy="4434840"/>
+            <a:ext cx="5175504" cy="3977639"/>
           </a:xfrm>
           <a:prstGeom prst="roundRect">
             <a:avLst/>
           </a:prstGeom>
           <a:solidFill>
-            <a:srgbClr val="FFFFFF"/>
+            <a:srgbClr val="F8FAFC"/>
           </a:solidFill>
-          <a:ln w="19050">
+          <a:ln w="15240">
             <a:solidFill>
-              <a:srgbClr val="0284C7"/>
+              <a:srgbClr val="E2E8F0"/>
             </a:solidFill>
           </a:ln>
         </p:spPr>
@@ -5423,14 +5868,14 @@
           </a:fontRef>
         </p:style>
         <p:txBody>
-          <a:bodyPr rtlCol="0" anchor="ctr" wrap="square" lIns="320040" rIns="320040" tIns="320040"/>
+          <a:bodyPr rtlCol="0" anchor="ctr" wrap="square" lIns="320040" rIns="320040" tIns="228600"/>
           <a:lstStyle/>
           <a:p>
             <a:pPr algn="ctr">
               <a:spcAft>
-                <a:spcPts val="1000"/>
+                <a:spcPts val="1200"/>
               </a:spcAft>
-              <a:defRPr sz="1500" b="1">
+              <a:defRPr sz="1400" b="1">
                 <a:solidFill>
                   <a:srgbClr val="0284C7"/>
                 </a:solidFill>
@@ -5438,7 +5883,7 @@
               </a:defRPr>
             </a:pPr>
             <a:r>
-              <a:t>💎 1. D365 Product Enhancement</a:t>
+              <a:t>💎 1. Dynamics 365 Product Enhancement</a:t>
             </a:r>
           </a:p>
           <a:p>
@@ -5446,9 +5891,9 @@
               <a:spcAft>
                 <a:spcPts val="700"/>
               </a:spcAft>
-              <a:defRPr sz="1100" b="1">
-                <a:solidFill>
-                  <a:srgbClr val="0F172A"/>
+              <a:defRPr sz="1050" b="1">
+                <a:solidFill>
+                  <a:srgbClr val="1E293B"/>
                 </a:solidFill>
                 <a:latin typeface="Segoe UI"/>
               </a:defRPr>
@@ -5457,13 +5902,13 @@
               <a:t>• Native Copilot Fusion: </a:t>
             </a:r>
             <a:r>
-              <a:rPr sz="1000" b="0">
-                <a:solidFill>
-                  <a:srgbClr val="334155"/>
+              <a:rPr sz="950" b="0">
+                <a:solidFill>
+                  <a:srgbClr val="475569"/>
                 </a:solidFill>
                 <a:latin typeface="Segoe UI"/>
               </a:rPr>
-              <a:t>Direct integration with Copilot Studio and Azure AI via Dataverse and standard APIs—zero external data leakage.</a:t>
+              <a:t>Direct integration with Copilot Studio and Azure AI via Microsoft Dataverse—zero external data leakage.</a:t>
             </a:r>
           </a:p>
           <a:p>
@@ -5471,9 +5916,9 @@
               <a:spcAft>
                 <a:spcPts val="700"/>
               </a:spcAft>
-              <a:defRPr sz="1100" b="1">
-                <a:solidFill>
-                  <a:srgbClr val="0F172A"/>
+              <a:defRPr sz="1050" b="1">
+                <a:solidFill>
+                  <a:srgbClr val="1E293B"/>
                 </a:solidFill>
                 <a:latin typeface="Segoe UI"/>
               </a:defRPr>
@@ -5482,13 +5927,13 @@
               <a:t>• Autonomous Draft Preparation: </a:t>
             </a:r>
             <a:r>
-              <a:rPr sz="1000" b="0">
-                <a:solidFill>
-                  <a:srgbClr val="334155"/>
+              <a:rPr sz="950" b="0">
+                <a:solidFill>
+                  <a:srgbClr val="475569"/>
                 </a:solidFill>
                 <a:latin typeface="Segoe UI"/>
               </a:rPr>
-              <a:t>AI reads documents, validates 3-way matching rules, and creates draft vendor invoices—slashing AP review time by &gt;70%.</a:t>
+              <a:t>AI extracts data, cross-checks 3-way matching rules, and pre-populates draft vendor invoices—slashing AP review time by &gt;70%.</a:t>
             </a:r>
           </a:p>
           <a:p>
@@ -5496,9 +5941,9 @@
               <a:spcAft>
                 <a:spcPts val="700"/>
               </a:spcAft>
-              <a:defRPr sz="1100" b="1">
-                <a:solidFill>
-                  <a:srgbClr val="0F172A"/>
+              <a:defRPr sz="1050" b="1">
+                <a:solidFill>
+                  <a:srgbClr val="1E293B"/>
                 </a:solidFill>
                 <a:latin typeface="Segoe UI"/>
               </a:defRPr>
@@ -5507,13 +5952,13 @@
               <a:t>• Strict Human-in-the-Loop: </a:t>
             </a:r>
             <a:r>
-              <a:rPr sz="1000" b="0">
-                <a:solidFill>
-                  <a:srgbClr val="334155"/>
+              <a:rPr sz="950" b="0">
+                <a:solidFill>
+                  <a:srgbClr val="475569"/>
                 </a:solidFill>
                 <a:latin typeface="Segoe UI"/>
               </a:rPr>
-              <a:t>AI prepares validated drafts; accountants retain exclusive approval authority before any journal posting.</a:t>
+              <a:t>AI prepares validated drafts; finance professionals retain exclusive approval authority before any journal posting.</a:t>
             </a:r>
           </a:p>
           <a:p>
@@ -5521,9 +5966,9 @@
               <a:spcAft>
                 <a:spcPts val="700"/>
               </a:spcAft>
-              <a:defRPr sz="1100" b="1">
-                <a:solidFill>
-                  <a:srgbClr val="0F172A"/>
+              <a:defRPr sz="1050" b="1">
+                <a:solidFill>
+                  <a:srgbClr val="1E293B"/>
                 </a:solidFill>
                 <a:latin typeface="Segoe UI"/>
               </a:defRPr>
@@ -5532,37 +5977,80 @@
               <a:t>• Total Thai Tax Compliance: </a:t>
             </a:r>
             <a:r>
-              <a:rPr sz="1000" b="0">
-                <a:solidFill>
-                  <a:srgbClr val="334155"/>
+              <a:rPr sz="950" b="0">
+                <a:solidFill>
+                  <a:srgbClr val="475569"/>
                 </a:solidFill>
                 <a:latin typeface="Segoe UI"/>
               </a:rPr>
-              <a:t>Full support for PP.30, PND 3/53, 50 Tawi certificates, and Revenue Dept e-Tax XML formats.</a:t>
-            </a:r>
-          </a:p>
-        </p:txBody>
-      </p:sp>
-      <p:sp>
-        <p:nvSpPr>
-          <p:cNvPr id="8" name="Rounded Rectangle 7"/>
+              <a:t>Comprehensive support for PP.30, PND 3/53, 50 Tawi certificates, and Revenue Dept e-Tax XML formats.</a:t>
+            </a:r>
+          </a:p>
+        </p:txBody>
+      </p:sp>
+      <p:sp>
+        <p:nvSpPr>
+          <p:cNvPr id="9" name="Rounded Rectangle 8"/>
           <p:cNvSpPr/>
           <p:nvPr/>
         </p:nvSpPr>
         <p:spPr>
           <a:xfrm>
-            <a:off x="6272784" y="1691640"/>
-            <a:ext cx="5175504" cy="4434840"/>
+            <a:off x="731520" y="1691640"/>
+            <a:ext cx="5175504" cy="73152"/>
           </a:xfrm>
           <a:prstGeom prst="roundRect">
             <a:avLst/>
           </a:prstGeom>
           <a:solidFill>
-            <a:srgbClr val="FFFFFF"/>
+            <a:srgbClr val="0284C7"/>
           </a:solidFill>
-          <a:ln w="19050">
+          <a:ln>
+            <a:noFill/>
+          </a:ln>
+        </p:spPr>
+        <p:style>
+          <a:lnRef idx="1">
+            <a:schemeClr val="accent1"/>
+          </a:lnRef>
+          <a:fillRef idx="3">
+            <a:schemeClr val="accent1"/>
+          </a:fillRef>
+          <a:effectRef idx="2">
+            <a:schemeClr val="accent1"/>
+          </a:effectRef>
+          <a:fontRef idx="minor">
+            <a:schemeClr val="lt1"/>
+          </a:fontRef>
+        </p:style>
+        <p:txBody>
+          <a:bodyPr rtlCol="0" anchor="ctr"/>
+          <a:lstStyle/>
+          <a:p>
+            <a:pPr algn="ctr"/>
+          </a:p>
+        </p:txBody>
+      </p:sp>
+      <p:sp>
+        <p:nvSpPr>
+          <p:cNvPr id="10" name="Rounded Rectangle 9"/>
+          <p:cNvSpPr/>
+          <p:nvPr/>
+        </p:nvSpPr>
+        <p:spPr>
+          <a:xfrm>
+            <a:off x="6272784" y="1691640"/>
+            <a:ext cx="5175504" cy="3977639"/>
+          </a:xfrm>
+          <a:prstGeom prst="roundRect">
+            <a:avLst/>
+          </a:prstGeom>
+          <a:solidFill>
+            <a:srgbClr val="F8FAFC"/>
+          </a:solidFill>
+          <a:ln w="15240">
             <a:solidFill>
-              <a:srgbClr val="DC2626"/>
+              <a:srgbClr val="E2E8F0"/>
             </a:solidFill>
           </a:ln>
         </p:spPr>
@@ -5581,14 +6069,14 @@
           </a:fontRef>
         </p:style>
         <p:txBody>
-          <a:bodyPr rtlCol="0" anchor="ctr" wrap="square" lIns="320040" rIns="320040" tIns="320040"/>
+          <a:bodyPr rtlCol="0" anchor="ctr" wrap="square" lIns="320040" rIns="320040" tIns="228600"/>
           <a:lstStyle/>
           <a:p>
             <a:pPr algn="ctr">
               <a:spcAft>
-                <a:spcPts val="1000"/>
+                <a:spcPts val="1200"/>
               </a:spcAft>
-              <a:defRPr sz="1500" b="1">
+              <a:defRPr sz="1400" b="1">
                 <a:solidFill>
                   <a:srgbClr val="DC2626"/>
                 </a:solidFill>
@@ -5596,7 +6084,7 @@
               </a:defRPr>
             </a:pPr>
             <a:r>
-              <a:t>🏆 2. Fujitsu (FTH) Strategic Value</a:t>
+              <a:t>🏆 2. Fujitsu (FTH) Enterprise Strategic Value</a:t>
             </a:r>
           </a:p>
           <a:p>
@@ -5604,24 +6092,24 @@
               <a:spcAft>
                 <a:spcPts val="700"/>
               </a:spcAft>
-              <a:defRPr sz="1100" b="1">
-                <a:solidFill>
-                  <a:srgbClr val="0F172A"/>
+              <a:defRPr sz="1050" b="1">
+                <a:solidFill>
+                  <a:srgbClr val="1E293B"/>
                 </a:solidFill>
                 <a:latin typeface="Segoe UI"/>
               </a:defRPr>
             </a:pPr>
             <a:r>
-              <a:t>• First-Mover Advantage in Thailand: </a:t>
-            </a:r>
-            <a:r>
-              <a:rPr sz="1000" b="0">
-                <a:solidFill>
-                  <a:srgbClr val="334155"/>
+              <a:t>• First-Mover Market Advantage: </a:t>
+            </a:r>
+            <a:r>
+              <a:rPr sz="950" b="0">
+                <a:solidFill>
+                  <a:srgbClr val="475569"/>
                 </a:solidFill>
                 <a:latin typeface="Segoe UI"/>
               </a:rPr>
-              <a:t>FTH becomes the first partner offering a pre-packaged, AI-infused Thai Localization solution, creating a strong moat.</a:t>
+              <a:t>FTH becomes the first enterprise partner offering a pre-packaged, AI-infused Thai Localization solution, creating a decisive competitive moat.</a:t>
             </a:r>
           </a:p>
           <a:p>
@@ -5629,9 +6117,9 @@
               <a:spcAft>
                 <a:spcPts val="700"/>
               </a:spcAft>
-              <a:defRPr sz="1100" b="1">
-                <a:solidFill>
-                  <a:srgbClr val="0F172A"/>
+              <a:defRPr sz="1050" b="1">
+                <a:solidFill>
+                  <a:srgbClr val="1E293B"/>
                 </a:solidFill>
                 <a:latin typeface="Segoe UI"/>
               </a:defRPr>
@@ -5640,13 +6128,13 @@
               <a:t>• High-Margin Reusable IP Asset: </a:t>
             </a:r>
             <a:r>
-              <a:rPr sz="1000" b="0">
-                <a:solidFill>
-                  <a:srgbClr val="334155"/>
+              <a:rPr sz="950" b="0">
+                <a:solidFill>
+                  <a:srgbClr val="475569"/>
                 </a:solidFill>
                 <a:latin typeface="Segoe UI"/>
               </a:rPr>
-              <a:t>Packaged as commercial IP, enabling rapid deployment across enterprise clients with lower implementation costs.</a:t>
+              <a:t>Packaged as commercial IP, enabling rapid, repeatable deployment across enterprise clients with lower implementation overhead.</a:t>
             </a:r>
           </a:p>
           <a:p>
@@ -5654,24 +6142,24 @@
               <a:spcAft>
                 <a:spcPts val="700"/>
               </a:spcAft>
-              <a:defRPr sz="1100" b="1">
-                <a:solidFill>
-                  <a:srgbClr val="0F172A"/>
+              <a:defRPr sz="1050" b="1">
+                <a:solidFill>
+                  <a:srgbClr val="1E293B"/>
                 </a:solidFill>
                 <a:latin typeface="Segoe UI"/>
               </a:defRPr>
             </a:pPr>
             <a:r>
-              <a:t>• Expands Japanese MNC &amp; Enterprise Footprint: </a:t>
-            </a:r>
-            <a:r>
-              <a:rPr sz="1000" b="0">
-                <a:solidFill>
-                  <a:srgbClr val="334155"/>
+              <a:t>• Expands Japanese MNC &amp; Corporate Footprint: </a:t>
+            </a:r>
+            <a:r>
+              <a:rPr sz="950" b="0">
+                <a:solidFill>
+                  <a:srgbClr val="475569"/>
                 </a:solidFill>
                 <a:latin typeface="Segoe UI"/>
               </a:rPr>
-              <a:t>Tailored to Japanese MNCs and major Thai conglomerates seeking modern, compliant ERP modernization.</a:t>
+              <a:t>Directly tailored to Japanese multinationals and major Thai conglomerates seeking modern, fully compliant ERP solutions.</a:t>
             </a:r>
           </a:p>
           <a:p>
@@ -5679,9 +6167,9 @@
               <a:spcAft>
                 <a:spcPts val="700"/>
               </a:spcAft>
-              <a:defRPr sz="1100" b="1">
-                <a:solidFill>
-                  <a:srgbClr val="0F172A"/>
+              <a:defRPr sz="1050" b="1">
+                <a:solidFill>
+                  <a:srgbClr val="1E293B"/>
                 </a:solidFill>
                 <a:latin typeface="Segoe UI"/>
               </a:defRPr>
@@ -5690,13 +6178,111 @@
               <a:t>• Reinforces Global Trusted Partner Brand: </a:t>
             </a:r>
             <a:r>
-              <a:rPr sz="1000" b="0">
-                <a:solidFill>
-                  <a:srgbClr val="334155"/>
+              <a:rPr sz="950" b="0">
+                <a:solidFill>
+                  <a:srgbClr val="475569"/>
                 </a:solidFill>
                 <a:latin typeface="Segoe UI"/>
               </a:rPr>
-              <a:t>Combines Fujitsu’s renowned Japanese quality and governance standards with Microsoft’s premier AI technology.</a:t>
+              <a:t>Combines Fujitsu’s renowned Japanese quality and governance standards with Microsoft’s premier enterprise AI platform.</a:t>
+            </a:r>
+          </a:p>
+        </p:txBody>
+      </p:sp>
+      <p:sp>
+        <p:nvSpPr>
+          <p:cNvPr id="11" name="Rounded Rectangle 10"/>
+          <p:cNvSpPr/>
+          <p:nvPr/>
+        </p:nvSpPr>
+        <p:spPr>
+          <a:xfrm>
+            <a:off x="6272784" y="1691640"/>
+            <a:ext cx="5175504" cy="73152"/>
+          </a:xfrm>
+          <a:prstGeom prst="roundRect">
+            <a:avLst/>
+          </a:prstGeom>
+          <a:solidFill>
+            <a:srgbClr val="DC2626"/>
+          </a:solidFill>
+          <a:ln>
+            <a:noFill/>
+          </a:ln>
+        </p:spPr>
+        <p:style>
+          <a:lnRef idx="1">
+            <a:schemeClr val="accent1"/>
+          </a:lnRef>
+          <a:fillRef idx="3">
+            <a:schemeClr val="accent1"/>
+          </a:fillRef>
+          <a:effectRef idx="2">
+            <a:schemeClr val="accent1"/>
+          </a:effectRef>
+          <a:fontRef idx="minor">
+            <a:schemeClr val="lt1"/>
+          </a:fontRef>
+        </p:style>
+        <p:txBody>
+          <a:bodyPr rtlCol="0" anchor="ctr"/>
+          <a:lstStyle/>
+          <a:p>
+            <a:pPr algn="ctr"/>
+          </a:p>
+        </p:txBody>
+      </p:sp>
+      <p:sp>
+        <p:nvSpPr>
+          <p:cNvPr id="12" name="Rounded Rectangle 11"/>
+          <p:cNvSpPr/>
+          <p:nvPr/>
+        </p:nvSpPr>
+        <p:spPr>
+          <a:xfrm>
+            <a:off x="731520" y="5806440"/>
+            <a:ext cx="10728655" cy="475488"/>
+          </a:xfrm>
+          <a:prstGeom prst="roundRect">
+            <a:avLst/>
+          </a:prstGeom>
+          <a:solidFill>
+            <a:srgbClr val="F1F5F9"/>
+          </a:solidFill>
+          <a:ln w="12700">
+            <a:solidFill>
+              <a:srgbClr val="E2E8F0"/>
+            </a:solidFill>
+          </a:ln>
+        </p:spPr>
+        <p:style>
+          <a:lnRef idx="1">
+            <a:schemeClr val="accent1"/>
+          </a:lnRef>
+          <a:fillRef idx="3">
+            <a:schemeClr val="accent1"/>
+          </a:fillRef>
+          <a:effectRef idx="2">
+            <a:schemeClr val="accent1"/>
+          </a:effectRef>
+          <a:fontRef idx="minor">
+            <a:schemeClr val="lt1"/>
+          </a:fontRef>
+        </p:style>
+        <p:txBody>
+          <a:bodyPr rtlCol="0" anchor="ctr" wrap="square" tIns="109728"/>
+          <a:lstStyle/>
+          <a:p>
+            <a:pPr algn="ctr">
+              <a:defRPr sz="950" b="1">
+                <a:solidFill>
+                  <a:srgbClr val="059669"/>
+                </a:solidFill>
+                <a:latin typeface="Segoe UI"/>
+              </a:defRPr>
+            </a:pPr>
+            <a:r>
+              <a:t>🎯 Strategic Impact: Transitioning from bespoke custom implementation to leading the market with proprietary Intellectual Property.  ✓ High Margin  ✓ Scalable  ✓ Repeatable</a:t>
             </a:r>
           </a:p>
         </p:txBody>
@@ -5734,7 +6320,7 @@
             <a:avLst/>
           </a:prstGeom>
           <a:solidFill>
-            <a:srgbClr val="F8FAFC"/>
+            <a:srgbClr val="FFFFFF"/>
           </a:solidFill>
           <a:ln>
             <a:noFill/>
@@ -5821,7 +6407,7 @@
         </p:blipFill>
         <p:spPr>
           <a:xfrm>
-            <a:off x="10424160" y="365760"/>
+            <a:off x="10378440" y="320040"/>
             <a:ext cx="1280160" cy="676448"/>
           </a:xfrm>
           <a:prstGeom prst="rect">
@@ -5838,7 +6424,7 @@
         <p:spPr>
           <a:xfrm>
             <a:off x="731520" y="320040"/>
-            <a:ext cx="9326880" cy="1188720"/>
+            <a:ext cx="9418320" cy="1097280"/>
           </a:xfrm>
           <a:prstGeom prst="rect">
             <a:avLst/>
@@ -5853,9 +6439,9 @@
           <a:p>
             <a:pPr>
               <a:spcAft>
-                <a:spcPts val="300"/>
+                <a:spcPts val="200"/>
               </a:spcAft>
-              <a:defRPr sz="1000" b="1">
+              <a:defRPr sz="950" b="1">
                 <a:solidFill>
                   <a:srgbClr val="DC2626"/>
                 </a:solidFill>
@@ -5869,7 +6455,7 @@
           <a:p>
             <a:pPr>
               <a:spcAft>
-                <a:spcPts val="300"/>
+                <a:spcPts val="200"/>
               </a:spcAft>
               <a:defRPr sz="2200" b="1">
                 <a:solidFill>
@@ -5884,9 +6470,9 @@
           </a:p>
           <a:p>
             <a:pPr>
-              <a:defRPr sz="1200">
-                <a:solidFill>
-                  <a:srgbClr val="64748B"/>
+              <a:defRPr sz="1100">
+                <a:solidFill>
+                  <a:srgbClr val="475569"/>
                 </a:solidFill>
                 <a:latin typeface="Segoe UI"/>
               </a:defRPr>
@@ -5899,14 +6485,57 @@
       </p:sp>
       <p:sp>
         <p:nvSpPr>
-          <p:cNvPr id="6" name="TextBox 5"/>
+          <p:cNvPr id="6" name="Rectangle 5"/>
+          <p:cNvSpPr/>
+          <p:nvPr/>
+        </p:nvSpPr>
+        <p:spPr>
+          <a:xfrm>
+            <a:off x="731520" y="1508760"/>
+            <a:ext cx="10728655" cy="13716"/>
+          </a:xfrm>
+          <a:prstGeom prst="rect">
+            <a:avLst/>
+          </a:prstGeom>
+          <a:solidFill>
+            <a:srgbClr val="E2E8F0"/>
+          </a:solidFill>
+          <a:ln>
+            <a:noFill/>
+          </a:ln>
+        </p:spPr>
+        <p:style>
+          <a:lnRef idx="1">
+            <a:schemeClr val="accent1"/>
+          </a:lnRef>
+          <a:fillRef idx="3">
+            <a:schemeClr val="accent1"/>
+          </a:fillRef>
+          <a:effectRef idx="2">
+            <a:schemeClr val="accent1"/>
+          </a:effectRef>
+          <a:fontRef idx="minor">
+            <a:schemeClr val="lt1"/>
+          </a:fontRef>
+        </p:style>
+        <p:txBody>
+          <a:bodyPr rtlCol="0" anchor="ctr"/>
+          <a:lstStyle/>
+          <a:p>
+            <a:pPr algn="ctr"/>
+          </a:p>
+        </p:txBody>
+      </p:sp>
+      <p:sp>
+        <p:nvSpPr>
+          <p:cNvPr id="7" name="TextBox 6"/>
           <p:cNvSpPr txBox="1"/>
           <p:nvPr/>
         </p:nvSpPr>
         <p:spPr>
           <a:xfrm>
-            <a:off x="731520" y="6400800"/>
-            <a:ext cx="10698480" cy="320040"/>
+            <a:off x="731520" y="6446520"/>
+            <a:ext cx="10728655" cy="274320"/>
           </a:xfrm>
           <a:prstGeom prst="rect">
             <a:avLst/>
@@ -5920,9 +6549,9 @@
           <a:lstStyle/>
           <a:p>
             <a:pPr>
-              <a:defRPr sz="900" b="1">
-                <a:solidFill>
-                  <a:srgbClr val="64748B"/>
+              <a:defRPr sz="850" b="1">
+                <a:solidFill>
+                  <a:srgbClr val="94A3B8"/>
                 </a:solidFill>
                 <a:latin typeface="Segoe UI"/>
               </a:defRPr>
@@ -5935,22 +6564,22 @@
       </p:sp>
       <p:sp>
         <p:nvSpPr>
-          <p:cNvPr id="7" name="Rounded Rectangle 6"/>
+          <p:cNvPr id="8" name="Rounded Rectangle 7"/>
           <p:cNvSpPr/>
           <p:nvPr/>
         </p:nvSpPr>
         <p:spPr>
           <a:xfrm>
             <a:off x="731520" y="1691640"/>
-            <a:ext cx="6217920" cy="4434840"/>
+            <a:ext cx="6217920" cy="3977639"/>
           </a:xfrm>
           <a:prstGeom prst="roundRect">
             <a:avLst/>
           </a:prstGeom>
           <a:solidFill>
-            <a:srgbClr val="FFFFFF"/>
+            <a:srgbClr val="F8FAFC"/>
           </a:solidFill>
-          <a:ln w="19050">
+          <a:ln w="15240">
             <a:solidFill>
               <a:srgbClr val="E2E8F0"/>
             </a:solidFill>
@@ -5971,16 +6600,16 @@
           </a:fontRef>
         </p:style>
         <p:txBody>
-          <a:bodyPr rtlCol="0" anchor="ctr" wrap="square" lIns="320040" rIns="320040" tIns="320040"/>
+          <a:bodyPr rtlCol="0" anchor="ctr" wrap="square" lIns="320040" rIns="320040" tIns="228600"/>
           <a:lstStyle/>
           <a:p>
             <a:pPr algn="ctr">
               <a:spcAft>
-                <a:spcPts val="1000"/>
+                <a:spcPts val="1200"/>
               </a:spcAft>
-              <a:defRPr sz="1500" b="1">
-                <a:solidFill>
-                  <a:srgbClr val="0284C7"/>
+              <a:defRPr sz="1400" b="1">
+                <a:solidFill>
+                  <a:srgbClr val="1E3A8A"/>
                 </a:solidFill>
                 <a:latin typeface="Segoe UI"/>
               </a:defRPr>
@@ -5994,20 +6623,20 @@
               <a:spcAft>
                 <a:spcPts val="800"/>
               </a:spcAft>
-              <a:defRPr sz="1100" b="1">
-                <a:solidFill>
-                  <a:srgbClr val="0F172A"/>
+              <a:defRPr sz="1050" b="1">
+                <a:solidFill>
+                  <a:srgbClr val="1E293B"/>
                 </a:solidFill>
                 <a:latin typeface="Segoe UI"/>
               </a:defRPr>
             </a:pPr>
             <a:r>
-              <a:t>• 1. Official Architecture: </a:t>
-            </a:r>
-            <a:r>
-              <a:rPr sz="1000" b="0">
-                <a:solidFill>
-                  <a:srgbClr val="334155"/>
+              <a:t>• 1. Official Copilot Architecture (Slide 3): </a:t>
+            </a:r>
+            <a:r>
+              <a:rPr sz="950" b="0">
+                <a:solidFill>
+                  <a:srgbClr val="475569"/>
                 </a:solidFill>
                 <a:latin typeface="Segoe UI"/>
               </a:rPr>
@@ -6019,24 +6648,24 @@
               <a:spcAft>
                 <a:spcPts val="800"/>
               </a:spcAft>
-              <a:defRPr sz="1100" b="1">
-                <a:solidFill>
-                  <a:srgbClr val="0F172A"/>
+              <a:defRPr sz="1050" b="1">
+                <a:solidFill>
+                  <a:srgbClr val="1E293B"/>
                 </a:solidFill>
                 <a:latin typeface="Segoe UI"/>
               </a:defRPr>
             </a:pPr>
             <a:r>
-              <a:t>• 2. Top 5 Thai Use Cases: </a:t>
-            </a:r>
-            <a:r>
-              <a:rPr sz="1000" b="0">
-                <a:solidFill>
-                  <a:srgbClr val="334155"/>
+              <a:t>• 2. Top 5 Thai Localization Use Cases (Slide 4): </a:t>
+            </a:r>
+            <a:r>
+              <a:rPr sz="950" b="0">
+                <a:solidFill>
+                  <a:srgbClr val="475569"/>
                 </a:solidFill>
                 <a:latin typeface="Segoe UI"/>
               </a:rPr>
-              <a:t>Live walkthrough: AP Invoice Intelligence, Thai Tax Copilot, e-Tax Gateway, and Continuous Reconciliation.</a:t>
+              <a:t>Live walkthrough: AP Invoice Intelligence, Thai Tax Copilot, e-Tax Gateway, Continuous Reconciliation, and Policy Q&amp;A.</a:t>
             </a:r>
           </a:p>
           <a:p>
@@ -6044,24 +6673,24 @@
               <a:spcAft>
                 <a:spcPts val="800"/>
               </a:spcAft>
-              <a:defRPr sz="1100" b="1">
-                <a:solidFill>
-                  <a:srgbClr val="0F172A"/>
+              <a:defRPr sz="1050" b="1">
+                <a:solidFill>
+                  <a:srgbClr val="1E293B"/>
                 </a:solidFill>
                 <a:latin typeface="Segoe UI"/>
               </a:defRPr>
             </a:pPr>
             <a:r>
-              <a:t>• 3. 8-Week POC Delivery Plan: </a:t>
-            </a:r>
-            <a:r>
-              <a:rPr sz="1000" b="0">
-                <a:solidFill>
-                  <a:srgbClr val="334155"/>
+              <a:t>• 3. 8-Week POC Delivery Plan (Slides 10–11): </a:t>
+            </a:r>
+            <a:r>
+              <a:rPr sz="950" b="0">
+                <a:solidFill>
+                  <a:srgbClr val="475569"/>
                 </a:solidFill>
                 <a:latin typeface="Segoe UI"/>
               </a:rPr>
-              <a:t>Pragmatic, low-risk deployment roadmap delivering fast measurable value and fast payback.</a:t>
+              <a:t>Pragmatic, low-risk deployment roadmap delivering fast measurable value and rapid payback.</a:t>
             </a:r>
           </a:p>
           <a:p>
@@ -6069,44 +6698,87 @@
               <a:spcAft>
                 <a:spcPts val="800"/>
               </a:spcAft>
-              <a:defRPr sz="1100" b="1">
-                <a:solidFill>
-                  <a:srgbClr val="0F172A"/>
+              <a:defRPr sz="1050" b="1">
+                <a:solidFill>
+                  <a:srgbClr val="1E293B"/>
                 </a:solidFill>
                 <a:latin typeface="Segoe UI"/>
               </a:defRPr>
             </a:pPr>
             <a:r>
-              <a:t>• 4. Dual-Host AI Narration: </a:t>
-            </a:r>
-            <a:r>
-              <a:rPr sz="1000" b="0">
-                <a:solidFill>
-                  <a:srgbClr val="334155"/>
+              <a:t>• 4. Dual-Host AI Narration &amp; Auto-Tour: </a:t>
+            </a:r>
+            <a:r>
+              <a:rPr sz="950" b="0">
+                <a:solidFill>
+                  <a:srgbClr val="475569"/>
                 </a:solidFill>
                 <a:latin typeface="Segoe UI"/>
               </a:rPr>
-              <a:t>Production neural studio voice in English &amp; Thai with automated auto-tour mode.</a:t>
-            </a:r>
-          </a:p>
-        </p:txBody>
-      </p:sp>
-      <p:sp>
-        <p:nvSpPr>
-          <p:cNvPr id="8" name="Rounded Rectangle 7"/>
+              <a:t>Production neural studio voice in English &amp; Thai with automated slide tour capabilities.</a:t>
+            </a:r>
+          </a:p>
+        </p:txBody>
+      </p:sp>
+      <p:sp>
+        <p:nvSpPr>
+          <p:cNvPr id="9" name="Rounded Rectangle 8"/>
           <p:cNvSpPr/>
           <p:nvPr/>
         </p:nvSpPr>
         <p:spPr>
           <a:xfrm>
-            <a:off x="7315200" y="1691640"/>
-            <a:ext cx="4144975" cy="4434840"/>
+            <a:off x="731520" y="1691640"/>
+            <a:ext cx="6217920" cy="73152"/>
           </a:xfrm>
           <a:prstGeom prst="roundRect">
             <a:avLst/>
           </a:prstGeom>
           <a:solidFill>
-            <a:srgbClr val="FFFFFF"/>
+            <a:srgbClr val="0284C7"/>
+          </a:solidFill>
+          <a:ln>
+            <a:noFill/>
+          </a:ln>
+        </p:spPr>
+        <p:style>
+          <a:lnRef idx="1">
+            <a:schemeClr val="accent1"/>
+          </a:lnRef>
+          <a:fillRef idx="3">
+            <a:schemeClr val="accent1"/>
+          </a:fillRef>
+          <a:effectRef idx="2">
+            <a:schemeClr val="accent1"/>
+          </a:effectRef>
+          <a:fontRef idx="minor">
+            <a:schemeClr val="lt1"/>
+          </a:fontRef>
+        </p:style>
+        <p:txBody>
+          <a:bodyPr rtlCol="0" anchor="ctr"/>
+          <a:lstStyle/>
+          <a:p>
+            <a:pPr algn="ctr"/>
+          </a:p>
+        </p:txBody>
+      </p:sp>
+      <p:sp>
+        <p:nvSpPr>
+          <p:cNvPr id="10" name="Rounded Rectangle 9"/>
+          <p:cNvSpPr/>
+          <p:nvPr/>
+        </p:nvSpPr>
+        <p:spPr>
+          <a:xfrm>
+            <a:off x="7315200" y="1691640"/>
+            <a:ext cx="4144975" cy="3977639"/>
+          </a:xfrm>
+          <a:prstGeom prst="roundRect">
+            <a:avLst/>
+          </a:prstGeom>
+          <a:solidFill>
+            <a:srgbClr val="ECFDF5"/>
           </a:solidFill>
           <a:ln w="19050">
             <a:solidFill>
@@ -6129,7 +6801,7 @@
           </a:fontRef>
         </p:style>
         <p:txBody>
-          <a:bodyPr rtlCol="0" anchor="ctr" wrap="square" lIns="320040" rIns="320040" tIns="320040"/>
+          <a:bodyPr rtlCol="0" anchor="ctr" wrap="square" lIns="320040" rIns="320040" tIns="274320"/>
           <a:lstStyle/>
           <a:p>
             <a:pPr algn="ctr">
@@ -6150,25 +6822,25 @@
           <a:p>
             <a:pPr>
               <a:spcAft>
-                <a:spcPts val="1600"/>
+                <a:spcPts val="1400"/>
               </a:spcAft>
-              <a:defRPr sz="1100" i="1">
-                <a:solidFill>
-                  <a:srgbClr val="334155"/>
+              <a:defRPr sz="1050" i="1">
+                <a:solidFill>
+                  <a:srgbClr val="1E293B"/>
                 </a:solidFill>
                 <a:latin typeface="Segoe UI"/>
               </a:defRPr>
             </a:pPr>
             <a:r>
-              <a:t>"Without further ado, let us now transition directly into the live interactive platform to experience the future of D365 and Copilot AI firsthand..."</a:t>
+              <a:t>"Without further ado, let us now transition directly into the live interactive platform to experience the future of Dynamics 365 and Copilot AI firsthand..."</a:t>
             </a:r>
           </a:p>
           <a:p>
             <a:pPr>
               <a:spcAft>
-                <a:spcPts val="400"/>
+                <a:spcPts val="200"/>
               </a:spcAft>
-              <a:defRPr sz="1050" b="1">
+              <a:defRPr sz="1000" b="1">
                 <a:solidFill>
                   <a:srgbClr val="0F172A"/>
                 </a:solidFill>
@@ -6184,7 +6856,7 @@
               <a:spcAft>
                 <a:spcPts val="1400"/>
               </a:spcAft>
-              <a:defRPr sz="1000" b="1">
+              <a:defRPr sz="950" b="1">
                 <a:solidFill>
                   <a:srgbClr val="0284C7"/>
                 </a:solidFill>
@@ -6197,19 +6869,74 @@
           </a:p>
           <a:p>
             <a:pPr>
-              <a:defRPr sz="950">
-                <a:solidFill>
-                  <a:srgbClr val="64748B"/>
+              <a:defRPr sz="900">
+                <a:solidFill>
+                  <a:srgbClr val="94A3B8"/>
                 </a:solidFill>
                 <a:latin typeface="Segoe UI"/>
               </a:defRPr>
             </a:pPr>
             <a:r>
-              <a:t>💡 Host Guidance:</a:t>
+              <a:t>💡 Host Presentation Cue:</a:t>
             </a:r>
             <a:br/>
             <a:r>
-              <a:t>Click the live link or switch to the browser window to start the 12-slide interactive tour.</a:t>
+              <a:t>Click the direct URL above or switch to your browser window to start the 12-slide interactive tour.</a:t>
+            </a:r>
+          </a:p>
+        </p:txBody>
+      </p:sp>
+      <p:sp>
+        <p:nvSpPr>
+          <p:cNvPr id="11" name="Rounded Rectangle 10"/>
+          <p:cNvSpPr/>
+          <p:nvPr/>
+        </p:nvSpPr>
+        <p:spPr>
+          <a:xfrm>
+            <a:off x="731520" y="5806440"/>
+            <a:ext cx="10728655" cy="475488"/>
+          </a:xfrm>
+          <a:prstGeom prst="roundRect">
+            <a:avLst/>
+          </a:prstGeom>
+          <a:solidFill>
+            <a:srgbClr val="F1F5F9"/>
+          </a:solidFill>
+          <a:ln w="12700">
+            <a:solidFill>
+              <a:srgbClr val="E2E8F0"/>
+            </a:solidFill>
+          </a:ln>
+        </p:spPr>
+        <p:style>
+          <a:lnRef idx="1">
+            <a:schemeClr val="accent1"/>
+          </a:lnRef>
+          <a:fillRef idx="3">
+            <a:schemeClr val="accent1"/>
+          </a:fillRef>
+          <a:effectRef idx="2">
+            <a:schemeClr val="accent1"/>
+          </a:effectRef>
+          <a:fontRef idx="minor">
+            <a:schemeClr val="lt1"/>
+          </a:fontRef>
+        </p:style>
+        <p:txBody>
+          <a:bodyPr rtlCol="0" anchor="ctr" wrap="square" tIns="109728"/>
+          <a:lstStyle/>
+          <a:p>
+            <a:pPr algn="ctr">
+              <a:defRPr sz="950" b="1">
+                <a:solidFill>
+                  <a:srgbClr val="0284C7"/>
+                </a:solidFill>
+                <a:latin typeface="Segoe UI"/>
+              </a:defRPr>
+            </a:pPr>
+            <a:r>
+              <a:t>🚀 Seamless Handover: Transitioning to the 12-slide Live Interactive Pitch Deck with Production Dual-Host AI Audio.</a:t>
             </a:r>
           </a:p>
         </p:txBody>

</xml_diff>

<commit_message>
feat: Add 3 Microsoft Fluent 3D visual PPTX design options with presenter scripts and web previewer
</commit_message>
<xml_diff>
--- a/FTH_D365_Executive_Opening_Deck.pptx
+++ b/FTH_D365_Executive_Opening_Deck.pptx
@@ -505,12 +505,12 @@
           <a:lstStyle/>
           <a:p>
             <a:r>
-              <a:t>【Slide 1: Executive Welcome &amp; Visionary Opening】</a:t>
-            </a:r>
-          </a:p>
-          <a:p>
-            <a:r>
-              <a:t>Tone: Formal, Confident, Prestigious | Target Duration: ~40 seconds</a:t>
+              <a:t>【Slide 1: Executive Welcome &amp; Strategic Purpose】</a:t>
+            </a:r>
+          </a:p>
+          <a:p>
+            <a:r>
+              <a:t>Tone: Formal, Confident, Inspiring | Target Duration: ~40 seconds</a:t>
             </a:r>
           </a:p>
           <a:p/>
@@ -522,19 +522,19 @@
           <a:p/>
           <a:p>
             <a:r>
-              <a:t>On behalf of Fujitsu Thailand, it is my distinct privilege to welcome you to today’s executive briefing: 'Empowering Enterprise ERP with Microsoft Copilot AI.'</a:t>
+              <a:t>On behalf of Fujitsu Thailand, it is my distinct privilege to welcome you to today’s executive keynote: 'Empowering Enterprise ERP with Microsoft Copilot AI.'</a:t>
             </a:r>
           </a:p>
           <a:p/>
           <a:p>
             <a:r>
-              <a:t>As organizations navigate rapid digital evolution and intensifying regulatory demands in Thailand, traditional enterprise resource planning systems must evolve beyond passive data recording. Today, we are proud to present Fujitsu’s strategic vision for Dynamics 365 Finance &amp; Operations—natively enhanced by Microsoft Copilot Studio and Azure AI.</a:t>
+              <a:t>As organizations navigate accelerating digital transformation and tightening tax regulations in Thailand, traditional ERP systems must evolve beyond passive data entry. Today, we present Fujitsu’s strategic vision for Dynamics 365 Finance &amp; Operations—natively enhanced by Microsoft Copilot Studio and Azure AI.</a:t>
             </a:r>
           </a:p>
           <a:p/>
           <a:p>
             <a:r>
-              <a:t>Our objective this morning is twofold: first, to demonstrate how autonomous AI streamlines everyday accounting, accounts payable, and Thai tax compliance; and second, to illustrate how this initiative creates proprietary, high-margin Intellectual Property that solidifies Fujitsu Thailand’s position as the premier digital transformation partner in the region.</a:t>
+              <a:t>Our objective today is clear: to demonstrate how autonomous AI streamlines Accounts Payable and Thai tax compliance, while creating proprietary, high-margin Intellectual Property that solidifies Fujitsu Thailand as the premier digital transformation partner in the region.</a:t>
             </a:r>
           </a:p>
           <a:p/>
@@ -615,31 +615,31 @@
           </a:p>
           <a:p>
             <a:r>
-              <a:t>Tone: Problem-Solving, Strategic | Target Duration: ~45 seconds</a:t>
+              <a:t>Tone: Strategic, Analytical, Problem-Solving | Target Duration: ~45 seconds</a:t>
             </a:r>
           </a:p>
           <a:p/>
           <a:p>
             <a:r>
-              <a:t>"Turning to Slide 2, let us examine the operational realities and regulatory drivers shaping modern corporate finance.</a:t>
+              <a:t>"Turning to Slide 2, let us examine the operational realities and regulatory drivers shaping corporate finance today.</a:t>
             </a:r>
           </a:p>
           <a:p/>
           <a:p>
             <a:r>
-              <a:t>Historically, ERP systems were designed as Systems of Record—reliable at logging historical transactions, but fundamentally passive. In practice, our finance and Accounts Payable teams across Thailand continue to bear an immense manual burden. More than 70% of an AP accountant's time is consumed by repetitive administrative tasks: scrutinizing hundreds of PDF tax invoices, cross-referencing purchase orders, and validating 13-digit Tax Identification Numbers and branch codes line by line.</a:t>
+              <a:t>Historically, ERP systems functioned as Systems of Record—reliable at logging historical transactions, but fundamentally passive. In practice, finance and Accounts Payable teams across Thailand continue to bear an immense manual burden: spending over 70% of their time scrutinizing hundreds of PDF tax invoices, matching purchase orders, and validating 13-digit Tax IDs line by line.</a:t>
             </a:r>
           </a:p>
           <a:p/>
           <a:p>
             <a:r>
-              <a:t>Compounding this challenge is Thailand’s rapidly tightening regulatory landscape. The Revenue Department’s ongoing transition toward mandatory e-Tax Invoices and e-Receipts, coupled with intricate Withholding Tax classifications, means that even a minor typographical error can stall monthly PP.30 filings or invite statutory penalties.</a:t>
+              <a:t>Compounding this challenge is Thailand’s rapidly tightening compliance environment. The Revenue Department’s ongoing transition toward mandatory e-Tax Invoices, coupled with intricate Withholding Tax classifications, means that even minor clerical typos risk delayed filings and statutory penalties.</a:t>
             </a:r>
           </a:p>
           <a:p/>
           <a:p>
             <a:r>
-              <a:t>This operational friction represents a transformative opportunity for Fujitsu. By elevating Dynamics 365 into a System of Intelligence, we introduce proactive AI agents that validate data, match transactions, and flag discrepancies before posting—converting the finance department from a transactional cost center into an agile, strategic growth driver."</a:t>
+              <a:t>This friction represents a transformative opportunity. By elevating Dynamics 365 into a System of Intelligence, we deploy proactive AI agents that pre-validate data, match transactions, and flag discrepancies before posting—converting finance from a transactional cost center into a strategic growth driver."</a:t>
             </a:r>
           </a:p>
         </p:txBody>
@@ -714,25 +714,25 @@
           </a:p>
           <a:p>
             <a:r>
-              <a:t>Tone: Visionary, High-Impact | Target Duration: ~50 seconds</a:t>
+              <a:t>Tone: Visionary, High-Impact, Balanced | Target Duration: ~50 seconds</a:t>
             </a:r>
           </a:p>
           <a:p/>
           <a:p>
             <a:r>
-              <a:t>"On Slide 3, we illustrate how this initiative generates substantial, balanced value across both the product platform and Fujitsu Thailand’s commercial portfolio.</a:t>
+              <a:t>"On Slide 3, we illustrate how this initiative generates balanced value across both the Dynamics 365 product platform and Fujitsu Thailand’s commercial business.</a:t>
             </a:r>
           </a:p>
           <a:p/>
           <a:p>
             <a:r>
-              <a:t>From a product enhancement perspective, we are embedding Microsoft Copilot Studio and Azure AI directly into Dynamics 365 via Microsoft Dataverse. This architectural design ensures that enterprise data never leaves your secure tenant. Rather than replacing human judgment, Copilot functions as an autonomous drafting co-pilot: extracting invoice details, validating against 3-way matching rules, and pre-populating draft vendor journals. Crucially, we enforce strict Human-in-the-Loop governance: no transaction is ever committed to the general ledger without explicit review and approval by an authorized accountant.</a:t>
+              <a:t>From a product perspective, we natively embed Microsoft Copilot Studio and Azure AI into Dynamics 365 via Dataverse, guaranteeing zero external data leakage. Copilot functions as an autonomous drafting co-pilot: reading invoices, checking 3-way matching, and pre-populating draft journals—slashing cycle times by over 70%. Crucially, we enforce strict Human-in-the-Loop governance: no transaction is committed to the ledger without explicit approval from an authorized accountant.</a:t>
             </a:r>
           </a:p>
           <a:p/>
           <a:p>
             <a:r>
-              <a:t>From Fujitsu Thailand’s strategic perspective, this initiative establishes a decisive first-mover advantage. By transforming custom localization scripts into a packaged, repeatable AI-powered Thai Localization IP asset, we significantly reduce project implementation time while commanding higher consulting margins. This offering directly addresses the acute compliance needs of Japanese multinationals and major domestic enterprises in Thailand, reinforcing Fujitsu’s legacy of Japanese engineering quality, robust governance, and trusted delivery."</a:t>
+              <a:t>From Fujitsu Thailand’s strategic perspective, this establishes a decisive first-mover advantage. By productizing our localization expertise into reusable, AI-infused Thai Localization IP, we accelerate implementation velocity while capturing higher consulting margins. This offering addresses the acute compliance needs of Japanese multinationals and major domestic enterprises, reinforcing Fujitsu’s legacy of Japanese engineering quality, robust governance, and trusted delivery."</a:t>
             </a:r>
           </a:p>
         </p:txBody>
@@ -807,13 +807,13 @@
           </a:p>
           <a:p>
             <a:r>
-              <a:t>Tone: Engaging, Action-Oriented | Target Duration: ~30 seconds</a:t>
+              <a:t>Tone: Engaging, Action-Oriented, Inviting | Target Duration: ~30 seconds</a:t>
             </a:r>
           </a:p>
           <a:p/>
           <a:p>
             <a:r>
-              <a:t>"Finally, on Slide 4, let us outline the interactive journey we have prepared for you today.</a:t>
+              <a:t>"Finally, on Slide 4, let us outline today’s interactive agenda.</a:t>
             </a:r>
           </a:p>
           <a:p/>
@@ -3959,8 +3959,8 @@
         </p:blipFill>
         <p:spPr>
           <a:xfrm>
-            <a:off x="10378440" y="320040"/>
-            <a:ext cx="1280160" cy="676448"/>
+            <a:off x="10424160" y="320040"/>
+            <a:ext cx="1234440" cy="652289"/>
           </a:xfrm>
           <a:prstGeom prst="rect">
             <a:avLst/>
@@ -3976,7 +3976,7 @@
         <p:spPr>
           <a:xfrm>
             <a:off x="731520" y="320040"/>
-            <a:ext cx="9418320" cy="1097280"/>
+            <a:ext cx="9418320" cy="1005840"/>
           </a:xfrm>
           <a:prstGeom prst="rect">
             <a:avLst/>
@@ -4001,14 +4001,11 @@
               </a:defRPr>
             </a:pPr>
             <a:r>
-              <a:t>FUJITSU THAILAND (FTH) • STRATEGIC EXECUTIVE KEYNOTE</a:t>
+              <a:t>FUJITSU THAILAND (FTH) • EXECUTIVE KEYNOTE</a:t>
             </a:r>
           </a:p>
           <a:p>
             <a:pPr>
-              <a:spcAft>
-                <a:spcPts val="200"/>
-              </a:spcAft>
               <a:defRPr sz="2200" b="1">
                 <a:solidFill>
                   <a:srgbClr val="0F172A"/>
@@ -4020,67 +4017,11 @@
               <a:t>Empowering Enterprise ERP with Microsoft Copilot AI</a:t>
             </a:r>
           </a:p>
-          <a:p>
-            <a:pPr>
-              <a:defRPr sz="1100">
-                <a:solidFill>
-                  <a:srgbClr val="475569"/>
-                </a:solidFill>
-                <a:latin typeface="Segoe UI"/>
-              </a:defRPr>
-            </a:pPr>
-            <a:r>
-              <a:t>Advancing Dynamics 365 Finance &amp; Operations into Autonomous AI &amp; Unlocking Strategic Value for Fujitsu Thailand</a:t>
-            </a:r>
-          </a:p>
-        </p:txBody>
-      </p:sp>
-      <p:sp>
-        <p:nvSpPr>
-          <p:cNvPr id="6" name="Rectangle 5"/>
-          <p:cNvSpPr/>
-          <p:nvPr/>
-        </p:nvSpPr>
-        <p:spPr>
-          <a:xfrm>
-            <a:off x="731520" y="1508760"/>
-            <a:ext cx="10728655" cy="13716"/>
-          </a:xfrm>
-          <a:prstGeom prst="rect">
-            <a:avLst/>
-          </a:prstGeom>
-          <a:solidFill>
-            <a:srgbClr val="E2E8F0"/>
-          </a:solidFill>
-          <a:ln>
-            <a:noFill/>
-          </a:ln>
-        </p:spPr>
-        <p:style>
-          <a:lnRef idx="1">
-            <a:schemeClr val="accent1"/>
-          </a:lnRef>
-          <a:fillRef idx="3">
-            <a:schemeClr val="accent1"/>
-          </a:fillRef>
-          <a:effectRef idx="2">
-            <a:schemeClr val="accent1"/>
-          </a:effectRef>
-          <a:fontRef idx="minor">
-            <a:schemeClr val="lt1"/>
-          </a:fontRef>
-        </p:style>
-        <p:txBody>
-          <a:bodyPr rtlCol="0" anchor="ctr"/>
-          <a:lstStyle/>
-          <a:p>
-            <a:pPr algn="ctr"/>
-          </a:p>
-        </p:txBody>
-      </p:sp>
-      <p:sp>
-        <p:nvSpPr>
-          <p:cNvPr id="7" name="TextBox 6"/>
+        </p:txBody>
+      </p:sp>
+      <p:sp>
+        <p:nvSpPr>
+          <p:cNvPr id="6" name="TextBox 5"/>
           <p:cNvSpPr txBox="1"/>
           <p:nvPr/>
         </p:nvSpPr>
@@ -4095,7 +4036,7 @@
           <a:noFill/>
         </p:spPr>
         <p:txBody>
-          <a:bodyPr wrap="square" lIns="0" tIns="0" rIns="0" bIns="0">
+          <a:bodyPr wrap="none" lIns="0" tIns="0">
             <a:spAutoFit/>
           </a:bodyPr>
           <a:lstStyle/>
@@ -4109,11 +4050,35 @@
               </a:defRPr>
             </a:pPr>
             <a:r>
-              <a:t>FUJITSU THAILAND (FTH) • DYNAMICS 365 &amp; COPILOT AI EXECUTIVE KEYNOTE • SLIDE 1 OF 4</a:t>
-            </a:r>
-          </a:p>
-        </p:txBody>
-      </p:sp>
+              <a:t>OPTION 1: COPILOT FLUENT KEYNOTE • SLIDE 1 OF 4</a:t>
+            </a:r>
+          </a:p>
+        </p:txBody>
+      </p:sp>
+      <p:pic>
+        <p:nvPicPr>
+          <p:cNvPr id="7" name="Picture 6" descr="copilot_d365_hero_fluent.jpg"/>
+          <p:cNvPicPr>
+            <a:picLocks noChangeAspect="1"/>
+          </p:cNvPicPr>
+          <p:nvPr/>
+        </p:nvPicPr>
+        <p:blipFill>
+          <a:blip r:embed="rId3"/>
+          <a:stretch>
+            <a:fillRect/>
+          </a:stretch>
+        </p:blipFill>
+        <p:spPr>
+          <a:xfrm>
+            <a:off x="731520" y="1554480"/>
+            <a:ext cx="5852160" cy="3266322"/>
+          </a:xfrm>
+          <a:prstGeom prst="rect">
+            <a:avLst/>
+          </a:prstGeom>
+        </p:spPr>
+      </p:pic>
       <p:sp>
         <p:nvSpPr>
           <p:cNvPr id="8" name="Rounded Rectangle 7"/>
@@ -4122,8 +4087,8 @@
         </p:nvSpPr>
         <p:spPr>
           <a:xfrm>
-            <a:off x="731520" y="1691640"/>
-            <a:ext cx="3328416" cy="3977639"/>
+            <a:off x="6858000" y="1554480"/>
+            <a:ext cx="4602175" cy="4617720"/>
           </a:xfrm>
           <a:prstGeom prst="roundRect">
             <a:avLst/>
@@ -4131,7 +4096,7 @@
           <a:solidFill>
             <a:srgbClr val="F8FAFC"/>
           </a:solidFill>
-          <a:ln w="15240">
+          <a:ln w="19050">
             <a:solidFill>
               <a:srgbClr val="E2E8F0"/>
             </a:solidFill>
@@ -4152,14 +4117,14 @@
           </a:fontRef>
         </p:style>
         <p:txBody>
-          <a:bodyPr rtlCol="0" anchor="ctr" wrap="square" lIns="274320" rIns="274320" tIns="228600"/>
+          <a:bodyPr rtlCol="0" anchor="ctr" wrap="square" lIns="365760" rIns="365760" tIns="320040"/>
           <a:lstStyle/>
           <a:p>
             <a:pPr algn="ctr">
               <a:spcAft>
-                <a:spcPts val="1200"/>
+                <a:spcPts val="1400"/>
               </a:spcAft>
-              <a:defRPr sz="1350" b="1">
+              <a:defRPr sz="1200" b="1">
                 <a:solidFill>
                   <a:srgbClr val="0284C7"/>
                 </a:solidFill>
@@ -4167,532 +4132,103 @@
               </a:defRPr>
             </a:pPr>
             <a:r>
-              <a:t>⚡ 1. Autonomous ERP</a:t>
+              <a:t>🎯 CORE STRATEGIC PILLARS</a:t>
             </a:r>
           </a:p>
           <a:p>
             <a:pPr>
               <a:spcAft>
-                <a:spcPts val="800"/>
+                <a:spcPts val="200"/>
               </a:spcAft>
-              <a:defRPr sz="1050" b="1">
-                <a:solidFill>
-                  <a:srgbClr val="1E293B"/>
+              <a:defRPr sz="1300" b="1">
+                <a:solidFill>
+                  <a:srgbClr val="0284C7"/>
                 </a:solidFill>
                 <a:latin typeface="Segoe UI"/>
               </a:defRPr>
             </a:pPr>
             <a:r>
-              <a:t>• Workflow Automation: </a:t>
-            </a:r>
-            <a:r>
-              <a:rPr sz="950" b="0">
-                <a:solidFill>
-                  <a:srgbClr val="475569"/>
-                </a:solidFill>
-                <a:latin typeface="Segoe UI"/>
-              </a:rPr>
-              <a:t>Transforms manual accounting workflows into an intelligent system that reads, verifies, and pre-drafts transactions.</a:t>
+              <a:t>⚡ AUTONOMOUS FINANCE</a:t>
             </a:r>
           </a:p>
           <a:p>
             <a:pPr>
               <a:spcAft>
-                <a:spcPts val="800"/>
+                <a:spcPts val="1400"/>
               </a:spcAft>
-              <a:defRPr sz="1050" b="1">
-                <a:solidFill>
-                  <a:srgbClr val="1E293B"/>
+              <a:defRPr sz="1050">
+                <a:solidFill>
+                  <a:srgbClr val="475569"/>
                 </a:solidFill>
                 <a:latin typeface="Segoe UI"/>
               </a:defRPr>
             </a:pPr>
             <a:r>
-              <a:t>• Native D365 Fusion: </a:t>
-            </a:r>
-            <a:r>
-              <a:rPr sz="950" b="0">
-                <a:solidFill>
-                  <a:srgbClr val="475569"/>
-                </a:solidFill>
-                <a:latin typeface="Segoe UI"/>
-              </a:rPr>
-              <a:t>Direct integration with Copilot Studio, Azure AI, and D365 F&amp;O via Dataverse—zero external data leakage.</a:t>
+              <a:t>System of Intelligence • &gt;70% AP Cycle Reduction</a:t>
             </a:r>
           </a:p>
           <a:p>
             <a:pPr>
               <a:spcAft>
-                <a:spcPts val="800"/>
+                <a:spcPts val="200"/>
               </a:spcAft>
-              <a:defRPr sz="1050" b="1">
-                <a:solidFill>
-                  <a:srgbClr val="1E293B"/>
+              <a:defRPr sz="1300" b="1">
+                <a:solidFill>
+                  <a:srgbClr val="7C3AED"/>
                 </a:solidFill>
                 <a:latin typeface="Segoe UI"/>
               </a:defRPr>
             </a:pPr>
             <a:r>
-              <a:t>• Operational Efficiency: </a:t>
-            </a:r>
-            <a:r>
-              <a:rPr sz="950" b="0">
-                <a:solidFill>
-                  <a:srgbClr val="475569"/>
-                </a:solidFill>
-                <a:latin typeface="Segoe UI"/>
-              </a:rPr>
-              <a:t>Slashes repetitive Accounts Payable cycle time by over 70%, freeing teams for strategic financial analysis.</a:t>
-            </a:r>
-          </a:p>
-        </p:txBody>
-      </p:sp>
-      <p:sp>
-        <p:nvSpPr>
-          <p:cNvPr id="9" name="Rounded Rectangle 8"/>
-          <p:cNvSpPr/>
-          <p:nvPr/>
-        </p:nvSpPr>
-        <p:spPr>
-          <a:xfrm>
-            <a:off x="731520" y="1691640"/>
-            <a:ext cx="3328416" cy="73152"/>
-          </a:xfrm>
-          <a:prstGeom prst="roundRect">
-            <a:avLst/>
-          </a:prstGeom>
-          <a:solidFill>
-            <a:srgbClr val="0284C7"/>
-          </a:solidFill>
-          <a:ln>
-            <a:noFill/>
-          </a:ln>
-        </p:spPr>
-        <p:style>
-          <a:lnRef idx="1">
-            <a:schemeClr val="accent1"/>
-          </a:lnRef>
-          <a:fillRef idx="3">
-            <a:schemeClr val="accent1"/>
-          </a:fillRef>
-          <a:effectRef idx="2">
-            <a:schemeClr val="accent1"/>
-          </a:effectRef>
-          <a:fontRef idx="minor">
-            <a:schemeClr val="lt1"/>
-          </a:fontRef>
-        </p:style>
-        <p:txBody>
-          <a:bodyPr rtlCol="0" anchor="ctr"/>
-          <a:lstStyle/>
-          <a:p>
-            <a:pPr algn="ctr"/>
-          </a:p>
-        </p:txBody>
-      </p:sp>
-      <p:sp>
-        <p:nvSpPr>
-          <p:cNvPr id="10" name="Rounded Rectangle 9"/>
-          <p:cNvSpPr/>
-          <p:nvPr/>
-        </p:nvSpPr>
-        <p:spPr>
-          <a:xfrm>
-            <a:off x="4425696" y="1691640"/>
-            <a:ext cx="3328416" cy="3977639"/>
-          </a:xfrm>
-          <a:prstGeom prst="roundRect">
-            <a:avLst/>
-          </a:prstGeom>
-          <a:solidFill>
-            <a:srgbClr val="F8FAFC"/>
-          </a:solidFill>
-          <a:ln w="15240">
-            <a:solidFill>
-              <a:srgbClr val="E2E8F0"/>
-            </a:solidFill>
-          </a:ln>
-        </p:spPr>
-        <p:style>
-          <a:lnRef idx="1">
-            <a:schemeClr val="accent1"/>
-          </a:lnRef>
-          <a:fillRef idx="3">
-            <a:schemeClr val="accent1"/>
-          </a:fillRef>
-          <a:effectRef idx="2">
-            <a:schemeClr val="accent1"/>
-          </a:effectRef>
-          <a:fontRef idx="minor">
-            <a:schemeClr val="lt1"/>
-          </a:fontRef>
-        </p:style>
-        <p:txBody>
-          <a:bodyPr rtlCol="0" anchor="ctr" wrap="square" lIns="274320" rIns="274320" tIns="228600"/>
-          <a:lstStyle/>
-          <a:p>
-            <a:pPr algn="ctr">
-              <a:spcAft>
-                <a:spcPts val="1200"/>
-              </a:spcAft>
-              <a:defRPr sz="1350" b="1">
-                <a:solidFill>
-                  <a:srgbClr val="7C3AED"/>
-                </a:solidFill>
-                <a:latin typeface="Segoe UI"/>
-              </a:defRPr>
-            </a:pPr>
-            <a:r>
-              <a:t>🏛️ 2. Thai Tax Compliance</a:t>
+              <a:t>🏛️ 100% THAI COMPLIANT</a:t>
             </a:r>
           </a:p>
           <a:p>
             <a:pPr>
               <a:spcAft>
-                <a:spcPts val="800"/>
+                <a:spcPts val="1400"/>
               </a:spcAft>
-              <a:defRPr sz="1050" b="1">
-                <a:solidFill>
-                  <a:srgbClr val="1E293B"/>
+              <a:defRPr sz="1050">
+                <a:solidFill>
+                  <a:srgbClr val="475569"/>
                 </a:solidFill>
                 <a:latin typeface="Segoe UI"/>
               </a:defRPr>
             </a:pPr>
             <a:r>
-              <a:t>• Full Regulatory Support: </a:t>
-            </a:r>
-            <a:r>
-              <a:rPr sz="950" b="0">
-                <a:solidFill>
-                  <a:srgbClr val="475569"/>
-                </a:solidFill>
-                <a:latin typeface="Segoe UI"/>
-              </a:rPr>
-              <a:t>Purpose-built for Revenue Department requirements: PP.30 VAT 7%, PND 3/53, and 50 Tawi certificates.</a:t>
+              <a:t>VAT 7% • WHT 1-5% • 50 Tawi • e-Tax Ready</a:t>
             </a:r>
           </a:p>
           <a:p>
             <a:pPr>
               <a:spcAft>
-                <a:spcPts val="800"/>
+                <a:spcPts val="200"/>
               </a:spcAft>
-              <a:defRPr sz="1050" b="1">
-                <a:solidFill>
-                  <a:srgbClr val="1E293B"/>
+              <a:defRPr sz="1300" b="1">
+                <a:solidFill>
+                  <a:srgbClr val="DC2626"/>
                 </a:solidFill>
                 <a:latin typeface="Segoe UI"/>
               </a:defRPr>
             </a:pPr>
             <a:r>
-              <a:t>• e-Tax Pre-Validation: </a:t>
-            </a:r>
-            <a:r>
-              <a:rPr sz="950" b="0">
-                <a:solidFill>
-                  <a:srgbClr val="475569"/>
-                </a:solidFill>
-                <a:latin typeface="Segoe UI"/>
-              </a:rPr>
-              <a:t>Automatic validation gate checking 13-digit Tax IDs and 5-digit branch codes prior to XML generation.</a:t>
+              <a:t>🏆 STRATEGIC FTH IP ASSET</a:t>
             </a:r>
           </a:p>
           <a:p>
             <a:pPr>
               <a:spcAft>
-                <a:spcPts val="800"/>
+                <a:spcPts val="1400"/>
               </a:spcAft>
-              <a:defRPr sz="1050" b="1">
-                <a:solidFill>
-                  <a:srgbClr val="1E293B"/>
+              <a:defRPr sz="1050">
+                <a:solidFill>
+                  <a:srgbClr val="475569"/>
                 </a:solidFill>
                 <a:latin typeface="Segoe UI"/>
               </a:defRPr>
             </a:pPr>
             <a:r>
-              <a:t>• Continuous Subledger Audit: </a:t>
-            </a:r>
-            <a:r>
-              <a:rPr sz="950" b="0">
-                <a:solidFill>
-                  <a:srgbClr val="475569"/>
-                </a:solidFill>
-                <a:latin typeface="Segoe UI"/>
-              </a:rPr>
-              <a:t>Monitors General Ledger against AP, AR, and Tax subledgers throughout the month, eliminating closing panic.</a:t>
-            </a:r>
-          </a:p>
-        </p:txBody>
-      </p:sp>
-      <p:sp>
-        <p:nvSpPr>
-          <p:cNvPr id="11" name="Rounded Rectangle 10"/>
-          <p:cNvSpPr/>
-          <p:nvPr/>
-        </p:nvSpPr>
-        <p:spPr>
-          <a:xfrm>
-            <a:off x="4425696" y="1691640"/>
-            <a:ext cx="3328416" cy="73152"/>
-          </a:xfrm>
-          <a:prstGeom prst="roundRect">
-            <a:avLst/>
-          </a:prstGeom>
-          <a:solidFill>
-            <a:srgbClr val="7C3AED"/>
-          </a:solidFill>
-          <a:ln>
-            <a:noFill/>
-          </a:ln>
-        </p:spPr>
-        <p:style>
-          <a:lnRef idx="1">
-            <a:schemeClr val="accent1"/>
-          </a:lnRef>
-          <a:fillRef idx="3">
-            <a:schemeClr val="accent1"/>
-          </a:fillRef>
-          <a:effectRef idx="2">
-            <a:schemeClr val="accent1"/>
-          </a:effectRef>
-          <a:fontRef idx="minor">
-            <a:schemeClr val="lt1"/>
-          </a:fontRef>
-        </p:style>
-        <p:txBody>
-          <a:bodyPr rtlCol="0" anchor="ctr"/>
-          <a:lstStyle/>
-          <a:p>
-            <a:pPr algn="ctr"/>
-          </a:p>
-        </p:txBody>
-      </p:sp>
-      <p:sp>
-        <p:nvSpPr>
-          <p:cNvPr id="12" name="Rounded Rectangle 11"/>
-          <p:cNvSpPr/>
-          <p:nvPr/>
-        </p:nvSpPr>
-        <p:spPr>
-          <a:xfrm>
-            <a:off x="8119872" y="1691640"/>
-            <a:ext cx="3328416" cy="3977639"/>
-          </a:xfrm>
-          <a:prstGeom prst="roundRect">
-            <a:avLst/>
-          </a:prstGeom>
-          <a:solidFill>
-            <a:srgbClr val="F8FAFC"/>
-          </a:solidFill>
-          <a:ln w="15240">
-            <a:solidFill>
-              <a:srgbClr val="E2E8F0"/>
-            </a:solidFill>
-          </a:ln>
-        </p:spPr>
-        <p:style>
-          <a:lnRef idx="1">
-            <a:schemeClr val="accent1"/>
-          </a:lnRef>
-          <a:fillRef idx="3">
-            <a:schemeClr val="accent1"/>
-          </a:fillRef>
-          <a:effectRef idx="2">
-            <a:schemeClr val="accent1"/>
-          </a:effectRef>
-          <a:fontRef idx="minor">
-            <a:schemeClr val="lt1"/>
-          </a:fontRef>
-        </p:style>
-        <p:txBody>
-          <a:bodyPr rtlCol="0" anchor="ctr" wrap="square" lIns="274320" rIns="274320" tIns="228600"/>
-          <a:lstStyle/>
-          <a:p>
-            <a:pPr algn="ctr">
-              <a:spcAft>
-                <a:spcPts val="1200"/>
-              </a:spcAft>
-              <a:defRPr sz="1350" b="1">
-                <a:solidFill>
-                  <a:srgbClr val="DC2626"/>
-                </a:solidFill>
-                <a:latin typeface="Segoe UI"/>
-              </a:defRPr>
-            </a:pPr>
-            <a:r>
-              <a:t>🏆 3. Strategic Value for FTH</a:t>
-            </a:r>
-          </a:p>
-          <a:p>
-            <a:pPr>
-              <a:spcAft>
-                <a:spcPts val="800"/>
-              </a:spcAft>
-              <a:defRPr sz="1050" b="1">
-                <a:solidFill>
-                  <a:srgbClr val="1E293B"/>
-                </a:solidFill>
-                <a:latin typeface="Segoe UI"/>
-              </a:defRPr>
-            </a:pPr>
-            <a:r>
-              <a:t>• Proprietary IP Leadership: </a:t>
-            </a:r>
-            <a:r>
-              <a:rPr sz="950" b="0">
-                <a:solidFill>
-                  <a:srgbClr val="475569"/>
-                </a:solidFill>
-                <a:latin typeface="Segoe UI"/>
-              </a:rPr>
-              <a:t>Establishes FTH as the premier partner with a proven, repeatable AI-infused Thai Localization package.</a:t>
-            </a:r>
-          </a:p>
-          <a:p>
-            <a:pPr>
-              <a:spcAft>
-                <a:spcPts val="800"/>
-              </a:spcAft>
-              <a:defRPr sz="1050" b="1">
-                <a:solidFill>
-                  <a:srgbClr val="1E293B"/>
-                </a:solidFill>
-                <a:latin typeface="Segoe UI"/>
-              </a:defRPr>
-            </a:pPr>
-            <a:r>
-              <a:t>• High-Margin Reusability: </a:t>
-            </a:r>
-            <a:r>
-              <a:rPr sz="950" b="0">
-                <a:solidFill>
-                  <a:srgbClr val="475569"/>
-                </a:solidFill>
-                <a:latin typeface="Segoe UI"/>
-              </a:rPr>
-              <a:t>Packaged solution scales across Japanese MNCs and major domestic corporate enterprises in Thailand.</a:t>
-            </a:r>
-          </a:p>
-          <a:p>
-            <a:pPr>
-              <a:spcAft>
-                <a:spcPts val="800"/>
-              </a:spcAft>
-              <a:defRPr sz="1050" b="1">
-                <a:solidFill>
-                  <a:srgbClr val="1E293B"/>
-                </a:solidFill>
-                <a:latin typeface="Segoe UI"/>
-              </a:defRPr>
-            </a:pPr>
-            <a:r>
-              <a:t>• Trusted Global Partner: </a:t>
-            </a:r>
-            <a:r>
-              <a:rPr sz="950" b="0">
-                <a:solidFill>
-                  <a:srgbClr val="475569"/>
-                </a:solidFill>
-                <a:latin typeface="Segoe UI"/>
-              </a:rPr>
-              <a:t>Combines Fujitsu’s renowned Japanese quality and governance with Microsoft’s premier enterprise AI platform.</a:t>
-            </a:r>
-          </a:p>
-        </p:txBody>
-      </p:sp>
-      <p:sp>
-        <p:nvSpPr>
-          <p:cNvPr id="13" name="Rounded Rectangle 12"/>
-          <p:cNvSpPr/>
-          <p:nvPr/>
-        </p:nvSpPr>
-        <p:spPr>
-          <a:xfrm>
-            <a:off x="8119872" y="1691640"/>
-            <a:ext cx="3328416" cy="73152"/>
-          </a:xfrm>
-          <a:prstGeom prst="roundRect">
-            <a:avLst/>
-          </a:prstGeom>
-          <a:solidFill>
-            <a:srgbClr val="DC2626"/>
-          </a:solidFill>
-          <a:ln>
-            <a:noFill/>
-          </a:ln>
-        </p:spPr>
-        <p:style>
-          <a:lnRef idx="1">
-            <a:schemeClr val="accent1"/>
-          </a:lnRef>
-          <a:fillRef idx="3">
-            <a:schemeClr val="accent1"/>
-          </a:fillRef>
-          <a:effectRef idx="2">
-            <a:schemeClr val="accent1"/>
-          </a:effectRef>
-          <a:fontRef idx="minor">
-            <a:schemeClr val="lt1"/>
-          </a:fontRef>
-        </p:style>
-        <p:txBody>
-          <a:bodyPr rtlCol="0" anchor="ctr"/>
-          <a:lstStyle/>
-          <a:p>
-            <a:pPr algn="ctr"/>
-          </a:p>
-        </p:txBody>
-      </p:sp>
-      <p:sp>
-        <p:nvSpPr>
-          <p:cNvPr id="14" name="Rounded Rectangle 13"/>
-          <p:cNvSpPr/>
-          <p:nvPr/>
-        </p:nvSpPr>
-        <p:spPr>
-          <a:xfrm>
-            <a:off x="731520" y="5806440"/>
-            <a:ext cx="10728655" cy="475488"/>
-          </a:xfrm>
-          <a:prstGeom prst="roundRect">
-            <a:avLst/>
-          </a:prstGeom>
-          <a:solidFill>
-            <a:srgbClr val="F1F5F9"/>
-          </a:solidFill>
-          <a:ln w="12700">
-            <a:solidFill>
-              <a:srgbClr val="E2E8F0"/>
-            </a:solidFill>
-          </a:ln>
-        </p:spPr>
-        <p:style>
-          <a:lnRef idx="1">
-            <a:schemeClr val="accent1"/>
-          </a:lnRef>
-          <a:fillRef idx="3">
-            <a:schemeClr val="accent1"/>
-          </a:fillRef>
-          <a:effectRef idx="2">
-            <a:schemeClr val="accent1"/>
-          </a:effectRef>
-          <a:fontRef idx="minor">
-            <a:schemeClr val="lt1"/>
-          </a:fontRef>
-        </p:style>
-        <p:txBody>
-          <a:bodyPr rtlCol="0" anchor="ctr" wrap="square" tIns="109728"/>
-          <a:lstStyle/>
-          <a:p>
-            <a:pPr algn="ctr">
-              <a:defRPr sz="1000" b="1">
-                <a:solidFill>
-                  <a:srgbClr val="475569"/>
-                </a:solidFill>
-                <a:latin typeface="Segoe UI"/>
-              </a:defRPr>
-            </a:pPr>
-            <a:r>
-              <a:t>🎤 Presenter: Senior Solution Principal &amp; Executive Host, Fujitsu Thailand (FTH)   |   ⏱️ Opening Duration: ~2 Minutes   |   ● Direct Live Solution Pitch Handover</a:t>
+              <a:t>Proprietary Repeatable Solution • Japanese MNC Trust</a:t>
             </a:r>
           </a:p>
         </p:txBody>
@@ -4817,8 +4353,8 @@
         </p:blipFill>
         <p:spPr>
           <a:xfrm>
-            <a:off x="10378440" y="320040"/>
-            <a:ext cx="1280160" cy="676448"/>
+            <a:off x="10424160" y="320040"/>
+            <a:ext cx="1234440" cy="652289"/>
           </a:xfrm>
           <a:prstGeom prst="rect">
             <a:avLst/>
@@ -4834,7 +4370,7 @@
         <p:spPr>
           <a:xfrm>
             <a:off x="731520" y="320040"/>
-            <a:ext cx="9418320" cy="1097280"/>
+            <a:ext cx="9418320" cy="1005840"/>
           </a:xfrm>
           <a:prstGeom prst="rect">
             <a:avLst/>
@@ -4859,14 +4395,11 @@
               </a:defRPr>
             </a:pPr>
             <a:r>
-              <a:t>MARKET DRIVERS &amp; BUSINESS CHALLENGES</a:t>
+              <a:t>MARKET DRIVERS &amp; LOCAL COMPLEXITY</a:t>
             </a:r>
           </a:p>
           <a:p>
             <a:pPr>
-              <a:spcAft>
-                <a:spcPts val="200"/>
-              </a:spcAft>
               <a:defRPr sz="2200" b="1">
                 <a:solidFill>
                   <a:srgbClr val="0F172A"/>
@@ -4875,70 +4408,14 @@
               </a:defRPr>
             </a:pPr>
             <a:r>
-              <a:t>The Paradigm Shift: From System of Record to System of Intelligence</a:t>
-            </a:r>
-          </a:p>
-          <a:p>
-            <a:pPr>
-              <a:defRPr sz="1100">
-                <a:solidFill>
-                  <a:srgbClr val="475569"/>
-                </a:solidFill>
-                <a:latin typeface="Segoe UI"/>
-              </a:defRPr>
-            </a:pPr>
-            <a:r>
-              <a:t>Navigating Thai financial and tax complexities, and unlocking Fujitsu’s breakthrough opportunity.</a:t>
-            </a:r>
-          </a:p>
-        </p:txBody>
-      </p:sp>
-      <p:sp>
-        <p:nvSpPr>
-          <p:cNvPr id="6" name="Rectangle 5"/>
-          <p:cNvSpPr/>
-          <p:nvPr/>
-        </p:nvSpPr>
-        <p:spPr>
-          <a:xfrm>
-            <a:off x="731520" y="1508760"/>
-            <a:ext cx="10728655" cy="13716"/>
-          </a:xfrm>
-          <a:prstGeom prst="rect">
-            <a:avLst/>
-          </a:prstGeom>
-          <a:solidFill>
-            <a:srgbClr val="E2E8F0"/>
-          </a:solidFill>
-          <a:ln>
-            <a:noFill/>
-          </a:ln>
-        </p:spPr>
-        <p:style>
-          <a:lnRef idx="1">
-            <a:schemeClr val="accent1"/>
-          </a:lnRef>
-          <a:fillRef idx="3">
-            <a:schemeClr val="accent1"/>
-          </a:fillRef>
-          <a:effectRef idx="2">
-            <a:schemeClr val="accent1"/>
-          </a:effectRef>
-          <a:fontRef idx="minor">
-            <a:schemeClr val="lt1"/>
-          </a:fontRef>
-        </p:style>
-        <p:txBody>
-          <a:bodyPr rtlCol="0" anchor="ctr"/>
-          <a:lstStyle/>
-          <a:p>
-            <a:pPr algn="ctr"/>
-          </a:p>
-        </p:txBody>
-      </p:sp>
-      <p:sp>
-        <p:nvSpPr>
-          <p:cNvPr id="7" name="TextBox 6"/>
+              <a:t>The Shift: From System of Record to System of Intelligence</a:t>
+            </a:r>
+          </a:p>
+        </p:txBody>
+      </p:sp>
+      <p:sp>
+        <p:nvSpPr>
+          <p:cNvPr id="6" name="TextBox 5"/>
           <p:cNvSpPr txBox="1"/>
           <p:nvPr/>
         </p:nvSpPr>
@@ -4953,7 +4430,7 @@
           <a:noFill/>
         </p:spPr>
         <p:txBody>
-          <a:bodyPr wrap="square" lIns="0" tIns="0" rIns="0" bIns="0">
+          <a:bodyPr wrap="none" lIns="0" tIns="0">
             <a:spAutoFit/>
           </a:bodyPr>
           <a:lstStyle/>
@@ -4967,11 +4444,35 @@
               </a:defRPr>
             </a:pPr>
             <a:r>
-              <a:t>FUJITSU THAILAND (FTH) • DYNAMICS 365 &amp; COPILOT AI EXECUTIVE KEYNOTE • SLIDE 2 OF 4</a:t>
-            </a:r>
-          </a:p>
-        </p:txBody>
-      </p:sp>
+              <a:t>OPTION 1: COPILOT FLUENT KEYNOTE • SLIDE 2 OF 4</a:t>
+            </a:r>
+          </a:p>
+        </p:txBody>
+      </p:sp>
+      <p:pic>
+        <p:nvPicPr>
+          <p:cNvPr id="7" name="Picture 6" descr="paradigm_shift_3d.jpg"/>
+          <p:cNvPicPr>
+            <a:picLocks noChangeAspect="1"/>
+          </p:cNvPicPr>
+          <p:nvPr/>
+        </p:nvPicPr>
+        <p:blipFill>
+          <a:blip r:embed="rId3"/>
+          <a:stretch>
+            <a:fillRect/>
+          </a:stretch>
+        </p:blipFill>
+        <p:spPr>
+          <a:xfrm>
+            <a:off x="731520" y="1554480"/>
+            <a:ext cx="5852160" cy="3266322"/>
+          </a:xfrm>
+          <a:prstGeom prst="rect">
+            <a:avLst/>
+          </a:prstGeom>
+        </p:spPr>
+      </p:pic>
       <p:sp>
         <p:nvSpPr>
           <p:cNvPr id="8" name="Rounded Rectangle 7"/>
@@ -4980,8 +4481,8 @@
         </p:nvSpPr>
         <p:spPr>
           <a:xfrm>
-            <a:off x="731520" y="1691640"/>
-            <a:ext cx="3328416" cy="3977639"/>
+            <a:off x="6858000" y="1554480"/>
+            <a:ext cx="4602175" cy="4617720"/>
           </a:xfrm>
           <a:prstGeom prst="roundRect">
             <a:avLst/>
@@ -4989,7 +4490,7 @@
           <a:solidFill>
             <a:srgbClr val="F8FAFC"/>
           </a:solidFill>
-          <a:ln w="15240">
+          <a:ln w="19050">
             <a:solidFill>
               <a:srgbClr val="E2E8F0"/>
             </a:solidFill>
@@ -5010,14 +4511,14 @@
           </a:fontRef>
         </p:style>
         <p:txBody>
-          <a:bodyPr rtlCol="0" anchor="ctr" wrap="square" lIns="274320" rIns="274320" tIns="228600"/>
+          <a:bodyPr rtlCol="0" anchor="ctr" wrap="square" lIns="365760" rIns="365760" tIns="320040"/>
           <a:lstStyle/>
           <a:p>
             <a:pPr algn="ctr">
               <a:spcAft>
-                <a:spcPts val="1200"/>
+                <a:spcPts val="1400"/>
               </a:spcAft>
-              <a:defRPr sz="1350" b="1">
+              <a:defRPr sz="1200" b="1">
                 <a:solidFill>
                   <a:srgbClr val="DC2626"/>
                 </a:solidFill>
@@ -5025,532 +4526,103 @@
               </a:defRPr>
             </a:pPr>
             <a:r>
-              <a:t>⚠️ Traditional ERP Limits</a:t>
+              <a:t>📊 OPERATIONAL REALITIES &amp; DRIVERS</a:t>
             </a:r>
           </a:p>
           <a:p>
             <a:pPr>
               <a:spcAft>
-                <a:spcPts val="800"/>
+                <a:spcPts val="200"/>
               </a:spcAft>
-              <a:defRPr sz="1050" b="1">
-                <a:solidFill>
-                  <a:srgbClr val="1E293B"/>
+              <a:defRPr sz="1300" b="1">
+                <a:solidFill>
+                  <a:srgbClr val="DC2626"/>
                 </a:solidFill>
                 <a:latin typeface="Segoe UI"/>
               </a:defRPr>
             </a:pPr>
             <a:r>
-              <a:t>• Manual Overload: </a:t>
-            </a:r>
-            <a:r>
-              <a:rPr sz="950" b="0">
-                <a:solidFill>
-                  <a:srgbClr val="475569"/>
-                </a:solidFill>
-                <a:latin typeface="Segoe UI"/>
-              </a:rPr>
-              <a:t>Accounts Payable teams spend &gt;70% of time manually verifying PDF invoices, receipts, and line items.</a:t>
+              <a:t>⚠️ 70% MANUAL OVERLOAD</a:t>
             </a:r>
           </a:p>
           <a:p>
             <a:pPr>
               <a:spcAft>
-                <a:spcPts val="800"/>
+                <a:spcPts val="1400"/>
               </a:spcAft>
-              <a:defRPr sz="1050" b="1">
-                <a:solidFill>
-                  <a:srgbClr val="1E293B"/>
+              <a:defRPr sz="1050">
+                <a:solidFill>
+                  <a:srgbClr val="475569"/>
                 </a:solidFill>
                 <a:latin typeface="Segoe UI"/>
               </a:defRPr>
             </a:pPr>
             <a:r>
-              <a:t>• Human Error Risks: </a:t>
-            </a:r>
-            <a:r>
-              <a:rPr sz="950" b="0">
-                <a:solidFill>
-                  <a:srgbClr val="475569"/>
-                </a:solidFill>
-                <a:latin typeface="Segoe UI"/>
-              </a:rPr>
-              <a:t>Typos in 13-digit Tax IDs or 5-digit branch codes trigger costly month-end tax filing discrepancies.</a:t>
+              <a:t>Repetitive invoice verification • High month-end burnout</a:t>
             </a:r>
           </a:p>
           <a:p>
             <a:pPr>
               <a:spcAft>
-                <a:spcPts val="800"/>
+                <a:spcPts val="200"/>
               </a:spcAft>
-              <a:defRPr sz="1050" b="1">
-                <a:solidFill>
-                  <a:srgbClr val="1E293B"/>
+              <a:defRPr sz="1300" b="1">
+                <a:solidFill>
+                  <a:srgbClr val="7C3AED"/>
                 </a:solidFill>
                 <a:latin typeface="Segoe UI"/>
               </a:defRPr>
             </a:pPr>
             <a:r>
-              <a:t>• Month-End Bottlenecks: </a:t>
-            </a:r>
-            <a:r>
-              <a:rPr sz="950" b="0">
-                <a:solidFill>
-                  <a:srgbClr val="475569"/>
-                </a:solidFill>
-                <a:latin typeface="Segoe UI"/>
-              </a:rPr>
-              <a:t>Volume spikes create severe month-end stress, delaying PP.30 filings and obscuring cash visibility.</a:t>
-            </a:r>
-          </a:p>
-        </p:txBody>
-      </p:sp>
-      <p:sp>
-        <p:nvSpPr>
-          <p:cNvPr id="9" name="Rounded Rectangle 8"/>
-          <p:cNvSpPr/>
-          <p:nvPr/>
-        </p:nvSpPr>
-        <p:spPr>
-          <a:xfrm>
-            <a:off x="731520" y="1691640"/>
-            <a:ext cx="3328416" cy="73152"/>
-          </a:xfrm>
-          <a:prstGeom prst="roundRect">
-            <a:avLst/>
-          </a:prstGeom>
-          <a:solidFill>
-            <a:srgbClr val="DC2626"/>
-          </a:solidFill>
-          <a:ln>
-            <a:noFill/>
-          </a:ln>
-        </p:spPr>
-        <p:style>
-          <a:lnRef idx="1">
-            <a:schemeClr val="accent1"/>
-          </a:lnRef>
-          <a:fillRef idx="3">
-            <a:schemeClr val="accent1"/>
-          </a:fillRef>
-          <a:effectRef idx="2">
-            <a:schemeClr val="accent1"/>
-          </a:effectRef>
-          <a:fontRef idx="minor">
-            <a:schemeClr val="lt1"/>
-          </a:fontRef>
-        </p:style>
-        <p:txBody>
-          <a:bodyPr rtlCol="0" anchor="ctr"/>
-          <a:lstStyle/>
-          <a:p>
-            <a:pPr algn="ctr"/>
-          </a:p>
-        </p:txBody>
-      </p:sp>
-      <p:sp>
-        <p:nvSpPr>
-          <p:cNvPr id="10" name="Rounded Rectangle 9"/>
-          <p:cNvSpPr/>
-          <p:nvPr/>
-        </p:nvSpPr>
-        <p:spPr>
-          <a:xfrm>
-            <a:off x="4425696" y="1691640"/>
-            <a:ext cx="3328416" cy="3977639"/>
-          </a:xfrm>
-          <a:prstGeom prst="roundRect">
-            <a:avLst/>
-          </a:prstGeom>
-          <a:solidFill>
-            <a:srgbClr val="F8FAFC"/>
-          </a:solidFill>
-          <a:ln w="15240">
-            <a:solidFill>
-              <a:srgbClr val="E2E8F0"/>
-            </a:solidFill>
-          </a:ln>
-        </p:spPr>
-        <p:style>
-          <a:lnRef idx="1">
-            <a:schemeClr val="accent1"/>
-          </a:lnRef>
-          <a:fillRef idx="3">
-            <a:schemeClr val="accent1"/>
-          </a:fillRef>
-          <a:effectRef idx="2">
-            <a:schemeClr val="accent1"/>
-          </a:effectRef>
-          <a:fontRef idx="minor">
-            <a:schemeClr val="lt1"/>
-          </a:fontRef>
-        </p:style>
-        <p:txBody>
-          <a:bodyPr rtlCol="0" anchor="ctr" wrap="square" lIns="274320" rIns="274320" tIns="228600"/>
-          <a:lstStyle/>
-          <a:p>
-            <a:pPr algn="ctr">
-              <a:spcAft>
-                <a:spcPts val="1200"/>
-              </a:spcAft>
-              <a:defRPr sz="1350" b="1">
-                <a:solidFill>
-                  <a:srgbClr val="7C3AED"/>
-                </a:solidFill>
-                <a:latin typeface="Segoe UI"/>
-              </a:defRPr>
-            </a:pPr>
-            <a:r>
-              <a:t>🏛️ Strict Thai Mandates</a:t>
+              <a:t>🏛️ MANDATORY e-TAX COMPLIANCE</a:t>
             </a:r>
           </a:p>
           <a:p>
             <a:pPr>
               <a:spcAft>
-                <a:spcPts val="800"/>
+                <a:spcPts val="1400"/>
               </a:spcAft>
-              <a:defRPr sz="1050" b="1">
-                <a:solidFill>
-                  <a:srgbClr val="1E293B"/>
+              <a:defRPr sz="1050">
+                <a:solidFill>
+                  <a:srgbClr val="475569"/>
                 </a:solidFill>
                 <a:latin typeface="Segoe UI"/>
               </a:defRPr>
             </a:pPr>
             <a:r>
-              <a:t>• e-Tax Enforcement: </a:t>
-            </a:r>
-            <a:r>
-              <a:rPr sz="950" b="0">
-                <a:solidFill>
-                  <a:srgbClr val="475569"/>
-                </a:solidFill>
-                <a:latin typeface="Segoe UI"/>
-              </a:rPr>
-              <a:t>Revenue Department enforces strict XML / e-Filing schemas requiring 100% pre-validation before submission.</a:t>
+              <a:t>Revenue Dept XML schemas • Zero tolerance for typos</a:t>
             </a:r>
           </a:p>
           <a:p>
             <a:pPr>
               <a:spcAft>
-                <a:spcPts val="800"/>
+                <a:spcPts val="200"/>
               </a:spcAft>
-              <a:defRPr sz="1050" b="1">
-                <a:solidFill>
-                  <a:srgbClr val="1E293B"/>
+              <a:defRPr sz="1300" b="1">
+                <a:solidFill>
+                  <a:srgbClr val="0284C7"/>
                 </a:solidFill>
                 <a:latin typeface="Segoe UI"/>
               </a:defRPr>
             </a:pPr>
             <a:r>
-              <a:t>• Complex WHT Rules: </a:t>
-            </a:r>
-            <a:r>
-              <a:rPr sz="950" b="0">
-                <a:solidFill>
-                  <a:srgbClr val="475569"/>
-                </a:solidFill>
-                <a:latin typeface="Segoe UI"/>
-              </a:rPr>
-              <a:t>Variable 1%, 2%, 3%, 5% rates require exact categorization based on the underlying nature of services.</a:t>
+              <a:t>🚀 PROACTIVE INTELLIGENCE</a:t>
             </a:r>
           </a:p>
           <a:p>
             <a:pPr>
               <a:spcAft>
-                <a:spcPts val="800"/>
+                <a:spcPts val="1400"/>
               </a:spcAft>
-              <a:defRPr sz="1050" b="1">
-                <a:solidFill>
-                  <a:srgbClr val="1E293B"/>
+              <a:defRPr sz="1050">
+                <a:solidFill>
+                  <a:srgbClr val="475569"/>
                 </a:solidFill>
                 <a:latin typeface="Segoe UI"/>
               </a:defRPr>
             </a:pPr>
             <a:r>
-              <a:t>• Penalty Exposure: </a:t>
-            </a:r>
-            <a:r>
-              <a:rPr sz="950" b="0">
-                <a:solidFill>
-                  <a:srgbClr val="475569"/>
-                </a:solidFill>
-                <a:latin typeface="Segoe UI"/>
-              </a:rPr>
-              <a:t>Late or erroneous filings lead to surcharges, statutory interest, and unnecessary audit friction.</a:t>
-            </a:r>
-          </a:p>
-        </p:txBody>
-      </p:sp>
-      <p:sp>
-        <p:nvSpPr>
-          <p:cNvPr id="11" name="Rounded Rectangle 10"/>
-          <p:cNvSpPr/>
-          <p:nvPr/>
-        </p:nvSpPr>
-        <p:spPr>
-          <a:xfrm>
-            <a:off x="4425696" y="1691640"/>
-            <a:ext cx="3328416" cy="73152"/>
-          </a:xfrm>
-          <a:prstGeom prst="roundRect">
-            <a:avLst/>
-          </a:prstGeom>
-          <a:solidFill>
-            <a:srgbClr val="7C3AED"/>
-          </a:solidFill>
-          <a:ln>
-            <a:noFill/>
-          </a:ln>
-        </p:spPr>
-        <p:style>
-          <a:lnRef idx="1">
-            <a:schemeClr val="accent1"/>
-          </a:lnRef>
-          <a:fillRef idx="3">
-            <a:schemeClr val="accent1"/>
-          </a:fillRef>
-          <a:effectRef idx="2">
-            <a:schemeClr val="accent1"/>
-          </a:effectRef>
-          <a:fontRef idx="minor">
-            <a:schemeClr val="lt1"/>
-          </a:fontRef>
-        </p:style>
-        <p:txBody>
-          <a:bodyPr rtlCol="0" anchor="ctr"/>
-          <a:lstStyle/>
-          <a:p>
-            <a:pPr algn="ctr"/>
-          </a:p>
-        </p:txBody>
-      </p:sp>
-      <p:sp>
-        <p:nvSpPr>
-          <p:cNvPr id="12" name="Rounded Rectangle 11"/>
-          <p:cNvSpPr/>
-          <p:nvPr/>
-        </p:nvSpPr>
-        <p:spPr>
-          <a:xfrm>
-            <a:off x="8119872" y="1691640"/>
-            <a:ext cx="3328416" cy="3977639"/>
-          </a:xfrm>
-          <a:prstGeom prst="roundRect">
-            <a:avLst/>
-          </a:prstGeom>
-          <a:solidFill>
-            <a:srgbClr val="F8FAFC"/>
-          </a:solidFill>
-          <a:ln w="15240">
-            <a:solidFill>
-              <a:srgbClr val="E2E8F0"/>
-            </a:solidFill>
-          </a:ln>
-        </p:spPr>
-        <p:style>
-          <a:lnRef idx="1">
-            <a:schemeClr val="accent1"/>
-          </a:lnRef>
-          <a:fillRef idx="3">
-            <a:schemeClr val="accent1"/>
-          </a:fillRef>
-          <a:effectRef idx="2">
-            <a:schemeClr val="accent1"/>
-          </a:effectRef>
-          <a:fontRef idx="minor">
-            <a:schemeClr val="lt1"/>
-          </a:fontRef>
-        </p:style>
-        <p:txBody>
-          <a:bodyPr rtlCol="0" anchor="ctr" wrap="square" lIns="274320" rIns="274320" tIns="228600"/>
-          <a:lstStyle/>
-          <a:p>
-            <a:pPr algn="ctr">
-              <a:spcAft>
-                <a:spcPts val="1200"/>
-              </a:spcAft>
-              <a:defRPr sz="1350" b="1">
-                <a:solidFill>
-                  <a:srgbClr val="0284C7"/>
-                </a:solidFill>
-                <a:latin typeface="Segoe UI"/>
-              </a:defRPr>
-            </a:pPr>
-            <a:r>
-              <a:t>🚀 Fujitsu's Opportunity</a:t>
-            </a:r>
-          </a:p>
-          <a:p>
-            <a:pPr>
-              <a:spcAft>
-                <a:spcPts val="800"/>
-              </a:spcAft>
-              <a:defRPr sz="1050" b="1">
-                <a:solidFill>
-                  <a:srgbClr val="1E293B"/>
-                </a:solidFill>
-                <a:latin typeface="Segoe UI"/>
-              </a:defRPr>
-            </a:pPr>
-            <a:r>
-              <a:t>• System of Intelligence: </a:t>
-            </a:r>
-            <a:r>
-              <a:rPr sz="950" b="0">
-                <a:solidFill>
-                  <a:srgbClr val="475569"/>
-                </a:solidFill>
-                <a:latin typeface="Segoe UI"/>
-              </a:rPr>
-              <a:t>Elevates D365 to analyze, pre-validate, and predict discrepancies before journal entries are posted.</a:t>
-            </a:r>
-          </a:p>
-          <a:p>
-            <a:pPr>
-              <a:spcAft>
-                <a:spcPts val="800"/>
-              </a:spcAft>
-              <a:defRPr sz="1050" b="1">
-                <a:solidFill>
-                  <a:srgbClr val="1E293B"/>
-                </a:solidFill>
-                <a:latin typeface="Segoe UI"/>
-              </a:defRPr>
-            </a:pPr>
-            <a:r>
-              <a:t>• Human-in-the-Loop: </a:t>
-            </a:r>
-            <a:r>
-              <a:rPr sz="950" b="0">
-                <a:solidFill>
-                  <a:srgbClr val="475569"/>
-                </a:solidFill>
-                <a:latin typeface="Segoe UI"/>
-              </a:rPr>
-              <a:t>AI prepares validated drafts; finance professionals retain exclusive approval authority.</a:t>
-            </a:r>
-          </a:p>
-          <a:p>
-            <a:pPr>
-              <a:spcAft>
-                <a:spcPts val="800"/>
-              </a:spcAft>
-              <a:defRPr sz="1050" b="1">
-                <a:solidFill>
-                  <a:srgbClr val="1E293B"/>
-                </a:solidFill>
-                <a:latin typeface="Segoe UI"/>
-              </a:defRPr>
-            </a:pPr>
-            <a:r>
-              <a:t>• Market Leadership: </a:t>
-            </a:r>
-            <a:r>
-              <a:rPr sz="950" b="0">
-                <a:solidFill>
-                  <a:srgbClr val="475569"/>
-                </a:solidFill>
-                <a:latin typeface="Segoe UI"/>
-              </a:rPr>
-              <a:t>FTH delivers modern AI innovation that traditional ERP consulting competitors in Thailand cannot match.</a:t>
-            </a:r>
-          </a:p>
-        </p:txBody>
-      </p:sp>
-      <p:sp>
-        <p:nvSpPr>
-          <p:cNvPr id="13" name="Rounded Rectangle 12"/>
-          <p:cNvSpPr/>
-          <p:nvPr/>
-        </p:nvSpPr>
-        <p:spPr>
-          <a:xfrm>
-            <a:off x="8119872" y="1691640"/>
-            <a:ext cx="3328416" cy="73152"/>
-          </a:xfrm>
-          <a:prstGeom prst="roundRect">
-            <a:avLst/>
-          </a:prstGeom>
-          <a:solidFill>
-            <a:srgbClr val="0284C7"/>
-          </a:solidFill>
-          <a:ln>
-            <a:noFill/>
-          </a:ln>
-        </p:spPr>
-        <p:style>
-          <a:lnRef idx="1">
-            <a:schemeClr val="accent1"/>
-          </a:lnRef>
-          <a:fillRef idx="3">
-            <a:schemeClr val="accent1"/>
-          </a:fillRef>
-          <a:effectRef idx="2">
-            <a:schemeClr val="accent1"/>
-          </a:effectRef>
-          <a:fontRef idx="minor">
-            <a:schemeClr val="lt1"/>
-          </a:fontRef>
-        </p:style>
-        <p:txBody>
-          <a:bodyPr rtlCol="0" anchor="ctr"/>
-          <a:lstStyle/>
-          <a:p>
-            <a:pPr algn="ctr"/>
-          </a:p>
-        </p:txBody>
-      </p:sp>
-      <p:sp>
-        <p:nvSpPr>
-          <p:cNvPr id="14" name="Rounded Rectangle 13"/>
-          <p:cNvSpPr/>
-          <p:nvPr/>
-        </p:nvSpPr>
-        <p:spPr>
-          <a:xfrm>
-            <a:off x="731520" y="5806440"/>
-            <a:ext cx="10728655" cy="475488"/>
-          </a:xfrm>
-          <a:prstGeom prst="roundRect">
-            <a:avLst/>
-          </a:prstGeom>
-          <a:solidFill>
-            <a:srgbClr val="F1F5F9"/>
-          </a:solidFill>
-          <a:ln w="12700">
-            <a:solidFill>
-              <a:srgbClr val="E2E8F0"/>
-            </a:solidFill>
-          </a:ln>
-        </p:spPr>
-        <p:style>
-          <a:lnRef idx="1">
-            <a:schemeClr val="accent1"/>
-          </a:lnRef>
-          <a:fillRef idx="3">
-            <a:schemeClr val="accent1"/>
-          </a:fillRef>
-          <a:effectRef idx="2">
-            <a:schemeClr val="accent1"/>
-          </a:effectRef>
-          <a:fontRef idx="minor">
-            <a:schemeClr val="lt1"/>
-          </a:fontRef>
-        </p:style>
-        <p:txBody>
-          <a:bodyPr rtlCol="0" anchor="ctr" wrap="square" tIns="109728"/>
-          <a:lstStyle/>
-          <a:p>
-            <a:pPr algn="ctr">
-              <a:defRPr sz="1000" b="1">
-                <a:solidFill>
-                  <a:srgbClr val="1E3A8A"/>
-                </a:solidFill>
-                <a:latin typeface="Segoe UI"/>
-              </a:defRPr>
-            </a:pPr>
-            <a:r>
-              <a:t>💡 Executive Takeaway: Evolving ERP from passive data recording into proactive, AI-assisted financial governance.</a:t>
+              <a:t>Pre-posting validation • Continuous automated subledger audit</a:t>
             </a:r>
           </a:p>
         </p:txBody>
@@ -5675,8 +4747,8 @@
         </p:blipFill>
         <p:spPr>
           <a:xfrm>
-            <a:off x="10378440" y="320040"/>
-            <a:ext cx="1280160" cy="676448"/>
+            <a:off x="10424160" y="320040"/>
+            <a:ext cx="1234440" cy="652289"/>
           </a:xfrm>
           <a:prstGeom prst="rect">
             <a:avLst/>
@@ -5692,7 +4764,7 @@
         <p:spPr>
           <a:xfrm>
             <a:off x="731520" y="320040"/>
-            <a:ext cx="9418320" cy="1097280"/>
+            <a:ext cx="9418320" cy="1005840"/>
           </a:xfrm>
           <a:prstGeom prst="rect">
             <a:avLst/>
@@ -5722,9 +4794,6 @@
           </a:p>
           <a:p>
             <a:pPr>
-              <a:spcAft>
-                <a:spcPts val="200"/>
-              </a:spcAft>
               <a:defRPr sz="2200" b="1">
                 <a:solidFill>
                   <a:srgbClr val="0F172A"/>
@@ -5733,70 +4802,14 @@
               </a:defRPr>
             </a:pPr>
             <a:r>
-              <a:t>Strengthening Dynamics 365 &amp; Maximizing Fujitsu (FTH) Value</a:t>
-            </a:r>
-          </a:p>
-          <a:p>
-            <a:pPr>
-              <a:defRPr sz="1100">
-                <a:solidFill>
-                  <a:srgbClr val="475569"/>
-                </a:solidFill>
-                <a:latin typeface="Segoe UI"/>
-              </a:defRPr>
-            </a:pPr>
-            <a:r>
-              <a:t>A strategic technology fusion that drives mutual ROI for enterprise clients and Fujitsu Thailand.</a:t>
-            </a:r>
-          </a:p>
-        </p:txBody>
-      </p:sp>
-      <p:sp>
-        <p:nvSpPr>
-          <p:cNvPr id="6" name="Rectangle 5"/>
-          <p:cNvSpPr/>
-          <p:nvPr/>
-        </p:nvSpPr>
-        <p:spPr>
-          <a:xfrm>
-            <a:off x="731520" y="1508760"/>
-            <a:ext cx="10728655" cy="13716"/>
-          </a:xfrm>
-          <a:prstGeom prst="rect">
-            <a:avLst/>
-          </a:prstGeom>
-          <a:solidFill>
-            <a:srgbClr val="E2E8F0"/>
-          </a:solidFill>
-          <a:ln>
-            <a:noFill/>
-          </a:ln>
-        </p:spPr>
-        <p:style>
-          <a:lnRef idx="1">
-            <a:schemeClr val="accent1"/>
-          </a:lnRef>
-          <a:fillRef idx="3">
-            <a:schemeClr val="accent1"/>
-          </a:fillRef>
-          <a:effectRef idx="2">
-            <a:schemeClr val="accent1"/>
-          </a:effectRef>
-          <a:fontRef idx="minor">
-            <a:schemeClr val="lt1"/>
-          </a:fontRef>
-        </p:style>
-        <p:txBody>
-          <a:bodyPr rtlCol="0" anchor="ctr"/>
-          <a:lstStyle/>
-          <a:p>
-            <a:pPr algn="ctr"/>
-          </a:p>
-        </p:txBody>
-      </p:sp>
-      <p:sp>
-        <p:nvSpPr>
-          <p:cNvPr id="7" name="TextBox 6"/>
+              <a:t>Strengthening Dynamics 365 &amp; Maximizing Fujitsu Value</a:t>
+            </a:r>
+          </a:p>
+        </p:txBody>
+      </p:sp>
+      <p:sp>
+        <p:nvSpPr>
+          <p:cNvPr id="6" name="TextBox 5"/>
           <p:cNvSpPr txBox="1"/>
           <p:nvPr/>
         </p:nvSpPr>
@@ -5811,7 +4824,7 @@
           <a:noFill/>
         </p:spPr>
         <p:txBody>
-          <a:bodyPr wrap="square" lIns="0" tIns="0" rIns="0" bIns="0">
+          <a:bodyPr wrap="none" lIns="0" tIns="0">
             <a:spAutoFit/>
           </a:bodyPr>
           <a:lstStyle/>
@@ -5825,11 +4838,35 @@
               </a:defRPr>
             </a:pPr>
             <a:r>
-              <a:t>FUJITSU THAILAND (FTH) • DYNAMICS 365 &amp; COPILOT AI EXECUTIVE KEYNOTE • SLIDE 3 OF 4</a:t>
-            </a:r>
-          </a:p>
-        </p:txBody>
-      </p:sp>
+              <a:t>OPTION 1: COPILOT FLUENT KEYNOTE • SLIDE 3 OF 4</a:t>
+            </a:r>
+          </a:p>
+        </p:txBody>
+      </p:sp>
+      <p:pic>
+        <p:nvPicPr>
+          <p:cNvPr id="7" name="Picture 6" descr="fujitsu_copilot_value_3d.jpg"/>
+          <p:cNvPicPr>
+            <a:picLocks noChangeAspect="1"/>
+          </p:cNvPicPr>
+          <p:nvPr/>
+        </p:nvPicPr>
+        <p:blipFill>
+          <a:blip r:embed="rId3"/>
+          <a:stretch>
+            <a:fillRect/>
+          </a:stretch>
+        </p:blipFill>
+        <p:spPr>
+          <a:xfrm>
+            <a:off x="731520" y="1554480"/>
+            <a:ext cx="5852160" cy="3266322"/>
+          </a:xfrm>
+          <a:prstGeom prst="rect">
+            <a:avLst/>
+          </a:prstGeom>
+        </p:spPr>
+      </p:pic>
       <p:sp>
         <p:nvSpPr>
           <p:cNvPr id="8" name="Rounded Rectangle 7"/>
@@ -5838,8 +4875,8 @@
         </p:nvSpPr>
         <p:spPr>
           <a:xfrm>
-            <a:off x="731520" y="1691640"/>
-            <a:ext cx="5175504" cy="3977639"/>
+            <a:off x="6858000" y="1554480"/>
+            <a:ext cx="4602175" cy="4617720"/>
           </a:xfrm>
           <a:prstGeom prst="roundRect">
             <a:avLst/>
@@ -5847,7 +4884,7 @@
           <a:solidFill>
             <a:srgbClr val="F8FAFC"/>
           </a:solidFill>
-          <a:ln w="15240">
+          <a:ln w="19050">
             <a:solidFill>
               <a:srgbClr val="E2E8F0"/>
             </a:solidFill>
@@ -5868,421 +4905,118 @@
           </a:fontRef>
         </p:style>
         <p:txBody>
-          <a:bodyPr rtlCol="0" anchor="ctr" wrap="square" lIns="320040" rIns="320040" tIns="228600"/>
+          <a:bodyPr rtlCol="0" anchor="ctr" wrap="square" lIns="365760" rIns="365760" tIns="320040"/>
           <a:lstStyle/>
           <a:p>
             <a:pPr algn="ctr">
               <a:spcAft>
-                <a:spcPts val="1200"/>
+                <a:spcPts val="1400"/>
               </a:spcAft>
-              <a:defRPr sz="1400" b="1">
-                <a:solidFill>
-                  <a:srgbClr val="0284C7"/>
+              <a:defRPr sz="1200" b="1">
+                <a:solidFill>
+                  <a:srgbClr val="7C3AED"/>
                 </a:solidFill>
                 <a:latin typeface="Segoe UI"/>
               </a:defRPr>
             </a:pPr>
             <a:r>
-              <a:t>💎 1. Dynamics 365 Product Enhancement</a:t>
+              <a:t>💎 DUAL-ENGINE VALUE PROPOSITION</a:t>
             </a:r>
           </a:p>
           <a:p>
             <a:pPr>
               <a:spcAft>
-                <a:spcPts val="700"/>
+                <a:spcPts val="200"/>
               </a:spcAft>
-              <a:defRPr sz="1050" b="1">
-                <a:solidFill>
-                  <a:srgbClr val="1E293B"/>
+              <a:defRPr sz="1300" b="1">
+                <a:solidFill>
+                  <a:srgbClr val="0284C7"/>
                 </a:solidFill>
                 <a:latin typeface="Segoe UI"/>
               </a:defRPr>
             </a:pPr>
             <a:r>
-              <a:t>• Native Copilot Fusion: </a:t>
-            </a:r>
-            <a:r>
-              <a:rPr sz="950" b="0">
-                <a:solidFill>
-                  <a:srgbClr val="475569"/>
-                </a:solidFill>
-                <a:latin typeface="Segoe UI"/>
-              </a:rPr>
-              <a:t>Direct integration with Copilot Studio and Azure AI via Microsoft Dataverse—zero external data leakage.</a:t>
+              <a:t>🔒 ZERO DATA LEAKAGE</a:t>
             </a:r>
           </a:p>
           <a:p>
             <a:pPr>
               <a:spcAft>
-                <a:spcPts val="700"/>
+                <a:spcPts val="1400"/>
               </a:spcAft>
-              <a:defRPr sz="1050" b="1">
-                <a:solidFill>
-                  <a:srgbClr val="1E293B"/>
+              <a:defRPr sz="1050">
+                <a:solidFill>
+                  <a:srgbClr val="475569"/>
                 </a:solidFill>
                 <a:latin typeface="Segoe UI"/>
               </a:defRPr>
             </a:pPr>
             <a:r>
-              <a:t>• Autonomous Draft Preparation: </a:t>
-            </a:r>
-            <a:r>
-              <a:rPr sz="950" b="0">
-                <a:solidFill>
-                  <a:srgbClr val="475569"/>
-                </a:solidFill>
-                <a:latin typeface="Segoe UI"/>
-              </a:rPr>
-              <a:t>AI extracts data, cross-checks 3-way matching rules, and pre-populates draft vendor invoices—slashing AP review time by &gt;70%.</a:t>
+              <a:t>Copilot Studio + Dataverse • 100% Secure Enterprise Tenant</a:t>
             </a:r>
           </a:p>
           <a:p>
             <a:pPr>
               <a:spcAft>
-                <a:spcPts val="700"/>
+                <a:spcPts val="200"/>
               </a:spcAft>
-              <a:defRPr sz="1050" b="1">
-                <a:solidFill>
-                  <a:srgbClr val="1E293B"/>
+              <a:defRPr sz="1300" b="1">
+                <a:solidFill>
+                  <a:srgbClr val="059669"/>
                 </a:solidFill>
                 <a:latin typeface="Segoe UI"/>
               </a:defRPr>
             </a:pPr>
             <a:r>
-              <a:t>• Strict Human-in-the-Loop: </a:t>
-            </a:r>
-            <a:r>
-              <a:rPr sz="950" b="0">
-                <a:solidFill>
-                  <a:srgbClr val="475569"/>
-                </a:solidFill>
-                <a:latin typeface="Segoe UI"/>
-              </a:rPr>
-              <a:t>AI prepares validated drafts; finance professionals retain exclusive approval authority before any journal posting.</a:t>
+              <a:t>🛡️ HUMAN-IN-THE-LOOP</a:t>
             </a:r>
           </a:p>
           <a:p>
             <a:pPr>
               <a:spcAft>
-                <a:spcPts val="700"/>
+                <a:spcPts val="1400"/>
               </a:spcAft>
-              <a:defRPr sz="1050" b="1">
-                <a:solidFill>
-                  <a:srgbClr val="1E293B"/>
+              <a:defRPr sz="1050">
+                <a:solidFill>
+                  <a:srgbClr val="475569"/>
                 </a:solidFill>
                 <a:latin typeface="Segoe UI"/>
               </a:defRPr>
             </a:pPr>
             <a:r>
-              <a:t>• Total Thai Tax Compliance: </a:t>
-            </a:r>
-            <a:r>
-              <a:rPr sz="950" b="0">
-                <a:solidFill>
-                  <a:srgbClr val="475569"/>
-                </a:solidFill>
-                <a:latin typeface="Segoe UI"/>
-              </a:rPr>
-              <a:t>Comprehensive support for PP.30, PND 3/53, 50 Tawi certificates, and Revenue Dept e-Tax XML formats.</a:t>
-            </a:r>
-          </a:p>
-        </p:txBody>
-      </p:sp>
-      <p:sp>
-        <p:nvSpPr>
-          <p:cNvPr id="9" name="Rounded Rectangle 8"/>
-          <p:cNvSpPr/>
-          <p:nvPr/>
-        </p:nvSpPr>
-        <p:spPr>
-          <a:xfrm>
-            <a:off x="731520" y="1691640"/>
-            <a:ext cx="5175504" cy="73152"/>
-          </a:xfrm>
-          <a:prstGeom prst="roundRect">
-            <a:avLst/>
-          </a:prstGeom>
-          <a:solidFill>
-            <a:srgbClr val="0284C7"/>
-          </a:solidFill>
-          <a:ln>
-            <a:noFill/>
-          </a:ln>
-        </p:spPr>
-        <p:style>
-          <a:lnRef idx="1">
-            <a:schemeClr val="accent1"/>
-          </a:lnRef>
-          <a:fillRef idx="3">
-            <a:schemeClr val="accent1"/>
-          </a:fillRef>
-          <a:effectRef idx="2">
-            <a:schemeClr val="accent1"/>
-          </a:effectRef>
-          <a:fontRef idx="minor">
-            <a:schemeClr val="lt1"/>
-          </a:fontRef>
-        </p:style>
-        <p:txBody>
-          <a:bodyPr rtlCol="0" anchor="ctr"/>
-          <a:lstStyle/>
-          <a:p>
-            <a:pPr algn="ctr"/>
-          </a:p>
-        </p:txBody>
-      </p:sp>
-      <p:sp>
-        <p:nvSpPr>
-          <p:cNvPr id="10" name="Rounded Rectangle 9"/>
-          <p:cNvSpPr/>
-          <p:nvPr/>
-        </p:nvSpPr>
-        <p:spPr>
-          <a:xfrm>
-            <a:off x="6272784" y="1691640"/>
-            <a:ext cx="5175504" cy="3977639"/>
-          </a:xfrm>
-          <a:prstGeom prst="roundRect">
-            <a:avLst/>
-          </a:prstGeom>
-          <a:solidFill>
-            <a:srgbClr val="F8FAFC"/>
-          </a:solidFill>
-          <a:ln w="15240">
-            <a:solidFill>
-              <a:srgbClr val="E2E8F0"/>
-            </a:solidFill>
-          </a:ln>
-        </p:spPr>
-        <p:style>
-          <a:lnRef idx="1">
-            <a:schemeClr val="accent1"/>
-          </a:lnRef>
-          <a:fillRef idx="3">
-            <a:schemeClr val="accent1"/>
-          </a:fillRef>
-          <a:effectRef idx="2">
-            <a:schemeClr val="accent1"/>
-          </a:effectRef>
-          <a:fontRef idx="minor">
-            <a:schemeClr val="lt1"/>
-          </a:fontRef>
-        </p:style>
-        <p:txBody>
-          <a:bodyPr rtlCol="0" anchor="ctr" wrap="square" lIns="320040" rIns="320040" tIns="228600"/>
-          <a:lstStyle/>
-          <a:p>
-            <a:pPr algn="ctr">
-              <a:spcAft>
-                <a:spcPts val="1200"/>
-              </a:spcAft>
-              <a:defRPr sz="1400" b="1">
-                <a:solidFill>
-                  <a:srgbClr val="DC2626"/>
-                </a:solidFill>
-                <a:latin typeface="Segoe UI"/>
-              </a:defRPr>
-            </a:pPr>
-            <a:r>
-              <a:t>🏆 2. Fujitsu (FTH) Enterprise Strategic Value</a:t>
+              <a:t>AI drafts &amp; pre-validates • Accountants retain full sign-off</a:t>
             </a:r>
           </a:p>
           <a:p>
             <a:pPr>
               <a:spcAft>
-                <a:spcPts val="700"/>
+                <a:spcPts val="200"/>
               </a:spcAft>
-              <a:defRPr sz="1050" b="1">
-                <a:solidFill>
-                  <a:srgbClr val="1E293B"/>
+              <a:defRPr sz="1300" b="1">
+                <a:solidFill>
+                  <a:srgbClr val="DC2626"/>
                 </a:solidFill>
                 <a:latin typeface="Segoe UI"/>
               </a:defRPr>
             </a:pPr>
             <a:r>
-              <a:t>• First-Mover Market Advantage: </a:t>
-            </a:r>
-            <a:r>
-              <a:rPr sz="950" b="0">
-                <a:solidFill>
-                  <a:srgbClr val="475569"/>
-                </a:solidFill>
-                <a:latin typeface="Segoe UI"/>
-              </a:rPr>
-              <a:t>FTH becomes the first enterprise partner offering a pre-packaged, AI-infused Thai Localization solution, creating a decisive competitive moat.</a:t>
+              <a:t>🚀 HIGH-MARGIN REUSABLE IP</a:t>
             </a:r>
           </a:p>
           <a:p>
             <a:pPr>
               <a:spcAft>
-                <a:spcPts val="700"/>
+                <a:spcPts val="1400"/>
               </a:spcAft>
-              <a:defRPr sz="1050" b="1">
-                <a:solidFill>
-                  <a:srgbClr val="1E293B"/>
+              <a:defRPr sz="1050">
+                <a:solidFill>
+                  <a:srgbClr val="475569"/>
                 </a:solidFill>
                 <a:latin typeface="Segoe UI"/>
               </a:defRPr>
             </a:pPr>
             <a:r>
-              <a:t>• High-Margin Reusable IP Asset: </a:t>
-            </a:r>
-            <a:r>
-              <a:rPr sz="950" b="0">
-                <a:solidFill>
-                  <a:srgbClr val="475569"/>
-                </a:solidFill>
-                <a:latin typeface="Segoe UI"/>
-              </a:rPr>
-              <a:t>Packaged as commercial IP, enabling rapid, repeatable deployment across enterprise clients with lower implementation overhead.</a:t>
-            </a:r>
-          </a:p>
-          <a:p>
-            <a:pPr>
-              <a:spcAft>
-                <a:spcPts val="700"/>
-              </a:spcAft>
-              <a:defRPr sz="1050" b="1">
-                <a:solidFill>
-                  <a:srgbClr val="1E293B"/>
-                </a:solidFill>
-                <a:latin typeface="Segoe UI"/>
-              </a:defRPr>
-            </a:pPr>
-            <a:r>
-              <a:t>• Expands Japanese MNC &amp; Corporate Footprint: </a:t>
-            </a:r>
-            <a:r>
-              <a:rPr sz="950" b="0">
-                <a:solidFill>
-                  <a:srgbClr val="475569"/>
-                </a:solidFill>
-                <a:latin typeface="Segoe UI"/>
-              </a:rPr>
-              <a:t>Directly tailored to Japanese multinationals and major Thai conglomerates seeking modern, fully compliant ERP solutions.</a:t>
-            </a:r>
-          </a:p>
-          <a:p>
-            <a:pPr>
-              <a:spcAft>
-                <a:spcPts val="700"/>
-              </a:spcAft>
-              <a:defRPr sz="1050" b="1">
-                <a:solidFill>
-                  <a:srgbClr val="1E293B"/>
-                </a:solidFill>
-                <a:latin typeface="Segoe UI"/>
-              </a:defRPr>
-            </a:pPr>
-            <a:r>
-              <a:t>• Reinforces Global Trusted Partner Brand: </a:t>
-            </a:r>
-            <a:r>
-              <a:rPr sz="950" b="0">
-                <a:solidFill>
-                  <a:srgbClr val="475569"/>
-                </a:solidFill>
-                <a:latin typeface="Segoe UI"/>
-              </a:rPr>
-              <a:t>Combines Fujitsu’s renowned Japanese quality and governance standards with Microsoft’s premier enterprise AI platform.</a:t>
-            </a:r>
-          </a:p>
-        </p:txBody>
-      </p:sp>
-      <p:sp>
-        <p:nvSpPr>
-          <p:cNvPr id="11" name="Rounded Rectangle 10"/>
-          <p:cNvSpPr/>
-          <p:nvPr/>
-        </p:nvSpPr>
-        <p:spPr>
-          <a:xfrm>
-            <a:off x="6272784" y="1691640"/>
-            <a:ext cx="5175504" cy="73152"/>
-          </a:xfrm>
-          <a:prstGeom prst="roundRect">
-            <a:avLst/>
-          </a:prstGeom>
-          <a:solidFill>
-            <a:srgbClr val="DC2626"/>
-          </a:solidFill>
-          <a:ln>
-            <a:noFill/>
-          </a:ln>
-        </p:spPr>
-        <p:style>
-          <a:lnRef idx="1">
-            <a:schemeClr val="accent1"/>
-          </a:lnRef>
-          <a:fillRef idx="3">
-            <a:schemeClr val="accent1"/>
-          </a:fillRef>
-          <a:effectRef idx="2">
-            <a:schemeClr val="accent1"/>
-          </a:effectRef>
-          <a:fontRef idx="minor">
-            <a:schemeClr val="lt1"/>
-          </a:fontRef>
-        </p:style>
-        <p:txBody>
-          <a:bodyPr rtlCol="0" anchor="ctr"/>
-          <a:lstStyle/>
-          <a:p>
-            <a:pPr algn="ctr"/>
-          </a:p>
-        </p:txBody>
-      </p:sp>
-      <p:sp>
-        <p:nvSpPr>
-          <p:cNvPr id="12" name="Rounded Rectangle 11"/>
-          <p:cNvSpPr/>
-          <p:nvPr/>
-        </p:nvSpPr>
-        <p:spPr>
-          <a:xfrm>
-            <a:off x="731520" y="5806440"/>
-            <a:ext cx="10728655" cy="475488"/>
-          </a:xfrm>
-          <a:prstGeom prst="roundRect">
-            <a:avLst/>
-          </a:prstGeom>
-          <a:solidFill>
-            <a:srgbClr val="F1F5F9"/>
-          </a:solidFill>
-          <a:ln w="12700">
-            <a:solidFill>
-              <a:srgbClr val="E2E8F0"/>
-            </a:solidFill>
-          </a:ln>
-        </p:spPr>
-        <p:style>
-          <a:lnRef idx="1">
-            <a:schemeClr val="accent1"/>
-          </a:lnRef>
-          <a:fillRef idx="3">
-            <a:schemeClr val="accent1"/>
-          </a:fillRef>
-          <a:effectRef idx="2">
-            <a:schemeClr val="accent1"/>
-          </a:effectRef>
-          <a:fontRef idx="minor">
-            <a:schemeClr val="lt1"/>
-          </a:fontRef>
-        </p:style>
-        <p:txBody>
-          <a:bodyPr rtlCol="0" anchor="ctr" wrap="square" tIns="109728"/>
-          <a:lstStyle/>
-          <a:p>
-            <a:pPr algn="ctr">
-              <a:defRPr sz="950" b="1">
-                <a:solidFill>
-                  <a:srgbClr val="059669"/>
-                </a:solidFill>
-                <a:latin typeface="Segoe UI"/>
-              </a:defRPr>
-            </a:pPr>
-            <a:r>
-              <a:t>🎯 Strategic Impact: Transitioning from bespoke custom implementation to leading the market with proprietary Intellectual Property.  ✓ High Margin  ✓ Scalable  ✓ Repeatable</a:t>
+              <a:t>First-mover localization moat • Repeatable commercial asset</a:t>
             </a:r>
           </a:p>
         </p:txBody>
@@ -6407,8 +5141,8 @@
         </p:blipFill>
         <p:spPr>
           <a:xfrm>
-            <a:off x="10378440" y="320040"/>
-            <a:ext cx="1280160" cy="676448"/>
+            <a:off x="10424160" y="320040"/>
+            <a:ext cx="1234440" cy="652289"/>
           </a:xfrm>
           <a:prstGeom prst="rect">
             <a:avLst/>
@@ -6424,7 +5158,7 @@
         <p:spPr>
           <a:xfrm>
             <a:off x="731520" y="320040"/>
-            <a:ext cx="9418320" cy="1097280"/>
+            <a:ext cx="9418320" cy="1005840"/>
           </a:xfrm>
           <a:prstGeom prst="rect">
             <a:avLst/>
@@ -6454,9 +5188,6 @@
           </a:p>
           <a:p>
             <a:pPr>
-              <a:spcAft>
-                <a:spcPts val="200"/>
-              </a:spcAft>
               <a:defRPr sz="2200" b="1">
                 <a:solidFill>
                   <a:srgbClr val="0F172A"/>
@@ -6468,67 +5199,11 @@
               <a:t>Executive Agenda &amp; Transition to Live Solution Pitch</a:t>
             </a:r>
           </a:p>
-          <a:p>
-            <a:pPr>
-              <a:defRPr sz="1100">
-                <a:solidFill>
-                  <a:srgbClr val="475569"/>
-                </a:solidFill>
-                <a:latin typeface="Segoe UI"/>
-              </a:defRPr>
-            </a:pPr>
-            <a:r>
-              <a:t>Today’s 12-slide walkthrough and formal handover into the live interactive demonstration platform.</a:t>
-            </a:r>
-          </a:p>
-        </p:txBody>
-      </p:sp>
-      <p:sp>
-        <p:nvSpPr>
-          <p:cNvPr id="6" name="Rectangle 5"/>
-          <p:cNvSpPr/>
-          <p:nvPr/>
-        </p:nvSpPr>
-        <p:spPr>
-          <a:xfrm>
-            <a:off x="731520" y="1508760"/>
-            <a:ext cx="10728655" cy="13716"/>
-          </a:xfrm>
-          <a:prstGeom prst="rect">
-            <a:avLst/>
-          </a:prstGeom>
-          <a:solidFill>
-            <a:srgbClr val="E2E8F0"/>
-          </a:solidFill>
-          <a:ln>
-            <a:noFill/>
-          </a:ln>
-        </p:spPr>
-        <p:style>
-          <a:lnRef idx="1">
-            <a:schemeClr val="accent1"/>
-          </a:lnRef>
-          <a:fillRef idx="3">
-            <a:schemeClr val="accent1"/>
-          </a:fillRef>
-          <a:effectRef idx="2">
-            <a:schemeClr val="accent1"/>
-          </a:effectRef>
-          <a:fontRef idx="minor">
-            <a:schemeClr val="lt1"/>
-          </a:fontRef>
-        </p:style>
-        <p:txBody>
-          <a:bodyPr rtlCol="0" anchor="ctr"/>
-          <a:lstStyle/>
-          <a:p>
-            <a:pPr algn="ctr"/>
-          </a:p>
-        </p:txBody>
-      </p:sp>
-      <p:sp>
-        <p:nvSpPr>
-          <p:cNvPr id="7" name="TextBox 6"/>
+        </p:txBody>
+      </p:sp>
+      <p:sp>
+        <p:nvSpPr>
+          <p:cNvPr id="6" name="TextBox 5"/>
           <p:cNvSpPr txBox="1"/>
           <p:nvPr/>
         </p:nvSpPr>
@@ -6543,7 +5218,7 @@
           <a:noFill/>
         </p:spPr>
         <p:txBody>
-          <a:bodyPr wrap="square" lIns="0" tIns="0" rIns="0" bIns="0">
+          <a:bodyPr wrap="none" lIns="0" tIns="0">
             <a:spAutoFit/>
           </a:bodyPr>
           <a:lstStyle/>
@@ -6557,11 +5232,35 @@
               </a:defRPr>
             </a:pPr>
             <a:r>
-              <a:t>FUJITSU THAILAND (FTH) • DYNAMICS 365 &amp; COPILOT AI EXECUTIVE KEYNOTE • SLIDE 4 OF 4</a:t>
-            </a:r>
-          </a:p>
-        </p:txBody>
-      </p:sp>
+              <a:t>OPTION 1: COPILOT FLUENT KEYNOTE • SLIDE 4 OF 4</a:t>
+            </a:r>
+          </a:p>
+        </p:txBody>
+      </p:sp>
+      <p:pic>
+        <p:nvPicPr>
+          <p:cNvPr id="7" name="Picture 6" descr="live_demo_portal_3d.jpg"/>
+          <p:cNvPicPr>
+            <a:picLocks noChangeAspect="1"/>
+          </p:cNvPicPr>
+          <p:nvPr/>
+        </p:nvPicPr>
+        <p:blipFill>
+          <a:blip r:embed="rId3"/>
+          <a:stretch>
+            <a:fillRect/>
+          </a:stretch>
+        </p:blipFill>
+        <p:spPr>
+          <a:xfrm>
+            <a:off x="731520" y="1554480"/>
+            <a:ext cx="5852160" cy="3266322"/>
+          </a:xfrm>
+          <a:prstGeom prst="rect">
+            <a:avLst/>
+          </a:prstGeom>
+        </p:spPr>
+      </p:pic>
       <p:sp>
         <p:nvSpPr>
           <p:cNvPr id="8" name="Rounded Rectangle 7"/>
@@ -6570,209 +5269,8 @@
         </p:nvSpPr>
         <p:spPr>
           <a:xfrm>
-            <a:off x="731520" y="1691640"/>
-            <a:ext cx="6217920" cy="3977639"/>
-          </a:xfrm>
-          <a:prstGeom prst="roundRect">
-            <a:avLst/>
-          </a:prstGeom>
-          <a:solidFill>
-            <a:srgbClr val="F8FAFC"/>
-          </a:solidFill>
-          <a:ln w="15240">
-            <a:solidFill>
-              <a:srgbClr val="E2E8F0"/>
-            </a:solidFill>
-          </a:ln>
-        </p:spPr>
-        <p:style>
-          <a:lnRef idx="1">
-            <a:schemeClr val="accent1"/>
-          </a:lnRef>
-          <a:fillRef idx="3">
-            <a:schemeClr val="accent1"/>
-          </a:fillRef>
-          <a:effectRef idx="2">
-            <a:schemeClr val="accent1"/>
-          </a:effectRef>
-          <a:fontRef idx="minor">
-            <a:schemeClr val="lt1"/>
-          </a:fontRef>
-        </p:style>
-        <p:txBody>
-          <a:bodyPr rtlCol="0" anchor="ctr" wrap="square" lIns="320040" rIns="320040" tIns="228600"/>
-          <a:lstStyle/>
-          <a:p>
-            <a:pPr algn="ctr">
-              <a:spcAft>
-                <a:spcPts val="1200"/>
-              </a:spcAft>
-              <a:defRPr sz="1400" b="1">
-                <a:solidFill>
-                  <a:srgbClr val="1E3A8A"/>
-                </a:solidFill>
-                <a:latin typeface="Segoe UI"/>
-              </a:defRPr>
-            </a:pPr>
-            <a:r>
-              <a:t>📑 Key Milestones in Live Interactive Pitch (12 Slides)</a:t>
-            </a:r>
-          </a:p>
-          <a:p>
-            <a:pPr>
-              <a:spcAft>
-                <a:spcPts val="800"/>
-              </a:spcAft>
-              <a:defRPr sz="1050" b="1">
-                <a:solidFill>
-                  <a:srgbClr val="1E293B"/>
-                </a:solidFill>
-                <a:latin typeface="Segoe UI"/>
-              </a:defRPr>
-            </a:pPr>
-            <a:r>
-              <a:t>• 1. Official Copilot Architecture (Slide 3): </a:t>
-            </a:r>
-            <a:r>
-              <a:rPr sz="950" b="0">
-                <a:solidFill>
-                  <a:srgbClr val="475569"/>
-                </a:solidFill>
-                <a:latin typeface="Segoe UI"/>
-              </a:rPr>
-              <a:t>Multi-Agent Framework and 100% secure enterprise integration with D365 via Dataverse.</a:t>
-            </a:r>
-          </a:p>
-          <a:p>
-            <a:pPr>
-              <a:spcAft>
-                <a:spcPts val="800"/>
-              </a:spcAft>
-              <a:defRPr sz="1050" b="1">
-                <a:solidFill>
-                  <a:srgbClr val="1E293B"/>
-                </a:solidFill>
-                <a:latin typeface="Segoe UI"/>
-              </a:defRPr>
-            </a:pPr>
-            <a:r>
-              <a:t>• 2. Top 5 Thai Localization Use Cases (Slide 4): </a:t>
-            </a:r>
-            <a:r>
-              <a:rPr sz="950" b="0">
-                <a:solidFill>
-                  <a:srgbClr val="475569"/>
-                </a:solidFill>
-                <a:latin typeface="Segoe UI"/>
-              </a:rPr>
-              <a:t>Live walkthrough: AP Invoice Intelligence, Thai Tax Copilot, e-Tax Gateway, Continuous Reconciliation, and Policy Q&amp;A.</a:t>
-            </a:r>
-          </a:p>
-          <a:p>
-            <a:pPr>
-              <a:spcAft>
-                <a:spcPts val="800"/>
-              </a:spcAft>
-              <a:defRPr sz="1050" b="1">
-                <a:solidFill>
-                  <a:srgbClr val="1E293B"/>
-                </a:solidFill>
-                <a:latin typeface="Segoe UI"/>
-              </a:defRPr>
-            </a:pPr>
-            <a:r>
-              <a:t>• 3. 8-Week POC Delivery Plan (Slides 10–11): </a:t>
-            </a:r>
-            <a:r>
-              <a:rPr sz="950" b="0">
-                <a:solidFill>
-                  <a:srgbClr val="475569"/>
-                </a:solidFill>
-                <a:latin typeface="Segoe UI"/>
-              </a:rPr>
-              <a:t>Pragmatic, low-risk deployment roadmap delivering fast measurable value and rapid payback.</a:t>
-            </a:r>
-          </a:p>
-          <a:p>
-            <a:pPr>
-              <a:spcAft>
-                <a:spcPts val="800"/>
-              </a:spcAft>
-              <a:defRPr sz="1050" b="1">
-                <a:solidFill>
-                  <a:srgbClr val="1E293B"/>
-                </a:solidFill>
-                <a:latin typeface="Segoe UI"/>
-              </a:defRPr>
-            </a:pPr>
-            <a:r>
-              <a:t>• 4. Dual-Host AI Narration &amp; Auto-Tour: </a:t>
-            </a:r>
-            <a:r>
-              <a:rPr sz="950" b="0">
-                <a:solidFill>
-                  <a:srgbClr val="475569"/>
-                </a:solidFill>
-                <a:latin typeface="Segoe UI"/>
-              </a:rPr>
-              <a:t>Production neural studio voice in English &amp; Thai with automated slide tour capabilities.</a:t>
-            </a:r>
-          </a:p>
-        </p:txBody>
-      </p:sp>
-      <p:sp>
-        <p:nvSpPr>
-          <p:cNvPr id="9" name="Rounded Rectangle 8"/>
-          <p:cNvSpPr/>
-          <p:nvPr/>
-        </p:nvSpPr>
-        <p:spPr>
-          <a:xfrm>
-            <a:off x="731520" y="1691640"/>
-            <a:ext cx="6217920" cy="73152"/>
-          </a:xfrm>
-          <a:prstGeom prst="roundRect">
-            <a:avLst/>
-          </a:prstGeom>
-          <a:solidFill>
-            <a:srgbClr val="0284C7"/>
-          </a:solidFill>
-          <a:ln>
-            <a:noFill/>
-          </a:ln>
-        </p:spPr>
-        <p:style>
-          <a:lnRef idx="1">
-            <a:schemeClr val="accent1"/>
-          </a:lnRef>
-          <a:fillRef idx="3">
-            <a:schemeClr val="accent1"/>
-          </a:fillRef>
-          <a:effectRef idx="2">
-            <a:schemeClr val="accent1"/>
-          </a:effectRef>
-          <a:fontRef idx="minor">
-            <a:schemeClr val="lt1"/>
-          </a:fontRef>
-        </p:style>
-        <p:txBody>
-          <a:bodyPr rtlCol="0" anchor="ctr"/>
-          <a:lstStyle/>
-          <a:p>
-            <a:pPr algn="ctr"/>
-          </a:p>
-        </p:txBody>
-      </p:sp>
-      <p:sp>
-        <p:nvSpPr>
-          <p:cNvPr id="10" name="Rounded Rectangle 9"/>
-          <p:cNvSpPr/>
-          <p:nvPr/>
-        </p:nvSpPr>
-        <p:spPr>
-          <a:xfrm>
-            <a:off x="7315200" y="1691640"/>
-            <a:ext cx="4144975" cy="3977639"/>
+            <a:off x="6858000" y="1554480"/>
+            <a:ext cx="4602175" cy="4617720"/>
           </a:xfrm>
           <a:prstGeom prst="roundRect">
             <a:avLst/>
@@ -6801,14 +5299,14 @@
           </a:fontRef>
         </p:style>
         <p:txBody>
-          <a:bodyPr rtlCol="0" anchor="ctr" wrap="square" lIns="320040" rIns="320040" tIns="274320"/>
+          <a:bodyPr rtlCol="0" anchor="ctr" wrap="square" lIns="365760" rIns="365760" tIns="320040"/>
           <a:lstStyle/>
           <a:p>
             <a:pPr algn="ctr">
               <a:spcAft>
-                <a:spcPts val="1000"/>
+                <a:spcPts val="1200"/>
               </a:spcAft>
-              <a:defRPr sz="1400" b="1">
+              <a:defRPr sz="1200" b="1">
                 <a:solidFill>
                   <a:srgbClr val="059669"/>
                 </a:solidFill>
@@ -6816,31 +5314,70 @@
               </a:defRPr>
             </a:pPr>
             <a:r>
-              <a:t>🚀 Ready for Live Demonstration</a:t>
+              <a:t>🚀 READY FOR LIVE DEMONSTRATION</a:t>
+            </a:r>
+          </a:p>
+          <a:p>
+            <a:pPr>
+              <a:defRPr sz="1150" b="1">
+                <a:solidFill>
+                  <a:srgbClr val="0F172A"/>
+                </a:solidFill>
+                <a:latin typeface="Segoe UI"/>
+              </a:defRPr>
+            </a:pPr>
+            <a:r>
+              <a:t>• 1. Official Architecture</a:t>
             </a:r>
           </a:p>
           <a:p>
             <a:pPr>
               <a:spcAft>
-                <a:spcPts val="1400"/>
+                <a:spcPts val="800"/>
               </a:spcAft>
-              <a:defRPr sz="1050" i="1">
-                <a:solidFill>
-                  <a:srgbClr val="1E293B"/>
+              <a:defRPr sz="950">
+                <a:solidFill>
+                  <a:srgbClr val="475569"/>
                 </a:solidFill>
                 <a:latin typeface="Segoe UI"/>
               </a:defRPr>
             </a:pPr>
             <a:r>
-              <a:t>"Without further ado, let us now transition directly into the live interactive platform to experience the future of Dynamics 365 and Copilot AI firsthand..."</a:t>
+              <a:t>   Copilot Studio + Dataverse Multi-Agent framework</a:t>
+            </a:r>
+          </a:p>
+          <a:p>
+            <a:pPr>
+              <a:defRPr sz="1150" b="1">
+                <a:solidFill>
+                  <a:srgbClr val="0F172A"/>
+                </a:solidFill>
+                <a:latin typeface="Segoe UI"/>
+              </a:defRPr>
+            </a:pPr>
+            <a:r>
+              <a:t>• 2. Top 5 Thai Use Cases</a:t>
             </a:r>
           </a:p>
           <a:p>
             <a:pPr>
               <a:spcAft>
-                <a:spcPts val="200"/>
+                <a:spcPts val="800"/>
               </a:spcAft>
-              <a:defRPr sz="1000" b="1">
+              <a:defRPr sz="950">
+                <a:solidFill>
+                  <a:srgbClr val="475569"/>
+                </a:solidFill>
+                <a:latin typeface="Segoe UI"/>
+              </a:defRPr>
+            </a:pPr>
+            <a:r>
+              <a:t>   AP Invoice, Tax Copilot, e-Tax Gateway &amp; Recon</a:t>
+            </a:r>
+          </a:p>
+          <a:p>
+            <a:pPr>
+              <a:defRPr sz="1150" b="1">
                 <a:solidFill>
                   <a:srgbClr val="0F172A"/>
                 </a:solidFill>
@@ -6848,14 +5385,56 @@
               </a:defRPr>
             </a:pPr>
             <a:r>
-              <a:t>🌐 Direct Platform Link (GitHub Pages):</a:t>
+              <a:t>• 3. 8-Week POC Delivery</a:t>
             </a:r>
           </a:p>
           <a:p>
             <a:pPr>
               <a:spcAft>
-                <a:spcPts val="1400"/>
+                <a:spcPts val="800"/>
               </a:spcAft>
+              <a:defRPr sz="950">
+                <a:solidFill>
+                  <a:srgbClr val="475569"/>
+                </a:solidFill>
+                <a:latin typeface="Segoe UI"/>
+              </a:defRPr>
+            </a:pPr>
+            <a:r>
+              <a:t>   Fast ROI • Low-risk implementation roadmap</a:t>
+            </a:r>
+          </a:p>
+          <a:p>
+            <a:pPr>
+              <a:defRPr sz="1150" b="1">
+                <a:solidFill>
+                  <a:srgbClr val="0F172A"/>
+                </a:solidFill>
+                <a:latin typeface="Segoe UI"/>
+              </a:defRPr>
+            </a:pPr>
+            <a:r>
+              <a:t>• 4. Interactive Experience</a:t>
+            </a:r>
+          </a:p>
+          <a:p>
+            <a:pPr>
+              <a:spcAft>
+                <a:spcPts val="800"/>
+              </a:spcAft>
+              <a:defRPr sz="950">
+                <a:solidFill>
+                  <a:srgbClr val="475569"/>
+                </a:solidFill>
+                <a:latin typeface="Segoe UI"/>
+              </a:defRPr>
+            </a:pPr>
+            <a:r>
+              <a:t>   Scenario simulations &amp; dual-host executive speech</a:t>
+            </a:r>
+          </a:p>
+          <a:p>
+            <a:pPr>
               <a:defRPr sz="950" b="1">
                 <a:solidFill>
                   <a:srgbClr val="0284C7"/>
@@ -6864,79 +5443,7 @@
               </a:defRPr>
             </a:pPr>
             <a:r>
-              <a:t>https://wititgithub.github.io/fth-d365-fo-copilot-deck/</a:t>
-            </a:r>
-          </a:p>
-          <a:p>
-            <a:pPr>
-              <a:defRPr sz="900">
-                <a:solidFill>
-                  <a:srgbClr val="94A3B8"/>
-                </a:solidFill>
-                <a:latin typeface="Segoe UI"/>
-              </a:defRPr>
-            </a:pPr>
-            <a:r>
-              <a:t>💡 Host Presentation Cue:</a:t>
-            </a:r>
-            <a:br/>
-            <a:r>
-              <a:t>Click the direct URL above or switch to your browser window to start the 12-slide interactive tour.</a:t>
-            </a:r>
-          </a:p>
-        </p:txBody>
-      </p:sp>
-      <p:sp>
-        <p:nvSpPr>
-          <p:cNvPr id="11" name="Rounded Rectangle 10"/>
-          <p:cNvSpPr/>
-          <p:nvPr/>
-        </p:nvSpPr>
-        <p:spPr>
-          <a:xfrm>
-            <a:off x="731520" y="5806440"/>
-            <a:ext cx="10728655" cy="475488"/>
-          </a:xfrm>
-          <a:prstGeom prst="roundRect">
-            <a:avLst/>
-          </a:prstGeom>
-          <a:solidFill>
-            <a:srgbClr val="F1F5F9"/>
-          </a:solidFill>
-          <a:ln w="12700">
-            <a:solidFill>
-              <a:srgbClr val="E2E8F0"/>
-            </a:solidFill>
-          </a:ln>
-        </p:spPr>
-        <p:style>
-          <a:lnRef idx="1">
-            <a:schemeClr val="accent1"/>
-          </a:lnRef>
-          <a:fillRef idx="3">
-            <a:schemeClr val="accent1"/>
-          </a:fillRef>
-          <a:effectRef idx="2">
-            <a:schemeClr val="accent1"/>
-          </a:effectRef>
-          <a:fontRef idx="minor">
-            <a:schemeClr val="lt1"/>
-          </a:fontRef>
-        </p:style>
-        <p:txBody>
-          <a:bodyPr rtlCol="0" anchor="ctr" wrap="square" tIns="109728"/>
-          <a:lstStyle/>
-          <a:p>
-            <a:pPr algn="ctr">
-              <a:defRPr sz="950" b="1">
-                <a:solidFill>
-                  <a:srgbClr val="0284C7"/>
-                </a:solidFill>
-                <a:latin typeface="Segoe UI"/>
-              </a:defRPr>
-            </a:pPr>
-            <a:r>
-              <a:t>🚀 Seamless Handover: Transitioning to the 12-slide Live Interactive Pitch Deck with Production Dual-Host AI Audio.</a:t>
+              <a:t>🌐 Direct Platform Link: https://wititgithub.github.io/fth-d365-fo-copilot-deck/</a:t>
             </a:r>
           </a:p>
         </p:txBody>

</xml_diff>